<commit_message>
Poster: enlarge side-column type (38pt body / 41pt headers) to fill columns
Larger body and header type fills the open-text side columns and improves 2-3 m
readability; both emphasis boxes retain their text-enclosing safety margin.

Co-Authored-By: Claude Opus 4.8 <noreply@anthropic.com>
Claude-Session: https://claude.ai/code/session_01Hys1rt1JVnsf8msS2XZJ53
</commit_message>
<xml_diff>
--- a/TNASICON2026-Poster-Metastatic-Ileal-Perforation.pptx
+++ b/TNASICON2026-Poster-Metastatic-Ileal-Perforation.pptx
@@ -1193,7 +1193,7 @@
         </p:nvSpPr>
         <p:spPr>
           <a:xfrm>
-            <a:off x="720000" y="11985084"/>
+            <a:off x="720000" y="10011504"/>
             <a:ext cx="310896" cy="310896"/>
           </a:xfrm>
           <a:prstGeom prst="ellipse">
@@ -1213,7 +1213,7 @@
         </p:nvSpPr>
         <p:spPr>
           <a:xfrm>
-            <a:off x="1213776" y="11875356"/>
+            <a:off x="1213776" y="9901776"/>
             <a:ext cx="7918992" cy="603504"/>
           </a:xfrm>
           <a:prstGeom prst="rect">
@@ -1230,7 +1230,7 @@
               <a:buNone/>
             </a:pPr>
             <a:r>
-              <a:rPr lang="en-US" sz="3600" b="1" dirty="0">
+              <a:rPr lang="en-US" sz="4100" b="1" dirty="0">
                 <a:solidFill>
                   <a:srgbClr val="12355B"/>
                 </a:solidFill>
@@ -1240,7 +1240,7 @@
               </a:rPr>
               <a:t>Background</a:t>
             </a:r>
-            <a:endParaRPr lang="en-US" sz="3600" dirty="0"/>
+            <a:endParaRPr lang="en-US" sz="4100" dirty="0"/>
           </a:p>
         </p:txBody>
       </p:sp>
@@ -1252,8 +1252,8 @@
         </p:nvSpPr>
         <p:spPr>
           <a:xfrm>
-            <a:off x="756576" y="12625164"/>
-            <a:ext cx="8339616" cy="5129784"/>
+            <a:off x="756576" y="10651584"/>
+            <a:ext cx="8339616" cy="5815584"/>
           </a:xfrm>
           <a:prstGeom prst="rect">
             <a:avLst/>
@@ -1273,7 +1273,7 @@
               <a:buChar char="•"/>
             </a:pPr>
             <a:r>
-              <a:rPr lang="en-US" sz="3300" dirty="0">
+              <a:rPr lang="en-US" sz="3800" dirty="0">
                 <a:solidFill>
                   <a:srgbClr val="333333"/>
                 </a:solidFill>
@@ -1283,7 +1283,7 @@
               </a:rPr>
               <a:t>Intestinal metastasis from breast carcinoma is uncommon.</a:t>
             </a:r>
-            <a:endParaRPr lang="en-US" sz="3300" dirty="0"/>
+            <a:endParaRPr lang="en-US" sz="3800" dirty="0"/>
           </a:p>
           <a:p>
             <a:pPr algn="l" marL="228600" indent="-228600">
@@ -1294,7 +1294,7 @@
               <a:buChar char="•"/>
             </a:pPr>
             <a:r>
-              <a:rPr lang="en-US" sz="3300" dirty="0">
+              <a:rPr lang="en-US" sz="3800" dirty="0">
                 <a:solidFill>
                   <a:srgbClr val="333333"/>
                 </a:solidFill>
@@ -1304,7 +1304,7 @@
               </a:rPr>
               <a:t>Perforation as the initial manifestation is exceedingly rare.</a:t>
             </a:r>
-            <a:endParaRPr lang="en-US" sz="3300" dirty="0"/>
+            <a:endParaRPr lang="en-US" sz="3800" dirty="0"/>
           </a:p>
           <a:p>
             <a:pPr algn="l" marL="228600" indent="-228600">
@@ -1315,7 +1315,7 @@
               <a:buChar char="•"/>
             </a:pPr>
             <a:r>
-              <a:rPr lang="en-US" sz="3300" dirty="0">
+              <a:rPr lang="en-US" sz="3800" dirty="0">
                 <a:solidFill>
                   <a:srgbClr val="333333"/>
                 </a:solidFill>
@@ -1325,7 +1325,7 @@
               </a:rPr>
               <a:t>Only a limited number of similar cases have been reported.</a:t>
             </a:r>
-            <a:endParaRPr lang="en-US" sz="3300" dirty="0"/>
+            <a:endParaRPr lang="en-US" sz="3800" dirty="0"/>
           </a:p>
           <a:p>
             <a:pPr algn="l" marL="228600" indent="-228600">
@@ -1336,7 +1336,7 @@
               <a:buChar char="•"/>
             </a:pPr>
             <a:r>
-              <a:rPr lang="en-US" sz="3300" dirty="0">
+              <a:rPr lang="en-US" sz="3800" dirty="0">
                 <a:solidFill>
                   <a:srgbClr val="333333"/>
                 </a:solidFill>
@@ -1346,7 +1346,7 @@
               </a:rPr>
               <a:t>An acute surgical abdomen may represent the first presentation of metastatic malignancy.</a:t>
             </a:r>
-            <a:endParaRPr lang="en-US" sz="3300" dirty="0"/>
+            <a:endParaRPr lang="en-US" sz="3800" dirty="0"/>
           </a:p>
         </p:txBody>
       </p:sp>
@@ -1358,7 +1358,7 @@
         </p:nvSpPr>
         <p:spPr>
           <a:xfrm>
-            <a:off x="720000" y="19309428"/>
+            <a:off x="720000" y="18021648"/>
             <a:ext cx="310896" cy="310896"/>
           </a:xfrm>
           <a:prstGeom prst="ellipse">
@@ -1378,7 +1378,7 @@
         </p:nvSpPr>
         <p:spPr>
           <a:xfrm>
-            <a:off x="1213776" y="19199700"/>
+            <a:off x="1213776" y="17911920"/>
             <a:ext cx="7918992" cy="603504"/>
           </a:xfrm>
           <a:prstGeom prst="rect">
@@ -1395,7 +1395,7 @@
               <a:buNone/>
             </a:pPr>
             <a:r>
-              <a:rPr lang="en-US" sz="3600" b="1" dirty="0">
+              <a:rPr lang="en-US" sz="4100" b="1" dirty="0">
                 <a:solidFill>
                   <a:srgbClr val="12355B"/>
                 </a:solidFill>
@@ -1405,7 +1405,7 @@
               </a:rPr>
               <a:t>Case Presentation</a:t>
             </a:r>
-            <a:endParaRPr lang="en-US" sz="3600" dirty="0"/>
+            <a:endParaRPr lang="en-US" sz="4100" dirty="0"/>
           </a:p>
         </p:txBody>
       </p:sp>
@@ -1417,8 +1417,8 @@
         </p:nvSpPr>
         <p:spPr>
           <a:xfrm>
-            <a:off x="756576" y="19949508"/>
-            <a:ext cx="8339616" cy="4526280"/>
+            <a:off x="756576" y="18661728"/>
+            <a:ext cx="8339616" cy="5715000"/>
           </a:xfrm>
           <a:prstGeom prst="rect">
             <a:avLst/>
@@ -1438,7 +1438,7 @@
               <a:buChar char="•"/>
             </a:pPr>
             <a:r>
-              <a:rPr lang="en-US" sz="3300" b="1" dirty="0">
+              <a:rPr lang="en-US" sz="3800" b="1" dirty="0">
                 <a:solidFill>
                   <a:srgbClr val="12355B"/>
                 </a:solidFill>
@@ -1448,7 +1448,7 @@
               </a:rPr>
               <a:t>38-year-old woman with abdominal pain for two days.</a:t>
             </a:r>
-            <a:endParaRPr lang="en-US" sz="3300" dirty="0"/>
+            <a:endParaRPr lang="en-US" sz="3800" dirty="0"/>
           </a:p>
           <a:p>
             <a:pPr algn="l" marL="228600" indent="-228600">
@@ -1459,7 +1459,7 @@
               <a:buChar char="•"/>
             </a:pPr>
             <a:r>
-              <a:rPr lang="en-US" sz="3300" dirty="0">
+              <a:rPr lang="en-US" sz="3800" dirty="0">
                 <a:solidFill>
                   <a:srgbClr val="333333"/>
                 </a:solidFill>
@@ -1469,7 +1469,7 @@
               </a:rPr>
               <a:t>History of chronic NSAID abuse for pain related to a right breast lump, which had been misdiagnosed as a breast abscess.</a:t>
             </a:r>
-            <a:endParaRPr lang="en-US" sz="3300" dirty="0"/>
+            <a:endParaRPr lang="en-US" sz="3800" dirty="0"/>
           </a:p>
           <a:p>
             <a:pPr algn="l" marL="228600" indent="-228600">
@@ -1480,7 +1480,7 @@
               <a:buChar char="•"/>
             </a:pPr>
             <a:r>
-              <a:rPr lang="en-US" sz="3300" dirty="0">
+              <a:rPr lang="en-US" sz="3800" dirty="0">
                 <a:solidFill>
                   <a:srgbClr val="333333"/>
                 </a:solidFill>
@@ -1490,7 +1490,7 @@
               </a:rPr>
               <a:t>On examination: tachycardic, with generalized abdominal rigidity.</a:t>
             </a:r>
-            <a:endParaRPr lang="en-US" sz="3300" dirty="0"/>
+            <a:endParaRPr lang="en-US" sz="3800" dirty="0"/>
           </a:p>
         </p:txBody>
       </p:sp>
@@ -1502,7 +1502,7 @@
         </p:nvSpPr>
         <p:spPr>
           <a:xfrm>
-            <a:off x="720000" y="26030268"/>
+            <a:off x="720000" y="25931208"/>
             <a:ext cx="310896" cy="310896"/>
           </a:xfrm>
           <a:prstGeom prst="ellipse">
@@ -1522,7 +1522,7 @@
         </p:nvSpPr>
         <p:spPr>
           <a:xfrm>
-            <a:off x="1213776" y="25920540"/>
+            <a:off x="1213776" y="25821480"/>
             <a:ext cx="7918992" cy="603504"/>
           </a:xfrm>
           <a:prstGeom prst="rect">
@@ -1539,7 +1539,7 @@
               <a:buNone/>
             </a:pPr>
             <a:r>
-              <a:rPr lang="en-US" sz="3600" b="1" dirty="0">
+              <a:rPr lang="en-US" sz="4100" b="1" dirty="0">
                 <a:solidFill>
                   <a:srgbClr val="12355B"/>
                 </a:solidFill>
@@ -1549,7 +1549,7 @@
               </a:rPr>
               <a:t>Investigations</a:t>
             </a:r>
-            <a:endParaRPr lang="en-US" sz="3600" dirty="0"/>
+            <a:endParaRPr lang="en-US" sz="4100" dirty="0"/>
           </a:p>
         </p:txBody>
       </p:sp>
@@ -1561,8 +1561,8 @@
         </p:nvSpPr>
         <p:spPr>
           <a:xfrm>
-            <a:off x="756576" y="26670348"/>
-            <a:ext cx="8339616" cy="2414016"/>
+            <a:off x="756576" y="26571288"/>
+            <a:ext cx="8339616" cy="3297936"/>
           </a:xfrm>
           <a:prstGeom prst="rect">
             <a:avLst/>
@@ -1582,7 +1582,7 @@
               <a:buChar char="•"/>
             </a:pPr>
             <a:r>
-              <a:rPr lang="en-US" sz="3300" b="1" dirty="0">
+              <a:rPr lang="en-US" sz="3800" b="1" dirty="0">
                 <a:solidFill>
                   <a:srgbClr val="12355B"/>
                 </a:solidFill>
@@ -1592,7 +1592,7 @@
               </a:rPr>
               <a:t>Erect abdominal radiograph demonstrated pneumoperitoneum.</a:t>
             </a:r>
-            <a:endParaRPr lang="en-US" sz="3300" dirty="0"/>
+            <a:endParaRPr lang="en-US" sz="3800" dirty="0"/>
           </a:p>
           <a:p>
             <a:pPr algn="l" marL="228600" indent="-228600">
@@ -1603,7 +1603,7 @@
               <a:buChar char="•"/>
             </a:pPr>
             <a:r>
-              <a:rPr lang="en-US" sz="3300" dirty="0">
+              <a:rPr lang="en-US" sz="3800" dirty="0">
                 <a:solidFill>
                   <a:srgbClr val="333333"/>
                 </a:solidFill>
@@ -1613,7 +1613,7 @@
               </a:rPr>
               <a:t>Findings prompted emergency exploratory laparotomy (see Figs 2–3).</a:t>
             </a:r>
-            <a:endParaRPr lang="en-US" sz="3300" dirty="0"/>
+            <a:endParaRPr lang="en-US" sz="3800" dirty="0"/>
           </a:p>
         </p:txBody>
       </p:sp>
@@ -1625,7 +1625,7 @@
         </p:nvSpPr>
         <p:spPr>
           <a:xfrm>
-            <a:off x="720000" y="30638844"/>
+            <a:off x="720000" y="31423704"/>
             <a:ext cx="310896" cy="310896"/>
           </a:xfrm>
           <a:prstGeom prst="ellipse">
@@ -1645,7 +1645,7 @@
         </p:nvSpPr>
         <p:spPr>
           <a:xfrm>
-            <a:off x="1213776" y="30529116"/>
+            <a:off x="1213776" y="31313976"/>
             <a:ext cx="7918992" cy="603504"/>
           </a:xfrm>
           <a:prstGeom prst="rect">
@@ -1662,7 +1662,7 @@
               <a:buNone/>
             </a:pPr>
             <a:r>
-              <a:rPr lang="en-US" sz="3600" b="1" dirty="0">
+              <a:rPr lang="en-US" sz="4100" b="1" dirty="0">
                 <a:solidFill>
                   <a:srgbClr val="12355B"/>
                 </a:solidFill>
@@ -1672,7 +1672,7 @@
               </a:rPr>
               <a:t>Operative Findings</a:t>
             </a:r>
-            <a:endParaRPr lang="en-US" sz="3600" dirty="0"/>
+            <a:endParaRPr lang="en-US" sz="4100" dirty="0"/>
           </a:p>
         </p:txBody>
       </p:sp>
@@ -1684,8 +1684,8 @@
         </p:nvSpPr>
         <p:spPr>
           <a:xfrm>
-            <a:off x="756576" y="31278924"/>
-            <a:ext cx="8339616" cy="4526280"/>
+            <a:off x="756576" y="32063784"/>
+            <a:ext cx="8339616" cy="5715000"/>
           </a:xfrm>
           <a:prstGeom prst="rect">
             <a:avLst/>
@@ -1705,7 +1705,7 @@
               <a:buChar char="•"/>
             </a:pPr>
             <a:r>
-              <a:rPr lang="en-US" sz="3300" dirty="0">
+              <a:rPr lang="en-US" sz="3800" dirty="0">
                 <a:solidFill>
                   <a:srgbClr val="333333"/>
                 </a:solidFill>
@@ -1715,7 +1715,7 @@
               </a:rPr>
               <a:t>Emergency exploratory laparotomy performed.</a:t>
             </a:r>
-            <a:endParaRPr lang="en-US" sz="3300" dirty="0"/>
+            <a:endParaRPr lang="en-US" sz="3800" dirty="0"/>
           </a:p>
           <a:p>
             <a:pPr algn="l" marL="228600" indent="-228600">
@@ -1726,7 +1726,7 @@
               <a:buChar char="•"/>
             </a:pPr>
             <a:r>
-              <a:rPr lang="en-US" sz="3300" b="1" dirty="0">
+              <a:rPr lang="en-US" sz="3800" b="1" dirty="0">
                 <a:solidFill>
                   <a:srgbClr val="12355B"/>
                 </a:solidFill>
@@ -1736,7 +1736,7 @@
               </a:rPr>
               <a:t>Solitary ileal perforation ≈ 0.5 × 0.5 cm, located 40 cm proximal to the ileocaecal junction.</a:t>
             </a:r>
-            <a:endParaRPr lang="en-US" sz="3300" dirty="0"/>
+            <a:endParaRPr lang="en-US" sz="3800" dirty="0"/>
           </a:p>
           <a:p>
             <a:pPr algn="l" marL="228600" indent="-228600">
@@ -1747,7 +1747,7 @@
               <a:buChar char="•"/>
             </a:pPr>
             <a:r>
-              <a:rPr lang="en-US" sz="3300" dirty="0">
+              <a:rPr lang="en-US" sz="3800" dirty="0">
                 <a:solidFill>
                   <a:srgbClr val="333333"/>
                 </a:solidFill>
@@ -1757,7 +1757,7 @@
               </a:rPr>
               <a:t>Primary closure of the perforation performed after obtaining a biopsy from the perforation margin.</a:t>
             </a:r>
-            <a:endParaRPr lang="en-US" sz="3300" dirty="0"/>
+            <a:endParaRPr lang="en-US" sz="3800" dirty="0"/>
           </a:p>
         </p:txBody>
       </p:sp>
@@ -1769,7 +1769,7 @@
         </p:nvSpPr>
         <p:spPr>
           <a:xfrm>
-            <a:off x="23267232" y="8771059"/>
+            <a:off x="23267232" y="6407568"/>
             <a:ext cx="310896" cy="310896"/>
           </a:xfrm>
           <a:prstGeom prst="ellipse">
@@ -1789,7 +1789,7 @@
         </p:nvSpPr>
         <p:spPr>
           <a:xfrm>
-            <a:off x="23761008" y="8661331"/>
+            <a:off x="23761008" y="6297840"/>
             <a:ext cx="7918992" cy="603504"/>
           </a:xfrm>
           <a:prstGeom prst="rect">
@@ -1806,7 +1806,7 @@
               <a:buNone/>
             </a:pPr>
             <a:r>
-              <a:rPr lang="en-US" sz="3600" b="1" dirty="0">
+              <a:rPr lang="en-US" sz="4100" b="1" dirty="0">
                 <a:solidFill>
                   <a:srgbClr val="12355B"/>
                 </a:solidFill>
@@ -1816,7 +1816,7 @@
               </a:rPr>
               <a:t>Histopathology</a:t>
             </a:r>
-            <a:endParaRPr lang="en-US" sz="3600" dirty="0"/>
+            <a:endParaRPr lang="en-US" sz="4100" dirty="0"/>
           </a:p>
         </p:txBody>
       </p:sp>
@@ -1828,8 +1828,8 @@
         </p:nvSpPr>
         <p:spPr>
           <a:xfrm>
-            <a:off x="23303808" y="9411139"/>
-            <a:ext cx="8339616" cy="2916936"/>
+            <a:off x="23303808" y="7047648"/>
+            <a:ext cx="8339616" cy="3877056"/>
           </a:xfrm>
           <a:prstGeom prst="rect">
             <a:avLst/>
@@ -1849,7 +1849,7 @@
               <a:buChar char="•"/>
             </a:pPr>
             <a:r>
-              <a:rPr lang="en-US" sz="3300" b="1" dirty="0">
+              <a:rPr lang="en-US" sz="3800" b="1" dirty="0">
                 <a:solidFill>
                   <a:srgbClr val="12355B"/>
                 </a:solidFill>
@@ -1859,7 +1859,7 @@
               </a:rPr>
               <a:t>Trucut biopsy of the breast lump confirmed invasive ductal carcinoma.</a:t>
             </a:r>
-            <a:endParaRPr lang="en-US" sz="3300" dirty="0"/>
+            <a:endParaRPr lang="en-US" sz="3800" dirty="0"/>
           </a:p>
           <a:p>
             <a:pPr algn="l" marL="228600" indent="-228600">
@@ -1870,7 +1870,7 @@
               <a:buChar char="•"/>
             </a:pPr>
             <a:r>
-              <a:rPr lang="en-US" sz="3300" b="1" dirty="0">
+              <a:rPr lang="en-US" sz="3800" b="1" dirty="0">
                 <a:solidFill>
                   <a:srgbClr val="12355B"/>
                 </a:solidFill>
@@ -1880,7 +1880,7 @@
               </a:rPr>
               <a:t>Histopathology of the ileal biopsy demonstrated metastatic deposits at the perforation site.</a:t>
             </a:r>
-            <a:endParaRPr lang="en-US" sz="3300" dirty="0"/>
+            <a:endParaRPr lang="en-US" sz="3800" dirty="0"/>
           </a:p>
         </p:txBody>
       </p:sp>
@@ -1892,7 +1892,7 @@
         </p:nvSpPr>
         <p:spPr>
           <a:xfrm>
-            <a:off x="23267232" y="13882555"/>
+            <a:off x="23267232" y="11773722"/>
             <a:ext cx="310896" cy="310896"/>
           </a:xfrm>
           <a:prstGeom prst="ellipse">
@@ -1912,7 +1912,7 @@
         </p:nvSpPr>
         <p:spPr>
           <a:xfrm>
-            <a:off x="23761008" y="13772827"/>
+            <a:off x="23761008" y="11663994"/>
             <a:ext cx="7918992" cy="603504"/>
           </a:xfrm>
           <a:prstGeom prst="rect">
@@ -1929,7 +1929,7 @@
               <a:buNone/>
             </a:pPr>
             <a:r>
-              <a:rPr lang="en-US" sz="3600" b="1" dirty="0">
+              <a:rPr lang="en-US" sz="4100" b="1" dirty="0">
                 <a:solidFill>
                   <a:srgbClr val="12355B"/>
                 </a:solidFill>
@@ -1939,7 +1939,7 @@
               </a:rPr>
               <a:t>Discussion</a:t>
             </a:r>
-            <a:endParaRPr lang="en-US" sz="3600" dirty="0"/>
+            <a:endParaRPr lang="en-US" sz="4100" dirty="0"/>
           </a:p>
         </p:txBody>
       </p:sp>
@@ -1951,8 +1951,8 @@
         </p:nvSpPr>
         <p:spPr>
           <a:xfrm>
-            <a:off x="23303808" y="14522635"/>
-            <a:ext cx="8339616" cy="7141464"/>
+            <a:off x="23303808" y="12413802"/>
+            <a:ext cx="8339616" cy="8711184"/>
           </a:xfrm>
           <a:prstGeom prst="rect">
             <a:avLst/>
@@ -1972,7 +1972,7 @@
               <a:buChar char="•"/>
             </a:pPr>
             <a:r>
-              <a:rPr lang="en-US" sz="3300" dirty="0">
+              <a:rPr lang="en-US" sz="3800" dirty="0">
                 <a:solidFill>
                   <a:srgbClr val="333333"/>
                 </a:solidFill>
@@ -1982,7 +1982,7 @@
               </a:rPr>
               <a:t>Intestinal metastasis from breast carcinoma is uncommon, and perforation as the initial manifestation is exceedingly rare.</a:t>
             </a:r>
-            <a:endParaRPr lang="en-US" sz="3300" dirty="0"/>
+            <a:endParaRPr lang="en-US" sz="3800" dirty="0"/>
           </a:p>
           <a:p>
             <a:pPr algn="l" marL="228600" indent="-228600">
@@ -1993,7 +1993,7 @@
               <a:buChar char="•"/>
             </a:pPr>
             <a:r>
-              <a:rPr lang="en-US" sz="3300" dirty="0">
+              <a:rPr lang="en-US" sz="3800" dirty="0">
                 <a:solidFill>
                   <a:srgbClr val="333333"/>
                 </a:solidFill>
@@ -2003,7 +2003,7 @@
               </a:rPr>
               <a:t>Only a limited number of similar cases have been reported.</a:t>
             </a:r>
-            <a:endParaRPr lang="en-US" sz="3300" dirty="0"/>
+            <a:endParaRPr lang="en-US" sz="3800" dirty="0"/>
           </a:p>
           <a:p>
             <a:pPr algn="l" marL="228600" indent="-228600">
@@ -2014,7 +2014,7 @@
               <a:buChar char="•"/>
             </a:pPr>
             <a:r>
-              <a:rPr lang="en-US" sz="3300" dirty="0">
+              <a:rPr lang="en-US" sz="3800" dirty="0">
                 <a:solidFill>
                   <a:srgbClr val="333333"/>
                 </a:solidFill>
@@ -2024,7 +2024,7 @@
               </a:rPr>
               <a:t>This case highlights that an acute surgical abdomen may represent the first presentation of metastatic malignancy.</a:t>
             </a:r>
-            <a:endParaRPr lang="en-US" sz="3300" dirty="0"/>
+            <a:endParaRPr lang="en-US" sz="3800" dirty="0"/>
           </a:p>
           <a:p>
             <a:pPr algn="l" marL="228600" indent="-228600">
@@ -2035,7 +2035,7 @@
               <a:buChar char="•"/>
             </a:pPr>
             <a:r>
-              <a:rPr lang="en-US" sz="3300" dirty="0">
+              <a:rPr lang="en-US" sz="3800" dirty="0">
                 <a:solidFill>
                   <a:srgbClr val="333333"/>
                 </a:solidFill>
@@ -2045,7 +2045,7 @@
               </a:rPr>
               <a:t>Management requires emergency surgery followed by evaluation of the primary breast malignancy.</a:t>
             </a:r>
-            <a:endParaRPr lang="en-US" sz="3300" dirty="0"/>
+            <a:endParaRPr lang="en-US" sz="3800" dirty="0"/>
           </a:p>
         </p:txBody>
       </p:sp>
@@ -2057,12 +2057,12 @@
         </p:nvSpPr>
         <p:spPr>
           <a:xfrm>
-            <a:off x="23267232" y="23127139"/>
-            <a:ext cx="8412768" cy="7798003"/>
+            <a:off x="23267232" y="21882564"/>
+            <a:ext cx="8412768" cy="10754258"/>
           </a:xfrm>
           <a:prstGeom prst="roundRect">
             <a:avLst>
-              <a:gd name="adj" fmla="val 1173"/>
+              <a:gd name="adj" fmla="val 1087"/>
             </a:avLst>
           </a:prstGeom>
           <a:solidFill>
@@ -2091,7 +2091,7 @@
         </p:nvSpPr>
         <p:spPr>
           <a:xfrm>
-            <a:off x="23559840" y="23721499"/>
+            <a:off x="23559840" y="22476924"/>
             <a:ext cx="310896" cy="310896"/>
           </a:xfrm>
           <a:prstGeom prst="ellipse">
@@ -2111,7 +2111,7 @@
         </p:nvSpPr>
         <p:spPr>
           <a:xfrm>
-            <a:off x="24035328" y="23648347"/>
+            <a:off x="24035328" y="22403772"/>
             <a:ext cx="7352064" cy="603504"/>
           </a:xfrm>
           <a:prstGeom prst="rect">
@@ -2128,7 +2128,7 @@
               <a:buNone/>
             </a:pPr>
             <a:r>
-              <a:rPr lang="en-US" sz="3600" b="1" dirty="0">
+              <a:rPr lang="en-US" sz="4100" b="1" dirty="0">
                 <a:solidFill>
                   <a:srgbClr val="12355B"/>
                 </a:solidFill>
@@ -2138,7 +2138,7 @@
               </a:rPr>
               <a:t>Why This Case Is Unique</a:t>
             </a:r>
-            <a:endParaRPr lang="en-US" sz="3600" dirty="0"/>
+            <a:endParaRPr lang="en-US" sz="4100" dirty="0"/>
           </a:p>
         </p:txBody>
       </p:sp>
@@ -2150,8 +2150,8 @@
         </p:nvSpPr>
         <p:spPr>
           <a:xfrm>
-            <a:off x="23559840" y="24379867"/>
-            <a:ext cx="7827552" cy="6115507"/>
+            <a:off x="23559840" y="23135292"/>
+            <a:ext cx="7827552" cy="9071762"/>
           </a:xfrm>
           <a:prstGeom prst="rect">
             <a:avLst/>
@@ -2171,7 +2171,7 @@
               <a:buChar char="•"/>
             </a:pPr>
             <a:r>
-              <a:rPr lang="en-US" sz="3300" dirty="0">
+              <a:rPr lang="en-US" sz="3800" dirty="0">
                 <a:solidFill>
                   <a:srgbClr val="5A4A12"/>
                 </a:solidFill>
@@ -2181,7 +2181,7 @@
               </a:rPr>
               <a:t>Ileal perforation was the initial manifestation of previously unrecognised metastatic breast carcinoma.</a:t>
             </a:r>
-            <a:endParaRPr lang="en-US" sz="3300" dirty="0"/>
+            <a:endParaRPr lang="en-US" sz="3800" dirty="0"/>
           </a:p>
           <a:p>
             <a:pPr algn="l" marL="228600" indent="-228600">
@@ -2192,7 +2192,7 @@
               <a:buChar char="•"/>
             </a:pPr>
             <a:r>
-              <a:rPr lang="en-US" sz="3300" dirty="0">
+              <a:rPr lang="en-US" sz="3800" dirty="0">
                 <a:solidFill>
                   <a:srgbClr val="5A4A12"/>
                 </a:solidFill>
@@ -2202,7 +2202,7 @@
               </a:rPr>
               <a:t>Perforation as the first presentation is exceedingly rare, with only a limited number of reported cases.</a:t>
             </a:r>
-            <a:endParaRPr lang="en-US" sz="3300" dirty="0"/>
+            <a:endParaRPr lang="en-US" sz="3800" dirty="0"/>
           </a:p>
           <a:p>
             <a:pPr algn="l" marL="228600" indent="-228600">
@@ -2213,7 +2213,7 @@
               <a:buChar char="•"/>
             </a:pPr>
             <a:r>
-              <a:rPr lang="en-US" sz="3300" dirty="0">
+              <a:rPr lang="en-US" sz="3800" dirty="0">
                 <a:solidFill>
                   <a:srgbClr val="5A4A12"/>
                 </a:solidFill>
@@ -2223,7 +2223,7 @@
               </a:rPr>
               <a:t>Demonstrates that an acute surgical abdomen may be the first presentation of metastatic malignancy.</a:t>
             </a:r>
-            <a:endParaRPr lang="en-US" sz="3300" dirty="0"/>
+            <a:endParaRPr lang="en-US" sz="3800" dirty="0"/>
           </a:p>
         </p:txBody>
       </p:sp>
@@ -2235,12 +2235,12 @@
         </p:nvSpPr>
         <p:spPr>
           <a:xfrm>
-            <a:off x="23267232" y="32479623"/>
-            <a:ext cx="8412768" cy="6448166"/>
+            <a:off x="23267232" y="33485840"/>
+            <a:ext cx="8412768" cy="7805440"/>
           </a:xfrm>
           <a:prstGeom prst="roundRect">
             <a:avLst>
-              <a:gd name="adj" fmla="val 1418"/>
+              <a:gd name="adj" fmla="val 1171"/>
             </a:avLst>
           </a:prstGeom>
           <a:solidFill>
@@ -2264,7 +2264,7 @@
         </p:nvSpPr>
         <p:spPr>
           <a:xfrm>
-            <a:off x="23559840" y="33073983"/>
+            <a:off x="23559840" y="34080200"/>
             <a:ext cx="310896" cy="310896"/>
           </a:xfrm>
           <a:prstGeom prst="ellipse">
@@ -2284,7 +2284,7 @@
         </p:nvSpPr>
         <p:spPr>
           <a:xfrm>
-            <a:off x="24035328" y="33000831"/>
+            <a:off x="24035328" y="34007048"/>
             <a:ext cx="7352064" cy="603504"/>
           </a:xfrm>
           <a:prstGeom prst="rect">
@@ -2301,7 +2301,7 @@
               <a:buNone/>
             </a:pPr>
             <a:r>
-              <a:rPr lang="en-US" sz="3600" b="1" dirty="0">
+              <a:rPr lang="en-US" sz="4100" b="1" dirty="0">
                 <a:solidFill>
                   <a:srgbClr val="FFFFFF"/>
                 </a:solidFill>
@@ -2311,7 +2311,7 @@
               </a:rPr>
               <a:t>Conclusion</a:t>
             </a:r>
-            <a:endParaRPr lang="en-US" sz="3600" dirty="0"/>
+            <a:endParaRPr lang="en-US" sz="4100" dirty="0"/>
           </a:p>
         </p:txBody>
       </p:sp>
@@ -2323,8 +2323,8 @@
         </p:nvSpPr>
         <p:spPr>
           <a:xfrm>
-            <a:off x="23559840" y="33732351"/>
-            <a:ext cx="7827552" cy="4765670"/>
+            <a:off x="23559840" y="34738568"/>
+            <a:ext cx="7827552" cy="6122944"/>
           </a:xfrm>
           <a:prstGeom prst="rect">
             <a:avLst/>
@@ -2344,7 +2344,7 @@
               <a:buChar char="•"/>
             </a:pPr>
             <a:r>
-              <a:rPr lang="en-US" sz="3300" dirty="0">
+              <a:rPr lang="en-US" sz="3800" dirty="0">
                 <a:solidFill>
                   <a:srgbClr val="EAF1F8"/>
                 </a:solidFill>
@@ -2354,7 +2354,7 @@
               </a:rPr>
               <a:t>Ileal perforation can rarely be the presenting manifestation of metastatic breast carcinoma.</a:t>
             </a:r>
-            <a:endParaRPr lang="en-US" sz="3300" dirty="0"/>
+            <a:endParaRPr lang="en-US" sz="3800" dirty="0"/>
           </a:p>
           <a:p>
             <a:pPr algn="l" marL="228600" indent="-228600">
@@ -2365,7 +2365,7 @@
               <a:buChar char="•"/>
             </a:pPr>
             <a:r>
-              <a:rPr lang="en-US" sz="3300" dirty="0">
+              <a:rPr lang="en-US" sz="3800" dirty="0">
                 <a:solidFill>
                   <a:srgbClr val="EAF1F8"/>
                 </a:solidFill>
@@ -2375,7 +2375,7 @@
               </a:rPr>
               <a:t>A high index of suspicion together with early histopathological confirmation is essential for accurate diagnosis and appropriate management.</a:t>
             </a:r>
-            <a:endParaRPr lang="en-US" sz="3300" dirty="0"/>
+            <a:endParaRPr lang="en-US" sz="3800" dirty="0"/>
           </a:p>
         </p:txBody>
       </p:sp>
@@ -2424,7 +2424,7 @@
               <a:buNone/>
             </a:pPr>
             <a:r>
-              <a:rPr lang="en-US" sz="3600" b="1" dirty="0">
+              <a:rPr lang="en-US" sz="4100" b="1" dirty="0">
                 <a:solidFill>
                   <a:srgbClr val="12355B"/>
                 </a:solidFill>
@@ -2434,7 +2434,7 @@
               </a:rPr>
               <a:t>Clinical &amp; Diagnostic Sequence</a:t>
             </a:r>
-            <a:endParaRPr lang="en-US" sz="3600" dirty="0"/>
+            <a:endParaRPr lang="en-US" sz="4100" dirty="0"/>
           </a:p>
         </p:txBody>
       </p:sp>
@@ -2447,11 +2447,11 @@
         <p:spPr>
           <a:xfrm>
             <a:off x="9589968" y="7157376"/>
-            <a:ext cx="13220064" cy="7566778"/>
+            <a:ext cx="13220064" cy="7536298"/>
           </a:xfrm>
           <a:prstGeom prst="roundRect">
             <a:avLst>
-              <a:gd name="adj" fmla="val 1208"/>
+              <a:gd name="adj" fmla="val 1213"/>
             </a:avLst>
           </a:prstGeom>
           <a:solidFill>
@@ -2480,7 +2480,7 @@
         </p:nvSpPr>
         <p:spPr>
           <a:xfrm>
-            <a:off x="9882576" y="8042117"/>
+            <a:off x="9882576" y="8026877"/>
             <a:ext cx="5480483" cy="5797296"/>
           </a:xfrm>
           <a:prstGeom prst="roundRect">
@@ -2522,7 +2522,7 @@
         </p:blipFill>
         <p:spPr>
           <a:xfrm>
-            <a:off x="9946584" y="8106125"/>
+            <a:off x="9946584" y="8090885"/>
             <a:ext cx="5352467" cy="5669280"/>
           </a:xfrm>
           <a:prstGeom prst="rect">
@@ -2539,7 +2539,7 @@
         <p:spPr>
           <a:xfrm>
             <a:off x="15774539" y="7157376"/>
-            <a:ext cx="6742885" cy="7566778"/>
+            <a:ext cx="6742885" cy="7536298"/>
           </a:xfrm>
           <a:prstGeom prst="rect">
             <a:avLst/>
@@ -2555,7 +2555,7 @@
               <a:buNone/>
             </a:pPr>
             <a:r>
-              <a:rPr lang="en-US" sz="1900" b="1" dirty="0">
+              <a:rPr lang="en-US" sz="2100" b="1" dirty="0">
                 <a:solidFill>
                   <a:srgbClr val="12355B"/>
                 </a:solidFill>
@@ -2569,7 +2569,7 @@
               <a:buNone/>
             </a:pPr>
             <a:r>
-              <a:rPr lang="en-US" sz="1900" i="1" dirty="0">
+              <a:rPr lang="en-US" sz="2100" i="1" dirty="0">
                 <a:solidFill>
                   <a:srgbClr val="5B5B5B"/>
                 </a:solidFill>
@@ -2579,7 +2579,7 @@
               </a:rPr>
               <a:t>Clinical photograph of the right breast showing the lump that had been misdiagnosed as a breast abscess.</a:t>
             </a:r>
-            <a:endParaRPr lang="en-US" sz="1900" dirty="0"/>
+            <a:endParaRPr lang="en-US" sz="2100" dirty="0"/>
           </a:p>
         </p:txBody>
       </p:sp>
@@ -2591,7 +2591,7 @@
         </p:nvSpPr>
         <p:spPr>
           <a:xfrm>
-            <a:off x="16026264" y="14779018"/>
+            <a:off x="16026264" y="14748538"/>
             <a:ext cx="347472" cy="393192"/>
           </a:xfrm>
           <a:prstGeom prst="downArrow">
@@ -2611,12 +2611,12 @@
         </p:nvSpPr>
         <p:spPr>
           <a:xfrm>
-            <a:off x="9589968" y="15227074"/>
-            <a:ext cx="13220064" cy="7450954"/>
+            <a:off x="9589968" y="15196594"/>
+            <a:ext cx="13220064" cy="7481434"/>
           </a:xfrm>
           <a:prstGeom prst="roundRect">
             <a:avLst>
-              <a:gd name="adj" fmla="val 1227"/>
+              <a:gd name="adj" fmla="val 1222"/>
             </a:avLst>
           </a:prstGeom>
           <a:solidFill>
@@ -2645,7 +2645,7 @@
         </p:nvSpPr>
         <p:spPr>
           <a:xfrm>
-            <a:off x="10871833" y="15501394"/>
+            <a:off x="10871833" y="15470914"/>
             <a:ext cx="4248912" cy="4882896"/>
           </a:xfrm>
           <a:prstGeom prst="roundRect">
@@ -2687,7 +2687,7 @@
         </p:blipFill>
         <p:spPr>
           <a:xfrm>
-            <a:off x="10935841" y="15565402"/>
+            <a:off x="10935841" y="15534922"/>
             <a:ext cx="4120896" cy="4754880"/>
           </a:xfrm>
           <a:prstGeom prst="rect">
@@ -2703,7 +2703,7 @@
         </p:nvSpPr>
         <p:spPr>
           <a:xfrm>
-            <a:off x="15623665" y="15501394"/>
+            <a:off x="15623665" y="15470914"/>
             <a:ext cx="5904502" cy="4882896"/>
           </a:xfrm>
           <a:prstGeom prst="roundRect">
@@ -2745,7 +2745,7 @@
         </p:blipFill>
         <p:spPr>
           <a:xfrm>
-            <a:off x="15687673" y="15565402"/>
+            <a:off x="15687673" y="15534922"/>
             <a:ext cx="5776486" cy="4754880"/>
           </a:xfrm>
           <a:prstGeom prst="rect">
@@ -2761,8 +2761,8 @@
         </p:nvSpPr>
         <p:spPr>
           <a:xfrm>
-            <a:off x="9882576" y="20494018"/>
-            <a:ext cx="12634848" cy="670560"/>
+            <a:off x="9882576" y="20463538"/>
+            <a:ext cx="12634848" cy="731520"/>
           </a:xfrm>
           <a:prstGeom prst="rect">
             <a:avLst/>
@@ -2778,7 +2778,7 @@
               <a:buNone/>
             </a:pPr>
             <a:r>
-              <a:rPr lang="en-US" sz="1900" b="1" dirty="0">
+              <a:rPr lang="en-US" sz="2100" b="1" dirty="0">
                 <a:solidFill>
                   <a:srgbClr val="12355B"/>
                 </a:solidFill>
@@ -2792,7 +2792,7 @@
               <a:buNone/>
             </a:pPr>
             <a:r>
-              <a:rPr lang="en-US" sz="1900" i="1" dirty="0">
+              <a:rPr lang="en-US" sz="2100" i="1" dirty="0">
                 <a:solidFill>
                   <a:srgbClr val="5B5B5B"/>
                 </a:solidFill>
@@ -2806,7 +2806,7 @@
               <a:buNone/>
             </a:pPr>
             <a:r>
-              <a:rPr lang="en-US" sz="1900" b="1" dirty="0">
+              <a:rPr lang="en-US" sz="2100" b="1" dirty="0">
                 <a:solidFill>
                   <a:srgbClr val="12355B"/>
                 </a:solidFill>
@@ -2820,7 +2820,7 @@
               <a:buNone/>
             </a:pPr>
             <a:r>
-              <a:rPr lang="en-US" sz="1900" i="1" dirty="0">
+              <a:rPr lang="en-US" sz="2100" i="1" dirty="0">
                 <a:solidFill>
                   <a:srgbClr val="5B5B5B"/>
                 </a:solidFill>
@@ -2834,7 +2834,7 @@
               <a:buNone/>
             </a:pPr>
             <a:r>
-              <a:rPr lang="en-US" sz="1900" i="1" dirty="0">
+              <a:rPr lang="en-US" sz="2100" i="1" dirty="0">
                 <a:solidFill>
                   <a:srgbClr val="9AA6B2"/>
                 </a:solidFill>
@@ -2844,7 +2844,7 @@
               </a:rPr>
               <a:t>[Additional Information: CT findings]</a:t>
             </a:r>
-            <a:endParaRPr lang="en-US" sz="1900" dirty="0"/>
+            <a:endParaRPr lang="en-US" sz="2100" dirty="0"/>
           </a:p>
         </p:txBody>
       </p:sp>
@@ -2877,11 +2877,11 @@
         <p:spPr>
           <a:xfrm>
             <a:off x="9589968" y="23180948"/>
-            <a:ext cx="13220064" cy="7841098"/>
+            <a:ext cx="13220064" cy="7810618"/>
           </a:xfrm>
           <a:prstGeom prst="roundRect">
             <a:avLst>
-              <a:gd name="adj" fmla="val 1166"/>
+              <a:gd name="adj" fmla="val 1171"/>
             </a:avLst>
           </a:prstGeom>
           <a:solidFill>
@@ -2910,7 +2910,7 @@
         </p:nvSpPr>
         <p:spPr>
           <a:xfrm>
-            <a:off x="9882576" y="24065690"/>
+            <a:off x="9882576" y="24050450"/>
             <a:ext cx="3313953" cy="6071616"/>
           </a:xfrm>
           <a:prstGeom prst="roundRect">
@@ -2952,7 +2952,7 @@
         </p:blipFill>
         <p:spPr>
           <a:xfrm>
-            <a:off x="9946584" y="24129698"/>
+            <a:off x="9946584" y="24114458"/>
             <a:ext cx="3185937" cy="5943600"/>
           </a:xfrm>
           <a:prstGeom prst="rect">
@@ -2969,7 +2969,7 @@
         <p:spPr>
           <a:xfrm>
             <a:off x="13608009" y="23180948"/>
-            <a:ext cx="8909415" cy="7841098"/>
+            <a:ext cx="8909415" cy="7810618"/>
           </a:xfrm>
           <a:prstGeom prst="rect">
             <a:avLst/>
@@ -2985,7 +2985,7 @@
               <a:buNone/>
             </a:pPr>
             <a:r>
-              <a:rPr lang="en-US" sz="1900" b="1" dirty="0">
+              <a:rPr lang="en-US" sz="2100" b="1" dirty="0">
                 <a:solidFill>
                   <a:srgbClr val="12355B"/>
                 </a:solidFill>
@@ -2999,7 +2999,7 @@
               <a:buNone/>
             </a:pPr>
             <a:r>
-              <a:rPr lang="en-US" sz="1900" i="1" dirty="0">
+              <a:rPr lang="en-US" sz="2100" i="1" dirty="0">
                 <a:solidFill>
                   <a:srgbClr val="5B5B5B"/>
                 </a:solidFill>
@@ -3009,7 +3009,7 @@
               </a:rPr>
               <a:t>Intraoperative photograph showing the solitary ileal perforation (≈ 0.5 × 0.5 cm), located 40 cm proximal to the ileocaecal junction.</a:t>
             </a:r>
-            <a:endParaRPr lang="en-US" sz="1900" dirty="0"/>
+            <a:endParaRPr lang="en-US" sz="2100" dirty="0"/>
           </a:p>
         </p:txBody>
       </p:sp>
@@ -3021,7 +3021,7 @@
         </p:nvSpPr>
         <p:spPr>
           <a:xfrm>
-            <a:off x="16026264" y="31076911"/>
+            <a:off x="16026264" y="31046431"/>
             <a:ext cx="347472" cy="393192"/>
           </a:xfrm>
           <a:prstGeom prst="downArrow">
@@ -3041,12 +3041,12 @@
         </p:nvSpPr>
         <p:spPr>
           <a:xfrm>
-            <a:off x="9589968" y="31524967"/>
-            <a:ext cx="13220064" cy="9766313"/>
+            <a:off x="9589968" y="31494487"/>
+            <a:ext cx="13220064" cy="9796793"/>
           </a:xfrm>
           <a:prstGeom prst="roundRect">
             <a:avLst>
-              <a:gd name="adj" fmla="val 936"/>
+              <a:gd name="adj" fmla="val 933"/>
             </a:avLst>
           </a:prstGeom>
           <a:solidFill>
@@ -3075,7 +3075,7 @@
         </p:nvSpPr>
         <p:spPr>
           <a:xfrm>
-            <a:off x="10184328" y="31799287"/>
+            <a:off x="10184328" y="31768807"/>
             <a:ext cx="12031344" cy="7198255"/>
           </a:xfrm>
           <a:prstGeom prst="roundRect">
@@ -3117,7 +3117,7 @@
         </p:blipFill>
         <p:spPr>
           <a:xfrm>
-            <a:off x="10248336" y="31863295"/>
+            <a:off x="10248336" y="31832815"/>
             <a:ext cx="11903328" cy="7070239"/>
           </a:xfrm>
           <a:prstGeom prst="rect">
@@ -3133,8 +3133,8 @@
         </p:nvSpPr>
         <p:spPr>
           <a:xfrm>
-            <a:off x="9882576" y="39107270"/>
-            <a:ext cx="12634848" cy="670560"/>
+            <a:off x="9882576" y="39076790"/>
+            <a:ext cx="12634848" cy="731520"/>
           </a:xfrm>
           <a:prstGeom prst="rect">
             <a:avLst/>
@@ -3150,7 +3150,7 @@
               <a:buNone/>
             </a:pPr>
             <a:r>
-              <a:rPr lang="en-US" sz="1900" b="1" dirty="0">
+              <a:rPr lang="en-US" sz="2100" b="1" dirty="0">
                 <a:solidFill>
                   <a:srgbClr val="12355B"/>
                 </a:solidFill>
@@ -3164,7 +3164,7 @@
               <a:buNone/>
             </a:pPr>
             <a:r>
-              <a:rPr lang="en-US" sz="1900" i="1" dirty="0">
+              <a:rPr lang="en-US" sz="2100" i="1" dirty="0">
                 <a:solidFill>
                   <a:srgbClr val="5B5B5B"/>
                 </a:solidFill>
@@ -3174,7 +3174,7 @@
               </a:rPr>
               <a:t>Histopathology (H&amp;E) — invasive ductal carcinoma; metastatic deposits demonstrated at the ileal perforation site.</a:t>
             </a:r>
-            <a:endParaRPr lang="en-US" sz="1900" dirty="0"/>
+            <a:endParaRPr lang="en-US" sz="2100" dirty="0"/>
           </a:p>
         </p:txBody>
       </p:sp>

</xml_diff>

<commit_message>
Poster: add key-numbers stat band, figure badges, centred images, tighter header
- Add a header stat band with abstract-sourced key numbers (38 yrs / 2 days /
  0.5x0.5 cm / 40 cm) for at-a-glance impact
- Centre the breast and intra-op images with legends below, removing side gaps
- Add numbered badges to all five figures; enlarge the histopathology image
- Tighten the header height and vertically centre the conference logo
- Set body text to 36pt for cleaner wrapping in the narrow columns

Co-Authored-By: Claude Opus 4.8 <noreply@anthropic.com>
Claude-Session: https://claude.ai/code/session_01Hys1rt1JVnsf8msS2XZJ53
</commit_message>
<xml_diff>
--- a/TNASICON2026-Poster-Metastatic-Ileal-Perforation.pptx
+++ b/TNASICON2026-Poster-Metastatic-Ileal-Perforation.pptx
@@ -884,11 +884,11 @@
         <p:spPr>
           <a:xfrm>
             <a:off x="720000" y="720000"/>
-            <a:ext cx="30960000" cy="5212080"/>
+            <a:ext cx="30960000" cy="4617720"/>
           </a:xfrm>
           <a:prstGeom prst="roundRect">
             <a:avLst>
-              <a:gd name="adj" fmla="val 2105"/>
+              <a:gd name="adj" fmla="val 2376"/>
             </a:avLst>
           </a:prstGeom>
           <a:solidFill>
@@ -912,7 +912,7 @@
         </p:nvSpPr>
         <p:spPr>
           <a:xfrm>
-            <a:off x="26193600" y="1012608"/>
+            <a:off x="26193600" y="1659109"/>
             <a:ext cx="5394960" cy="3013823"/>
           </a:xfrm>
           <a:prstGeom prst="roundRect">
@@ -949,7 +949,7 @@
         </p:blipFill>
         <p:spPr>
           <a:xfrm>
-            <a:off x="26330760" y="1149768"/>
+            <a:off x="26330760" y="1796269"/>
             <a:ext cx="5120640" cy="2739503"/>
           </a:xfrm>
           <a:prstGeom prst="rect">
@@ -1193,16 +1193,30 @@
         </p:nvSpPr>
         <p:spPr>
           <a:xfrm>
-            <a:off x="720000" y="10011504"/>
-            <a:ext cx="310896" cy="310896"/>
-          </a:xfrm>
-          <a:prstGeom prst="ellipse">
-            <a:avLst/>
-          </a:prstGeom>
-          <a:solidFill>
-            <a:srgbClr val="2A9D8F"/>
-          </a:solidFill>
-          <a:ln/>
+            <a:off x="720000" y="5630328"/>
+            <a:ext cx="7465680" cy="1463040"/>
+          </a:xfrm>
+          <a:prstGeom prst="roundRect">
+            <a:avLst>
+              <a:gd name="adj" fmla="val 6250"/>
+            </a:avLst>
+          </a:prstGeom>
+          <a:solidFill>
+            <a:srgbClr val="EAF5F3"/>
+          </a:solidFill>
+          <a:ln w="15875">
+            <a:solidFill>
+              <a:srgbClr val="2A9D8F"/>
+            </a:solidFill>
+            <a:prstDash val="solid"/>
+          </a:ln>
+          <a:effectLst>
+            <a:outerShdw sx="100000" sy="100000" kx="0" ky="0" algn="bl" rotWithShape="0" blurRad="50800" dist="25400" dir="5400000">
+              <a:srgbClr val="B4B4B4">
+                <a:alpha val="30000"/>
+              </a:srgbClr>
+            </a:outerShdw>
+          </a:effectLst>
         </p:spPr>
       </p:sp>
       <p:sp>
@@ -1213,8 +1227,8 @@
         </p:nvSpPr>
         <p:spPr>
           <a:xfrm>
-            <a:off x="1213776" y="9901776"/>
-            <a:ext cx="7918992" cy="603504"/>
+            <a:off x="720000" y="5776632"/>
+            <a:ext cx="7465680" cy="749808"/>
           </a:xfrm>
           <a:prstGeom prst="rect">
             <a:avLst/>
@@ -1226,11 +1240,11 @@
           <a:bodyPr wrap="square" lIns="0" tIns="0" rIns="0" bIns="0" rtlCol="0" anchor="ctr"/>
           <a:lstStyle/>
           <a:p>
-            <a:pPr algn="l" indent="0" marL="0">
-              <a:buNone/>
-            </a:pPr>
-            <a:r>
-              <a:rPr lang="en-US" sz="4100" b="1" dirty="0">
+            <a:pPr algn="ctr" indent="0" marL="0">
+              <a:buNone/>
+            </a:pPr>
+            <a:r>
+              <a:rPr lang="en-US" sz="4200" b="1" dirty="0">
                 <a:solidFill>
                   <a:srgbClr val="12355B"/>
                 </a:solidFill>
@@ -1238,22 +1252,456 @@
                 <a:ea typeface="Cambria" pitchFamily="34" charset="-122"/>
                 <a:cs typeface="Cambria" pitchFamily="34" charset="-120"/>
               </a:rPr>
+              <a:t>38</a:t>
+            </a:r>
+            <a:endParaRPr lang="en-US" sz="4200" dirty="0"/>
+          </a:p>
+        </p:txBody>
+      </p:sp>
+      <p:sp>
+        <p:nvSpPr>
+          <p:cNvPr id="10" name="Text 7"/>
+          <p:cNvSpPr/>
+          <p:nvPr/>
+        </p:nvSpPr>
+        <p:spPr>
+          <a:xfrm>
+            <a:off x="720000" y="6508152"/>
+            <a:ext cx="7465680" cy="457200"/>
+          </a:xfrm>
+          <a:prstGeom prst="rect">
+            <a:avLst/>
+          </a:prstGeom>
+          <a:noFill/>
+          <a:ln/>
+        </p:spPr>
+        <p:txBody>
+          <a:bodyPr wrap="square" lIns="0" tIns="0" rIns="0" bIns="0" rtlCol="0" anchor="t"/>
+          <a:lstStyle/>
+          <a:p>
+            <a:pPr algn="ctr" indent="0" marL="0">
+              <a:buNone/>
+            </a:pPr>
+            <a:r>
+              <a:rPr lang="en-US" sz="2100" dirty="0">
+                <a:solidFill>
+                  <a:srgbClr val="333333"/>
+                </a:solidFill>
+                <a:latin typeface="Calibri" pitchFamily="34" charset="0"/>
+                <a:ea typeface="Calibri" pitchFamily="34" charset="-122"/>
+                <a:cs typeface="Calibri" pitchFamily="34" charset="-120"/>
+              </a:rPr>
+              <a:t>year-old woman</a:t>
+            </a:r>
+            <a:endParaRPr lang="en-US" sz="2100" dirty="0"/>
+          </a:p>
+        </p:txBody>
+      </p:sp>
+      <p:sp>
+        <p:nvSpPr>
+          <p:cNvPr id="11" name="Shape 8"/>
+          <p:cNvSpPr/>
+          <p:nvPr/>
+        </p:nvSpPr>
+        <p:spPr>
+          <a:xfrm>
+            <a:off x="8551440" y="5630328"/>
+            <a:ext cx="7465680" cy="1463040"/>
+          </a:xfrm>
+          <a:prstGeom prst="roundRect">
+            <a:avLst>
+              <a:gd name="adj" fmla="val 6250"/>
+            </a:avLst>
+          </a:prstGeom>
+          <a:solidFill>
+            <a:srgbClr val="EAF5F3"/>
+          </a:solidFill>
+          <a:ln w="15875">
+            <a:solidFill>
+              <a:srgbClr val="2A9D8F"/>
+            </a:solidFill>
+            <a:prstDash val="solid"/>
+          </a:ln>
+          <a:effectLst>
+            <a:outerShdw sx="100000" sy="100000" kx="0" ky="0" algn="bl" rotWithShape="0" blurRad="50800" dist="25400" dir="5400000">
+              <a:srgbClr val="B4B4B4">
+                <a:alpha val="30000"/>
+              </a:srgbClr>
+            </a:outerShdw>
+          </a:effectLst>
+        </p:spPr>
+      </p:sp>
+      <p:sp>
+        <p:nvSpPr>
+          <p:cNvPr id="12" name="Text 9"/>
+          <p:cNvSpPr/>
+          <p:nvPr/>
+        </p:nvSpPr>
+        <p:spPr>
+          <a:xfrm>
+            <a:off x="8551440" y="5776632"/>
+            <a:ext cx="7465680" cy="749808"/>
+          </a:xfrm>
+          <a:prstGeom prst="rect">
+            <a:avLst/>
+          </a:prstGeom>
+          <a:noFill/>
+          <a:ln/>
+        </p:spPr>
+        <p:txBody>
+          <a:bodyPr wrap="square" lIns="0" tIns="0" rIns="0" bIns="0" rtlCol="0" anchor="ctr"/>
+          <a:lstStyle/>
+          <a:p>
+            <a:pPr algn="ctr" indent="0" marL="0">
+              <a:buNone/>
+            </a:pPr>
+            <a:r>
+              <a:rPr lang="en-US" sz="4200" b="1" dirty="0">
+                <a:solidFill>
+                  <a:srgbClr val="12355B"/>
+                </a:solidFill>
+                <a:latin typeface="Cambria" pitchFamily="34" charset="0"/>
+                <a:ea typeface="Cambria" pitchFamily="34" charset="-122"/>
+                <a:cs typeface="Cambria" pitchFamily="34" charset="-120"/>
+              </a:rPr>
+              <a:t>2 days</a:t>
+            </a:r>
+            <a:endParaRPr lang="en-US" sz="4200" dirty="0"/>
+          </a:p>
+        </p:txBody>
+      </p:sp>
+      <p:sp>
+        <p:nvSpPr>
+          <p:cNvPr id="13" name="Text 10"/>
+          <p:cNvSpPr/>
+          <p:nvPr/>
+        </p:nvSpPr>
+        <p:spPr>
+          <a:xfrm>
+            <a:off x="8551440" y="6508152"/>
+            <a:ext cx="7465680" cy="457200"/>
+          </a:xfrm>
+          <a:prstGeom prst="rect">
+            <a:avLst/>
+          </a:prstGeom>
+          <a:noFill/>
+          <a:ln/>
+        </p:spPr>
+        <p:txBody>
+          <a:bodyPr wrap="square" lIns="0" tIns="0" rIns="0" bIns="0" rtlCol="0" anchor="t"/>
+          <a:lstStyle/>
+          <a:p>
+            <a:pPr algn="ctr" indent="0" marL="0">
+              <a:buNone/>
+            </a:pPr>
+            <a:r>
+              <a:rPr lang="en-US" sz="2100" dirty="0">
+                <a:solidFill>
+                  <a:srgbClr val="333333"/>
+                </a:solidFill>
+                <a:latin typeface="Calibri" pitchFamily="34" charset="0"/>
+                <a:ea typeface="Calibri" pitchFamily="34" charset="-122"/>
+                <a:cs typeface="Calibri" pitchFamily="34" charset="-120"/>
+              </a:rPr>
+              <a:t>of abdominal pain</a:t>
+            </a:r>
+            <a:endParaRPr lang="en-US" sz="2100" dirty="0"/>
+          </a:p>
+        </p:txBody>
+      </p:sp>
+      <p:sp>
+        <p:nvSpPr>
+          <p:cNvPr id="14" name="Shape 11"/>
+          <p:cNvSpPr/>
+          <p:nvPr/>
+        </p:nvSpPr>
+        <p:spPr>
+          <a:xfrm>
+            <a:off x="16382880" y="5630328"/>
+            <a:ext cx="7465680" cy="1463040"/>
+          </a:xfrm>
+          <a:prstGeom prst="roundRect">
+            <a:avLst>
+              <a:gd name="adj" fmla="val 6250"/>
+            </a:avLst>
+          </a:prstGeom>
+          <a:solidFill>
+            <a:srgbClr val="EAF5F3"/>
+          </a:solidFill>
+          <a:ln w="15875">
+            <a:solidFill>
+              <a:srgbClr val="2A9D8F"/>
+            </a:solidFill>
+            <a:prstDash val="solid"/>
+          </a:ln>
+          <a:effectLst>
+            <a:outerShdw sx="100000" sy="100000" kx="0" ky="0" algn="bl" rotWithShape="0" blurRad="50800" dist="25400" dir="5400000">
+              <a:srgbClr val="B4B4B4">
+                <a:alpha val="30000"/>
+              </a:srgbClr>
+            </a:outerShdw>
+          </a:effectLst>
+        </p:spPr>
+      </p:sp>
+      <p:sp>
+        <p:nvSpPr>
+          <p:cNvPr id="15" name="Text 12"/>
+          <p:cNvSpPr/>
+          <p:nvPr/>
+        </p:nvSpPr>
+        <p:spPr>
+          <a:xfrm>
+            <a:off x="16382880" y="5776632"/>
+            <a:ext cx="7465680" cy="749808"/>
+          </a:xfrm>
+          <a:prstGeom prst="rect">
+            <a:avLst/>
+          </a:prstGeom>
+          <a:noFill/>
+          <a:ln/>
+        </p:spPr>
+        <p:txBody>
+          <a:bodyPr wrap="square" lIns="0" tIns="0" rIns="0" bIns="0" rtlCol="0" anchor="ctr"/>
+          <a:lstStyle/>
+          <a:p>
+            <a:pPr algn="ctr" indent="0" marL="0">
+              <a:buNone/>
+            </a:pPr>
+            <a:r>
+              <a:rPr lang="en-US" sz="4200" b="1" dirty="0">
+                <a:solidFill>
+                  <a:srgbClr val="12355B"/>
+                </a:solidFill>
+                <a:latin typeface="Cambria" pitchFamily="34" charset="0"/>
+                <a:ea typeface="Cambria" pitchFamily="34" charset="-122"/>
+                <a:cs typeface="Cambria" pitchFamily="34" charset="-120"/>
+              </a:rPr>
+              <a:t>0.5 × 0.5 cm</a:t>
+            </a:r>
+            <a:endParaRPr lang="en-US" sz="4200" dirty="0"/>
+          </a:p>
+        </p:txBody>
+      </p:sp>
+      <p:sp>
+        <p:nvSpPr>
+          <p:cNvPr id="16" name="Text 13"/>
+          <p:cNvSpPr/>
+          <p:nvPr/>
+        </p:nvSpPr>
+        <p:spPr>
+          <a:xfrm>
+            <a:off x="16382880" y="6508152"/>
+            <a:ext cx="7465680" cy="457200"/>
+          </a:xfrm>
+          <a:prstGeom prst="rect">
+            <a:avLst/>
+          </a:prstGeom>
+          <a:noFill/>
+          <a:ln/>
+        </p:spPr>
+        <p:txBody>
+          <a:bodyPr wrap="square" lIns="0" tIns="0" rIns="0" bIns="0" rtlCol="0" anchor="t"/>
+          <a:lstStyle/>
+          <a:p>
+            <a:pPr algn="ctr" indent="0" marL="0">
+              <a:buNone/>
+            </a:pPr>
+            <a:r>
+              <a:rPr lang="en-US" sz="2100" dirty="0">
+                <a:solidFill>
+                  <a:srgbClr val="333333"/>
+                </a:solidFill>
+                <a:latin typeface="Calibri" pitchFamily="34" charset="0"/>
+                <a:ea typeface="Calibri" pitchFamily="34" charset="-122"/>
+                <a:cs typeface="Calibri" pitchFamily="34" charset="-120"/>
+              </a:rPr>
+              <a:t>solitary ileal perforation</a:t>
+            </a:r>
+            <a:endParaRPr lang="en-US" sz="2100" dirty="0"/>
+          </a:p>
+        </p:txBody>
+      </p:sp>
+      <p:sp>
+        <p:nvSpPr>
+          <p:cNvPr id="17" name="Shape 14"/>
+          <p:cNvSpPr/>
+          <p:nvPr/>
+        </p:nvSpPr>
+        <p:spPr>
+          <a:xfrm>
+            <a:off x="24214320" y="5630328"/>
+            <a:ext cx="7465680" cy="1463040"/>
+          </a:xfrm>
+          <a:prstGeom prst="roundRect">
+            <a:avLst>
+              <a:gd name="adj" fmla="val 6250"/>
+            </a:avLst>
+          </a:prstGeom>
+          <a:solidFill>
+            <a:srgbClr val="EAF5F3"/>
+          </a:solidFill>
+          <a:ln w="15875">
+            <a:solidFill>
+              <a:srgbClr val="2A9D8F"/>
+            </a:solidFill>
+            <a:prstDash val="solid"/>
+          </a:ln>
+          <a:effectLst>
+            <a:outerShdw sx="100000" sy="100000" kx="0" ky="0" algn="bl" rotWithShape="0" blurRad="50800" dist="25400" dir="5400000">
+              <a:srgbClr val="B4B4B4">
+                <a:alpha val="30000"/>
+              </a:srgbClr>
+            </a:outerShdw>
+          </a:effectLst>
+        </p:spPr>
+      </p:sp>
+      <p:sp>
+        <p:nvSpPr>
+          <p:cNvPr id="18" name="Text 15"/>
+          <p:cNvSpPr/>
+          <p:nvPr/>
+        </p:nvSpPr>
+        <p:spPr>
+          <a:xfrm>
+            <a:off x="24214320" y="5776632"/>
+            <a:ext cx="7465680" cy="749808"/>
+          </a:xfrm>
+          <a:prstGeom prst="rect">
+            <a:avLst/>
+          </a:prstGeom>
+          <a:noFill/>
+          <a:ln/>
+        </p:spPr>
+        <p:txBody>
+          <a:bodyPr wrap="square" lIns="0" tIns="0" rIns="0" bIns="0" rtlCol="0" anchor="ctr"/>
+          <a:lstStyle/>
+          <a:p>
+            <a:pPr algn="ctr" indent="0" marL="0">
+              <a:buNone/>
+            </a:pPr>
+            <a:r>
+              <a:rPr lang="en-US" sz="4200" b="1" dirty="0">
+                <a:solidFill>
+                  <a:srgbClr val="12355B"/>
+                </a:solidFill>
+                <a:latin typeface="Cambria" pitchFamily="34" charset="0"/>
+                <a:ea typeface="Cambria" pitchFamily="34" charset="-122"/>
+                <a:cs typeface="Cambria" pitchFamily="34" charset="-120"/>
+              </a:rPr>
+              <a:t>40 cm</a:t>
+            </a:r>
+            <a:endParaRPr lang="en-US" sz="4200" dirty="0"/>
+          </a:p>
+        </p:txBody>
+      </p:sp>
+      <p:sp>
+        <p:nvSpPr>
+          <p:cNvPr id="19" name="Text 16"/>
+          <p:cNvSpPr/>
+          <p:nvPr/>
+        </p:nvSpPr>
+        <p:spPr>
+          <a:xfrm>
+            <a:off x="24214320" y="6508152"/>
+            <a:ext cx="7465680" cy="457200"/>
+          </a:xfrm>
+          <a:prstGeom prst="rect">
+            <a:avLst/>
+          </a:prstGeom>
+          <a:noFill/>
+          <a:ln/>
+        </p:spPr>
+        <p:txBody>
+          <a:bodyPr wrap="square" lIns="0" tIns="0" rIns="0" bIns="0" rtlCol="0" anchor="t"/>
+          <a:lstStyle/>
+          <a:p>
+            <a:pPr algn="ctr" indent="0" marL="0">
+              <a:buNone/>
+            </a:pPr>
+            <a:r>
+              <a:rPr lang="en-US" sz="2100" dirty="0">
+                <a:solidFill>
+                  <a:srgbClr val="333333"/>
+                </a:solidFill>
+                <a:latin typeface="Calibri" pitchFamily="34" charset="0"/>
+                <a:ea typeface="Calibri" pitchFamily="34" charset="-122"/>
+                <a:cs typeface="Calibri" pitchFamily="34" charset="-120"/>
+              </a:rPr>
+              <a:t>proximal to the IC junction</a:t>
+            </a:r>
+            <a:endParaRPr lang="en-US" sz="2100" dirty="0"/>
+          </a:p>
+        </p:txBody>
+      </p:sp>
+      <p:sp>
+        <p:nvSpPr>
+          <p:cNvPr id="20" name="Shape 17"/>
+          <p:cNvSpPr/>
+          <p:nvPr/>
+        </p:nvSpPr>
+        <p:spPr>
+          <a:xfrm>
+            <a:off x="720000" y="11902788"/>
+            <a:ext cx="310896" cy="310896"/>
+          </a:xfrm>
+          <a:prstGeom prst="ellipse">
+            <a:avLst/>
+          </a:prstGeom>
+          <a:solidFill>
+            <a:srgbClr val="2A9D8F"/>
+          </a:solidFill>
+          <a:ln/>
+        </p:spPr>
+      </p:sp>
+      <p:sp>
+        <p:nvSpPr>
+          <p:cNvPr id="21" name="Text 18"/>
+          <p:cNvSpPr/>
+          <p:nvPr/>
+        </p:nvSpPr>
+        <p:spPr>
+          <a:xfrm>
+            <a:off x="1213776" y="11793060"/>
+            <a:ext cx="7918992" cy="603504"/>
+          </a:xfrm>
+          <a:prstGeom prst="rect">
+            <a:avLst/>
+          </a:prstGeom>
+          <a:noFill/>
+          <a:ln/>
+        </p:spPr>
+        <p:txBody>
+          <a:bodyPr wrap="square" lIns="0" tIns="0" rIns="0" bIns="0" rtlCol="0" anchor="ctr"/>
+          <a:lstStyle/>
+          <a:p>
+            <a:pPr algn="l" indent="0" marL="0">
+              <a:buNone/>
+            </a:pPr>
+            <a:r>
+              <a:rPr lang="en-US" sz="3900" b="1" dirty="0">
+                <a:solidFill>
+                  <a:srgbClr val="12355B"/>
+                </a:solidFill>
+                <a:latin typeface="Cambria" pitchFamily="34" charset="0"/>
+                <a:ea typeface="Cambria" pitchFamily="34" charset="-122"/>
+                <a:cs typeface="Cambria" pitchFamily="34" charset="-120"/>
+              </a:rPr>
               <a:t>Background</a:t>
             </a:r>
-            <a:endParaRPr lang="en-US" sz="4100" dirty="0"/>
-          </a:p>
-        </p:txBody>
-      </p:sp>
-      <p:sp>
-        <p:nvSpPr>
-          <p:cNvPr id="10" name="Text 7"/>
-          <p:cNvSpPr/>
-          <p:nvPr/>
-        </p:nvSpPr>
-        <p:spPr>
-          <a:xfrm>
-            <a:off x="756576" y="10651584"/>
-            <a:ext cx="8339616" cy="5815584"/>
+            <a:endParaRPr lang="en-US" sz="3900" dirty="0"/>
+          </a:p>
+        </p:txBody>
+      </p:sp>
+      <p:sp>
+        <p:nvSpPr>
+          <p:cNvPr id="22" name="Text 19"/>
+          <p:cNvSpPr/>
+          <p:nvPr/>
+        </p:nvSpPr>
+        <p:spPr>
+          <a:xfrm>
+            <a:off x="756576" y="12542868"/>
+            <a:ext cx="8339616" cy="5541264"/>
           </a:xfrm>
           <a:prstGeom prst="rect">
             <a:avLst/>
@@ -1273,7 +1721,7 @@
               <a:buChar char="•"/>
             </a:pPr>
             <a:r>
-              <a:rPr lang="en-US" sz="3800" dirty="0">
+              <a:rPr lang="en-US" sz="3600" dirty="0">
                 <a:solidFill>
                   <a:srgbClr val="333333"/>
                 </a:solidFill>
@@ -1283,7 +1731,7 @@
               </a:rPr>
               <a:t>Intestinal metastasis from breast carcinoma is uncommon.</a:t>
             </a:r>
-            <a:endParaRPr lang="en-US" sz="3800" dirty="0"/>
+            <a:endParaRPr lang="en-US" sz="3600" dirty="0"/>
           </a:p>
           <a:p>
             <a:pPr algn="l" marL="228600" indent="-228600">
@@ -1294,7 +1742,7 @@
               <a:buChar char="•"/>
             </a:pPr>
             <a:r>
-              <a:rPr lang="en-US" sz="3800" dirty="0">
+              <a:rPr lang="en-US" sz="3600" dirty="0">
                 <a:solidFill>
                   <a:srgbClr val="333333"/>
                 </a:solidFill>
@@ -1304,7 +1752,7 @@
               </a:rPr>
               <a:t>Perforation as the initial manifestation is exceedingly rare.</a:t>
             </a:r>
-            <a:endParaRPr lang="en-US" sz="3800" dirty="0"/>
+            <a:endParaRPr lang="en-US" sz="3600" dirty="0"/>
           </a:p>
           <a:p>
             <a:pPr algn="l" marL="228600" indent="-228600">
@@ -1315,7 +1763,7 @@
               <a:buChar char="•"/>
             </a:pPr>
             <a:r>
-              <a:rPr lang="en-US" sz="3800" dirty="0">
+              <a:rPr lang="en-US" sz="3600" dirty="0">
                 <a:solidFill>
                   <a:srgbClr val="333333"/>
                 </a:solidFill>
@@ -1325,7 +1773,7 @@
               </a:rPr>
               <a:t>Only a limited number of similar cases have been reported.</a:t>
             </a:r>
-            <a:endParaRPr lang="en-US" sz="3800" dirty="0"/>
+            <a:endParaRPr lang="en-US" sz="3600" dirty="0"/>
           </a:p>
           <a:p>
             <a:pPr algn="l" marL="228600" indent="-228600">
@@ -1336,7 +1784,7 @@
               <a:buChar char="•"/>
             </a:pPr>
             <a:r>
-              <a:rPr lang="en-US" sz="3800" dirty="0">
+              <a:rPr lang="en-US" sz="3600" dirty="0">
                 <a:solidFill>
                   <a:srgbClr val="333333"/>
                 </a:solidFill>
@@ -1346,19 +1794,19 @@
               </a:rPr>
               <a:t>An acute surgical abdomen may represent the first presentation of metastatic malignancy.</a:t>
             </a:r>
-            <a:endParaRPr lang="en-US" sz="3800" dirty="0"/>
-          </a:p>
-        </p:txBody>
-      </p:sp>
-      <p:sp>
-        <p:nvSpPr>
-          <p:cNvPr id="11" name="Shape 8"/>
-          <p:cNvSpPr/>
-          <p:nvPr/>
-        </p:nvSpPr>
-        <p:spPr>
-          <a:xfrm>
-            <a:off x="720000" y="18021648"/>
+            <a:endParaRPr lang="en-US" sz="3600" dirty="0"/>
+          </a:p>
+        </p:txBody>
+      </p:sp>
+      <p:sp>
+        <p:nvSpPr>
+          <p:cNvPr id="23" name="Shape 20"/>
+          <p:cNvSpPr/>
+          <p:nvPr/>
+        </p:nvSpPr>
+        <p:spPr>
+          <a:xfrm>
+            <a:off x="720000" y="19638612"/>
             <a:ext cx="310896" cy="310896"/>
           </a:xfrm>
           <a:prstGeom prst="ellipse">
@@ -1372,13 +1820,13 @@
       </p:sp>
       <p:sp>
         <p:nvSpPr>
-          <p:cNvPr id="12" name="Text 9"/>
-          <p:cNvSpPr/>
-          <p:nvPr/>
-        </p:nvSpPr>
-        <p:spPr>
-          <a:xfrm>
-            <a:off x="1213776" y="17911920"/>
+          <p:cNvPr id="24" name="Text 21"/>
+          <p:cNvSpPr/>
+          <p:nvPr/>
+        </p:nvSpPr>
+        <p:spPr>
+          <a:xfrm>
+            <a:off x="1213776" y="19528884"/>
             <a:ext cx="7918992" cy="603504"/>
           </a:xfrm>
           <a:prstGeom prst="rect">
@@ -1395,7 +1843,7 @@
               <a:buNone/>
             </a:pPr>
             <a:r>
-              <a:rPr lang="en-US" sz="4100" b="1" dirty="0">
+              <a:rPr lang="en-US" sz="3900" b="1" dirty="0">
                 <a:solidFill>
                   <a:srgbClr val="12355B"/>
                 </a:solidFill>
@@ -1405,20 +1853,20 @@
               </a:rPr>
               <a:t>Case Presentation</a:t>
             </a:r>
-            <a:endParaRPr lang="en-US" sz="4100" dirty="0"/>
-          </a:p>
-        </p:txBody>
-      </p:sp>
-      <p:sp>
-        <p:nvSpPr>
-          <p:cNvPr id="13" name="Text 10"/>
-          <p:cNvSpPr/>
-          <p:nvPr/>
-        </p:nvSpPr>
-        <p:spPr>
-          <a:xfrm>
-            <a:off x="756576" y="18661728"/>
-            <a:ext cx="8339616" cy="5715000"/>
+            <a:endParaRPr lang="en-US" sz="3900" dirty="0"/>
+          </a:p>
+        </p:txBody>
+      </p:sp>
+      <p:sp>
+        <p:nvSpPr>
+          <p:cNvPr id="25" name="Text 22"/>
+          <p:cNvSpPr/>
+          <p:nvPr/>
+        </p:nvSpPr>
+        <p:spPr>
+          <a:xfrm>
+            <a:off x="756576" y="20278692"/>
+            <a:ext cx="8339616" cy="4892040"/>
           </a:xfrm>
           <a:prstGeom prst="rect">
             <a:avLst/>
@@ -1438,7 +1886,7 @@
               <a:buChar char="•"/>
             </a:pPr>
             <a:r>
-              <a:rPr lang="en-US" sz="3800" b="1" dirty="0">
+              <a:rPr lang="en-US" sz="3600" b="1" dirty="0">
                 <a:solidFill>
                   <a:srgbClr val="12355B"/>
                 </a:solidFill>
@@ -1448,7 +1896,7 @@
               </a:rPr>
               <a:t>38-year-old woman with abdominal pain for two days.</a:t>
             </a:r>
-            <a:endParaRPr lang="en-US" sz="3800" dirty="0"/>
+            <a:endParaRPr lang="en-US" sz="3600" dirty="0"/>
           </a:p>
           <a:p>
             <a:pPr algn="l" marL="228600" indent="-228600">
@@ -1459,7 +1907,7 @@
               <a:buChar char="•"/>
             </a:pPr>
             <a:r>
-              <a:rPr lang="en-US" sz="3800" dirty="0">
+              <a:rPr lang="en-US" sz="3600" dirty="0">
                 <a:solidFill>
                   <a:srgbClr val="333333"/>
                 </a:solidFill>
@@ -1469,7 +1917,7 @@
               </a:rPr>
               <a:t>History of chronic NSAID abuse for pain related to a right breast lump, which had been misdiagnosed as a breast abscess.</a:t>
             </a:r>
-            <a:endParaRPr lang="en-US" sz="3800" dirty="0"/>
+            <a:endParaRPr lang="en-US" sz="3600" dirty="0"/>
           </a:p>
           <a:p>
             <a:pPr algn="l" marL="228600" indent="-228600">
@@ -1480,7 +1928,7 @@
               <a:buChar char="•"/>
             </a:pPr>
             <a:r>
-              <a:rPr lang="en-US" sz="3800" dirty="0">
+              <a:rPr lang="en-US" sz="3600" dirty="0">
                 <a:solidFill>
                   <a:srgbClr val="333333"/>
                 </a:solidFill>
@@ -1490,19 +1938,19 @@
               </a:rPr>
               <a:t>On examination: tachycardic, with generalized abdominal rigidity.</a:t>
             </a:r>
-            <a:endParaRPr lang="en-US" sz="3800" dirty="0"/>
-          </a:p>
-        </p:txBody>
-      </p:sp>
-      <p:sp>
-        <p:nvSpPr>
-          <p:cNvPr id="14" name="Shape 11"/>
-          <p:cNvSpPr/>
-          <p:nvPr/>
-        </p:nvSpPr>
-        <p:spPr>
-          <a:xfrm>
-            <a:off x="720000" y="25931208"/>
+            <a:endParaRPr lang="en-US" sz="3600" dirty="0"/>
+          </a:p>
+        </p:txBody>
+      </p:sp>
+      <p:sp>
+        <p:nvSpPr>
+          <p:cNvPr id="26" name="Shape 23"/>
+          <p:cNvSpPr/>
+          <p:nvPr/>
+        </p:nvSpPr>
+        <p:spPr>
+          <a:xfrm>
+            <a:off x="720000" y="26725212"/>
             <a:ext cx="310896" cy="310896"/>
           </a:xfrm>
           <a:prstGeom prst="ellipse">
@@ -1516,13 +1964,13 @@
       </p:sp>
       <p:sp>
         <p:nvSpPr>
-          <p:cNvPr id="15" name="Text 12"/>
-          <p:cNvSpPr/>
-          <p:nvPr/>
-        </p:nvSpPr>
-        <p:spPr>
-          <a:xfrm>
-            <a:off x="1213776" y="25821480"/>
+          <p:cNvPr id="27" name="Text 24"/>
+          <p:cNvSpPr/>
+          <p:nvPr/>
+        </p:nvSpPr>
+        <p:spPr>
+          <a:xfrm>
+            <a:off x="1213776" y="26615484"/>
             <a:ext cx="7918992" cy="603504"/>
           </a:xfrm>
           <a:prstGeom prst="rect">
@@ -1539,7 +1987,7 @@
               <a:buNone/>
             </a:pPr>
             <a:r>
-              <a:rPr lang="en-US" sz="4100" b="1" dirty="0">
+              <a:rPr lang="en-US" sz="3900" b="1" dirty="0">
                 <a:solidFill>
                   <a:srgbClr val="12355B"/>
                 </a:solidFill>
@@ -1549,20 +1997,20 @@
               </a:rPr>
               <a:t>Investigations</a:t>
             </a:r>
-            <a:endParaRPr lang="en-US" sz="4100" dirty="0"/>
-          </a:p>
-        </p:txBody>
-      </p:sp>
-      <p:sp>
-        <p:nvSpPr>
-          <p:cNvPr id="16" name="Text 13"/>
-          <p:cNvSpPr/>
-          <p:nvPr/>
-        </p:nvSpPr>
-        <p:spPr>
-          <a:xfrm>
-            <a:off x="756576" y="26571288"/>
-            <a:ext cx="8339616" cy="3297936"/>
+            <a:endParaRPr lang="en-US" sz="3900" dirty="0"/>
+          </a:p>
+        </p:txBody>
+      </p:sp>
+      <p:sp>
+        <p:nvSpPr>
+          <p:cNvPr id="28" name="Text 25"/>
+          <p:cNvSpPr/>
+          <p:nvPr/>
+        </p:nvSpPr>
+        <p:spPr>
+          <a:xfrm>
+            <a:off x="756576" y="27365292"/>
+            <a:ext cx="8339616" cy="2596896"/>
           </a:xfrm>
           <a:prstGeom prst="rect">
             <a:avLst/>
@@ -1582,7 +2030,7 @@
               <a:buChar char="•"/>
             </a:pPr>
             <a:r>
-              <a:rPr lang="en-US" sz="3800" b="1" dirty="0">
+              <a:rPr lang="en-US" sz="3600" b="1" dirty="0">
                 <a:solidFill>
                   <a:srgbClr val="12355B"/>
                 </a:solidFill>
@@ -1592,7 +2040,7 @@
               </a:rPr>
               <a:t>Erect abdominal radiograph demonstrated pneumoperitoneum.</a:t>
             </a:r>
-            <a:endParaRPr lang="en-US" sz="3800" dirty="0"/>
+            <a:endParaRPr lang="en-US" sz="3600" dirty="0"/>
           </a:p>
           <a:p>
             <a:pPr algn="l" marL="228600" indent="-228600">
@@ -1603,7 +2051,7 @@
               <a:buChar char="•"/>
             </a:pPr>
             <a:r>
-              <a:rPr lang="en-US" sz="3800" dirty="0">
+              <a:rPr lang="en-US" sz="3600" dirty="0">
                 <a:solidFill>
                   <a:srgbClr val="333333"/>
                 </a:solidFill>
@@ -1613,19 +2061,19 @@
               </a:rPr>
               <a:t>Findings prompted emergency exploratory laparotomy (see Figs 2–3).</a:t>
             </a:r>
-            <a:endParaRPr lang="en-US" sz="3800" dirty="0"/>
-          </a:p>
-        </p:txBody>
-      </p:sp>
-      <p:sp>
-        <p:nvSpPr>
-          <p:cNvPr id="17" name="Shape 14"/>
-          <p:cNvSpPr/>
-          <p:nvPr/>
-        </p:nvSpPr>
-        <p:spPr>
-          <a:xfrm>
-            <a:off x="720000" y="31423704"/>
+            <a:endParaRPr lang="en-US" sz="3600" dirty="0"/>
+          </a:p>
+        </p:txBody>
+      </p:sp>
+      <p:sp>
+        <p:nvSpPr>
+          <p:cNvPr id="29" name="Shape 26"/>
+          <p:cNvSpPr/>
+          <p:nvPr/>
+        </p:nvSpPr>
+        <p:spPr>
+          <a:xfrm>
+            <a:off x="720000" y="31516668"/>
             <a:ext cx="310896" cy="310896"/>
           </a:xfrm>
           <a:prstGeom prst="ellipse">
@@ -1639,13 +2087,13 @@
       </p:sp>
       <p:sp>
         <p:nvSpPr>
-          <p:cNvPr id="18" name="Text 15"/>
-          <p:cNvSpPr/>
-          <p:nvPr/>
-        </p:nvSpPr>
-        <p:spPr>
-          <a:xfrm>
-            <a:off x="1213776" y="31313976"/>
+          <p:cNvPr id="30" name="Text 27"/>
+          <p:cNvSpPr/>
+          <p:nvPr/>
+        </p:nvSpPr>
+        <p:spPr>
+          <a:xfrm>
+            <a:off x="1213776" y="31406940"/>
             <a:ext cx="7918992" cy="603504"/>
           </a:xfrm>
           <a:prstGeom prst="rect">
@@ -1662,7 +2110,7 @@
               <a:buNone/>
             </a:pPr>
             <a:r>
-              <a:rPr lang="en-US" sz="4100" b="1" dirty="0">
+              <a:rPr lang="en-US" sz="3900" b="1" dirty="0">
                 <a:solidFill>
                   <a:srgbClr val="12355B"/>
                 </a:solidFill>
@@ -1672,20 +2120,20 @@
               </a:rPr>
               <a:t>Operative Findings</a:t>
             </a:r>
-            <a:endParaRPr lang="en-US" sz="4100" dirty="0"/>
-          </a:p>
-        </p:txBody>
-      </p:sp>
-      <p:sp>
-        <p:nvSpPr>
-          <p:cNvPr id="19" name="Text 16"/>
-          <p:cNvSpPr/>
-          <p:nvPr/>
-        </p:nvSpPr>
-        <p:spPr>
-          <a:xfrm>
-            <a:off x="756576" y="32063784"/>
-            <a:ext cx="8339616" cy="5715000"/>
+            <a:endParaRPr lang="en-US" sz="3900" dirty="0"/>
+          </a:p>
+        </p:txBody>
+      </p:sp>
+      <p:sp>
+        <p:nvSpPr>
+          <p:cNvPr id="31" name="Text 28"/>
+          <p:cNvSpPr/>
+          <p:nvPr/>
+        </p:nvSpPr>
+        <p:spPr>
+          <a:xfrm>
+            <a:off x="756576" y="32156748"/>
+            <a:ext cx="8339616" cy="4892040"/>
           </a:xfrm>
           <a:prstGeom prst="rect">
             <a:avLst/>
@@ -1705,7 +2153,7 @@
               <a:buChar char="•"/>
             </a:pPr>
             <a:r>
-              <a:rPr lang="en-US" sz="3800" dirty="0">
+              <a:rPr lang="en-US" sz="3600" dirty="0">
                 <a:solidFill>
                   <a:srgbClr val="333333"/>
                 </a:solidFill>
@@ -1715,7 +2163,7 @@
               </a:rPr>
               <a:t>Emergency exploratory laparotomy performed.</a:t>
             </a:r>
-            <a:endParaRPr lang="en-US" sz="3800" dirty="0"/>
+            <a:endParaRPr lang="en-US" sz="3600" dirty="0"/>
           </a:p>
           <a:p>
             <a:pPr algn="l" marL="228600" indent="-228600">
@@ -1726,7 +2174,7 @@
               <a:buChar char="•"/>
             </a:pPr>
             <a:r>
-              <a:rPr lang="en-US" sz="3800" b="1" dirty="0">
+              <a:rPr lang="en-US" sz="3600" b="1" dirty="0">
                 <a:solidFill>
                   <a:srgbClr val="12355B"/>
                 </a:solidFill>
@@ -1736,7 +2184,7 @@
               </a:rPr>
               <a:t>Solitary ileal perforation ≈ 0.5 × 0.5 cm, located 40 cm proximal to the ileocaecal junction.</a:t>
             </a:r>
-            <a:endParaRPr lang="en-US" sz="3800" dirty="0"/>
+            <a:endParaRPr lang="en-US" sz="3600" dirty="0"/>
           </a:p>
           <a:p>
             <a:pPr algn="l" marL="228600" indent="-228600">
@@ -1747,7 +2195,7 @@
               <a:buChar char="•"/>
             </a:pPr>
             <a:r>
-              <a:rPr lang="en-US" sz="3800" dirty="0">
+              <a:rPr lang="en-US" sz="3600" dirty="0">
                 <a:solidFill>
                   <a:srgbClr val="333333"/>
                 </a:solidFill>
@@ -1757,19 +2205,19 @@
               </a:rPr>
               <a:t>Primary closure of the perforation performed after obtaining a biopsy from the perforation margin.</a:t>
             </a:r>
-            <a:endParaRPr lang="en-US" sz="3800" dirty="0"/>
-          </a:p>
-        </p:txBody>
-      </p:sp>
-      <p:sp>
-        <p:nvSpPr>
-          <p:cNvPr id="20" name="Shape 17"/>
-          <p:cNvSpPr/>
-          <p:nvPr/>
-        </p:nvSpPr>
-        <p:spPr>
-          <a:xfrm>
-            <a:off x="23267232" y="6407568"/>
+            <a:endParaRPr lang="en-US" sz="3600" dirty="0"/>
+          </a:p>
+        </p:txBody>
+      </p:sp>
+      <p:sp>
+        <p:nvSpPr>
+          <p:cNvPr id="32" name="Shape 29"/>
+          <p:cNvSpPr/>
+          <p:nvPr/>
+        </p:nvSpPr>
+        <p:spPr>
+          <a:xfrm>
+            <a:off x="23267232" y="7568856"/>
             <a:ext cx="310896" cy="310896"/>
           </a:xfrm>
           <a:prstGeom prst="ellipse">
@@ -1783,13 +2231,13 @@
       </p:sp>
       <p:sp>
         <p:nvSpPr>
-          <p:cNvPr id="21" name="Text 18"/>
-          <p:cNvSpPr/>
-          <p:nvPr/>
-        </p:nvSpPr>
-        <p:spPr>
-          <a:xfrm>
-            <a:off x="23761008" y="6297840"/>
+          <p:cNvPr id="33" name="Text 30"/>
+          <p:cNvSpPr/>
+          <p:nvPr/>
+        </p:nvSpPr>
+        <p:spPr>
+          <a:xfrm>
+            <a:off x="23761008" y="7459128"/>
             <a:ext cx="7918992" cy="603504"/>
           </a:xfrm>
           <a:prstGeom prst="rect">
@@ -1806,7 +2254,7 @@
               <a:buNone/>
             </a:pPr>
             <a:r>
-              <a:rPr lang="en-US" sz="4100" b="1" dirty="0">
+              <a:rPr lang="en-US" sz="3900" b="1" dirty="0">
                 <a:solidFill>
                   <a:srgbClr val="12355B"/>
                 </a:solidFill>
@@ -1816,20 +2264,20 @@
               </a:rPr>
               <a:t>Histopathology</a:t>
             </a:r>
-            <a:endParaRPr lang="en-US" sz="4100" dirty="0"/>
-          </a:p>
-        </p:txBody>
-      </p:sp>
-      <p:sp>
-        <p:nvSpPr>
-          <p:cNvPr id="22" name="Text 19"/>
-          <p:cNvSpPr/>
-          <p:nvPr/>
-        </p:nvSpPr>
-        <p:spPr>
-          <a:xfrm>
-            <a:off x="23303808" y="7047648"/>
-            <a:ext cx="8339616" cy="3877056"/>
+            <a:endParaRPr lang="en-US" sz="3900" dirty="0"/>
+          </a:p>
+        </p:txBody>
+      </p:sp>
+      <p:sp>
+        <p:nvSpPr>
+          <p:cNvPr id="34" name="Text 31"/>
+          <p:cNvSpPr/>
+          <p:nvPr/>
+        </p:nvSpPr>
+        <p:spPr>
+          <a:xfrm>
+            <a:off x="23303808" y="8208936"/>
+            <a:ext cx="8339616" cy="3694176"/>
           </a:xfrm>
           <a:prstGeom prst="rect">
             <a:avLst/>
@@ -1849,7 +2297,7 @@
               <a:buChar char="•"/>
             </a:pPr>
             <a:r>
-              <a:rPr lang="en-US" sz="3800" b="1" dirty="0">
+              <a:rPr lang="en-US" sz="3600" b="1" dirty="0">
                 <a:solidFill>
                   <a:srgbClr val="12355B"/>
                 </a:solidFill>
@@ -1859,7 +2307,7 @@
               </a:rPr>
               <a:t>Trucut biopsy of the breast lump confirmed invasive ductal carcinoma.</a:t>
             </a:r>
-            <a:endParaRPr lang="en-US" sz="3800" dirty="0"/>
+            <a:endParaRPr lang="en-US" sz="3600" dirty="0"/>
           </a:p>
           <a:p>
             <a:pPr algn="l" marL="228600" indent="-228600">
@@ -1870,7 +2318,7 @@
               <a:buChar char="•"/>
             </a:pPr>
             <a:r>
-              <a:rPr lang="en-US" sz="3800" b="1" dirty="0">
+              <a:rPr lang="en-US" sz="3600" b="1" dirty="0">
                 <a:solidFill>
                   <a:srgbClr val="12355B"/>
                 </a:solidFill>
@@ -1880,19 +2328,19 @@
               </a:rPr>
               <a:t>Histopathology of the ileal biopsy demonstrated metastatic deposits at the perforation site.</a:t>
             </a:r>
-            <a:endParaRPr lang="en-US" sz="3800" dirty="0"/>
-          </a:p>
-        </p:txBody>
-      </p:sp>
-      <p:sp>
-        <p:nvSpPr>
-          <p:cNvPr id="23" name="Shape 20"/>
-          <p:cNvSpPr/>
-          <p:nvPr/>
-        </p:nvSpPr>
-        <p:spPr>
-          <a:xfrm>
-            <a:off x="23267232" y="11773722"/>
+            <a:endParaRPr lang="en-US" sz="3600" dirty="0"/>
+          </a:p>
+        </p:txBody>
+      </p:sp>
+      <p:sp>
+        <p:nvSpPr>
+          <p:cNvPr id="35" name="Shape 32"/>
+          <p:cNvSpPr/>
+          <p:nvPr/>
+        </p:nvSpPr>
+        <p:spPr>
+          <a:xfrm>
+            <a:off x="23267232" y="12999018"/>
             <a:ext cx="310896" cy="310896"/>
           </a:xfrm>
           <a:prstGeom prst="ellipse">
@@ -1906,13 +2354,13 @@
       </p:sp>
       <p:sp>
         <p:nvSpPr>
-          <p:cNvPr id="24" name="Text 21"/>
-          <p:cNvSpPr/>
-          <p:nvPr/>
-        </p:nvSpPr>
-        <p:spPr>
-          <a:xfrm>
-            <a:off x="23761008" y="11663994"/>
+          <p:cNvPr id="36" name="Text 33"/>
+          <p:cNvSpPr/>
+          <p:nvPr/>
+        </p:nvSpPr>
+        <p:spPr>
+          <a:xfrm>
+            <a:off x="23761008" y="12889290"/>
             <a:ext cx="7918992" cy="603504"/>
           </a:xfrm>
           <a:prstGeom prst="rect">
@@ -1929,7 +2377,7 @@
               <a:buNone/>
             </a:pPr>
             <a:r>
-              <a:rPr lang="en-US" sz="4100" b="1" dirty="0">
+              <a:rPr lang="en-US" sz="3900" b="1" dirty="0">
                 <a:solidFill>
                   <a:srgbClr val="12355B"/>
                 </a:solidFill>
@@ -1939,20 +2387,20 @@
               </a:rPr>
               <a:t>Discussion</a:t>
             </a:r>
-            <a:endParaRPr lang="en-US" sz="4100" dirty="0"/>
-          </a:p>
-        </p:txBody>
-      </p:sp>
-      <p:sp>
-        <p:nvSpPr>
-          <p:cNvPr id="25" name="Text 22"/>
-          <p:cNvSpPr/>
-          <p:nvPr/>
-        </p:nvSpPr>
-        <p:spPr>
-          <a:xfrm>
-            <a:off x="23303808" y="12413802"/>
-            <a:ext cx="8339616" cy="8711184"/>
+            <a:endParaRPr lang="en-US" sz="3900" dirty="0"/>
+          </a:p>
+        </p:txBody>
+      </p:sp>
+      <p:sp>
+        <p:nvSpPr>
+          <p:cNvPr id="37" name="Text 34"/>
+          <p:cNvSpPr/>
+          <p:nvPr/>
+        </p:nvSpPr>
+        <p:spPr>
+          <a:xfrm>
+            <a:off x="23303808" y="13639098"/>
+            <a:ext cx="8339616" cy="7735824"/>
           </a:xfrm>
           <a:prstGeom prst="rect">
             <a:avLst/>
@@ -1972,7 +2420,7 @@
               <a:buChar char="•"/>
             </a:pPr>
             <a:r>
-              <a:rPr lang="en-US" sz="3800" dirty="0">
+              <a:rPr lang="en-US" sz="3600" dirty="0">
                 <a:solidFill>
                   <a:srgbClr val="333333"/>
                 </a:solidFill>
@@ -1982,7 +2430,7 @@
               </a:rPr>
               <a:t>Intestinal metastasis from breast carcinoma is uncommon, and perforation as the initial manifestation is exceedingly rare.</a:t>
             </a:r>
-            <a:endParaRPr lang="en-US" sz="3800" dirty="0"/>
+            <a:endParaRPr lang="en-US" sz="3600" dirty="0"/>
           </a:p>
           <a:p>
             <a:pPr algn="l" marL="228600" indent="-228600">
@@ -1993,7 +2441,7 @@
               <a:buChar char="•"/>
             </a:pPr>
             <a:r>
-              <a:rPr lang="en-US" sz="3800" dirty="0">
+              <a:rPr lang="en-US" sz="3600" dirty="0">
                 <a:solidFill>
                   <a:srgbClr val="333333"/>
                 </a:solidFill>
@@ -2003,7 +2451,7 @@
               </a:rPr>
               <a:t>Only a limited number of similar cases have been reported.</a:t>
             </a:r>
-            <a:endParaRPr lang="en-US" sz="3800" dirty="0"/>
+            <a:endParaRPr lang="en-US" sz="3600" dirty="0"/>
           </a:p>
           <a:p>
             <a:pPr algn="l" marL="228600" indent="-228600">
@@ -2014,7 +2462,7 @@
               <a:buChar char="•"/>
             </a:pPr>
             <a:r>
-              <a:rPr lang="en-US" sz="3800" dirty="0">
+              <a:rPr lang="en-US" sz="3600" dirty="0">
                 <a:solidFill>
                   <a:srgbClr val="333333"/>
                 </a:solidFill>
@@ -2024,7 +2472,7 @@
               </a:rPr>
               <a:t>This case highlights that an acute surgical abdomen may represent the first presentation of metastatic malignancy.</a:t>
             </a:r>
-            <a:endParaRPr lang="en-US" sz="3800" dirty="0"/>
+            <a:endParaRPr lang="en-US" sz="3600" dirty="0"/>
           </a:p>
           <a:p>
             <a:pPr algn="l" marL="228600" indent="-228600">
@@ -2035,7 +2483,7 @@
               <a:buChar char="•"/>
             </a:pPr>
             <a:r>
-              <a:rPr lang="en-US" sz="3800" dirty="0">
+              <a:rPr lang="en-US" sz="3600" dirty="0">
                 <a:solidFill>
                   <a:srgbClr val="333333"/>
                 </a:solidFill>
@@ -2045,20 +2493,20 @@
               </a:rPr>
               <a:t>Management requires emergency surgery followed by evaluation of the primary breast malignancy.</a:t>
             </a:r>
-            <a:endParaRPr lang="en-US" sz="3800" dirty="0"/>
-          </a:p>
-        </p:txBody>
-      </p:sp>
-      <p:sp>
-        <p:nvSpPr>
-          <p:cNvPr id="26" name="Shape 23"/>
-          <p:cNvSpPr/>
-          <p:nvPr/>
-        </p:nvSpPr>
-        <p:spPr>
-          <a:xfrm>
-            <a:off x="23267232" y="21882564"/>
-            <a:ext cx="8412768" cy="10754258"/>
+            <a:endParaRPr lang="en-US" sz="3600" dirty="0"/>
+          </a:p>
+        </p:txBody>
+      </p:sp>
+      <p:sp>
+        <p:nvSpPr>
+          <p:cNvPr id="38" name="Shape 35"/>
+          <p:cNvSpPr/>
+          <p:nvPr/>
+        </p:nvSpPr>
+        <p:spPr>
+          <a:xfrm>
+            <a:off x="23267232" y="22379388"/>
+            <a:ext cx="8412768" cy="10308031"/>
           </a:xfrm>
           <a:prstGeom prst="roundRect">
             <a:avLst>
@@ -2085,13 +2533,13 @@
       </p:sp>
       <p:sp>
         <p:nvSpPr>
-          <p:cNvPr id="27" name="Shape 24"/>
-          <p:cNvSpPr/>
-          <p:nvPr/>
-        </p:nvSpPr>
-        <p:spPr>
-          <a:xfrm>
-            <a:off x="23559840" y="22476924"/>
+          <p:cNvPr id="39" name="Shape 36"/>
+          <p:cNvSpPr/>
+          <p:nvPr/>
+        </p:nvSpPr>
+        <p:spPr>
+          <a:xfrm>
+            <a:off x="23559840" y="22973748"/>
             <a:ext cx="310896" cy="310896"/>
           </a:xfrm>
           <a:prstGeom prst="ellipse">
@@ -2105,13 +2553,13 @@
       </p:sp>
       <p:sp>
         <p:nvSpPr>
-          <p:cNvPr id="28" name="Text 25"/>
-          <p:cNvSpPr/>
-          <p:nvPr/>
-        </p:nvSpPr>
-        <p:spPr>
-          <a:xfrm>
-            <a:off x="24035328" y="22403772"/>
+          <p:cNvPr id="40" name="Text 37"/>
+          <p:cNvSpPr/>
+          <p:nvPr/>
+        </p:nvSpPr>
+        <p:spPr>
+          <a:xfrm>
+            <a:off x="24035328" y="22900596"/>
             <a:ext cx="7352064" cy="603504"/>
           </a:xfrm>
           <a:prstGeom prst="rect">
@@ -2128,7 +2576,7 @@
               <a:buNone/>
             </a:pPr>
             <a:r>
-              <a:rPr lang="en-US" sz="4100" b="1" dirty="0">
+              <a:rPr lang="en-US" sz="3900" b="1" dirty="0">
                 <a:solidFill>
                   <a:srgbClr val="12355B"/>
                 </a:solidFill>
@@ -2138,20 +2586,20 @@
               </a:rPr>
               <a:t>Why This Case Is Unique</a:t>
             </a:r>
-            <a:endParaRPr lang="en-US" sz="4100" dirty="0"/>
-          </a:p>
-        </p:txBody>
-      </p:sp>
-      <p:sp>
-        <p:nvSpPr>
-          <p:cNvPr id="29" name="Text 26"/>
-          <p:cNvSpPr/>
-          <p:nvPr/>
-        </p:nvSpPr>
-        <p:spPr>
-          <a:xfrm>
-            <a:off x="23559840" y="23135292"/>
-            <a:ext cx="7827552" cy="9071762"/>
+            <a:endParaRPr lang="en-US" sz="3900" dirty="0"/>
+          </a:p>
+        </p:txBody>
+      </p:sp>
+      <p:sp>
+        <p:nvSpPr>
+          <p:cNvPr id="41" name="Text 38"/>
+          <p:cNvSpPr/>
+          <p:nvPr/>
+        </p:nvSpPr>
+        <p:spPr>
+          <a:xfrm>
+            <a:off x="23559840" y="23632116"/>
+            <a:ext cx="7827552" cy="8625535"/>
           </a:xfrm>
           <a:prstGeom prst="rect">
             <a:avLst/>
@@ -2171,7 +2619,7 @@
               <a:buChar char="•"/>
             </a:pPr>
             <a:r>
-              <a:rPr lang="en-US" sz="3800" dirty="0">
+              <a:rPr lang="en-US" sz="3600" dirty="0">
                 <a:solidFill>
                   <a:srgbClr val="5A4A12"/>
                 </a:solidFill>
@@ -2181,7 +2629,7 @@
               </a:rPr>
               <a:t>Ileal perforation was the initial manifestation of previously unrecognised metastatic breast carcinoma.</a:t>
             </a:r>
-            <a:endParaRPr lang="en-US" sz="3800" dirty="0"/>
+            <a:endParaRPr lang="en-US" sz="3600" dirty="0"/>
           </a:p>
           <a:p>
             <a:pPr algn="l" marL="228600" indent="-228600">
@@ -2192,7 +2640,7 @@
               <a:buChar char="•"/>
             </a:pPr>
             <a:r>
-              <a:rPr lang="en-US" sz="3800" dirty="0">
+              <a:rPr lang="en-US" sz="3600" dirty="0">
                 <a:solidFill>
                   <a:srgbClr val="5A4A12"/>
                 </a:solidFill>
@@ -2202,7 +2650,7 @@
               </a:rPr>
               <a:t>Perforation as the first presentation is exceedingly rare, with only a limited number of reported cases.</a:t>
             </a:r>
-            <a:endParaRPr lang="en-US" sz="3800" dirty="0"/>
+            <a:endParaRPr lang="en-US" sz="3600" dirty="0"/>
           </a:p>
           <a:p>
             <a:pPr algn="l" marL="228600" indent="-228600">
@@ -2213,7 +2661,7 @@
               <a:buChar char="•"/>
             </a:pPr>
             <a:r>
-              <a:rPr lang="en-US" sz="3800" dirty="0">
+              <a:rPr lang="en-US" sz="3600" dirty="0">
                 <a:solidFill>
                   <a:srgbClr val="5A4A12"/>
                 </a:solidFill>
@@ -2223,24 +2671,24 @@
               </a:rPr>
               <a:t>Demonstrates that an acute surgical abdomen may be the first presentation of metastatic malignancy.</a:t>
             </a:r>
-            <a:endParaRPr lang="en-US" sz="3800" dirty="0"/>
-          </a:p>
-        </p:txBody>
-      </p:sp>
-      <p:sp>
-        <p:nvSpPr>
-          <p:cNvPr id="30" name="Shape 27"/>
-          <p:cNvSpPr/>
-          <p:nvPr/>
-        </p:nvSpPr>
-        <p:spPr>
-          <a:xfrm>
-            <a:off x="23267232" y="33485840"/>
-            <a:ext cx="8412768" cy="7805440"/>
+            <a:endParaRPr lang="en-US" sz="3600" dirty="0"/>
+          </a:p>
+        </p:txBody>
+      </p:sp>
+      <p:sp>
+        <p:nvSpPr>
+          <p:cNvPr id="42" name="Shape 39"/>
+          <p:cNvSpPr/>
+          <p:nvPr/>
+        </p:nvSpPr>
+        <p:spPr>
+          <a:xfrm>
+            <a:off x="23267232" y="33783324"/>
+            <a:ext cx="8412768" cy="7507956"/>
           </a:xfrm>
           <a:prstGeom prst="roundRect">
             <a:avLst>
-              <a:gd name="adj" fmla="val 1171"/>
+              <a:gd name="adj" fmla="val 1218"/>
             </a:avLst>
           </a:prstGeom>
           <a:solidFill>
@@ -2258,13 +2706,13 @@
       </p:sp>
       <p:sp>
         <p:nvSpPr>
-          <p:cNvPr id="31" name="Shape 28"/>
-          <p:cNvSpPr/>
-          <p:nvPr/>
-        </p:nvSpPr>
-        <p:spPr>
-          <a:xfrm>
-            <a:off x="23559840" y="34080200"/>
+          <p:cNvPr id="43" name="Shape 40"/>
+          <p:cNvSpPr/>
+          <p:nvPr/>
+        </p:nvSpPr>
+        <p:spPr>
+          <a:xfrm>
+            <a:off x="23559840" y="34377684"/>
             <a:ext cx="310896" cy="310896"/>
           </a:xfrm>
           <a:prstGeom prst="ellipse">
@@ -2278,13 +2726,13 @@
       </p:sp>
       <p:sp>
         <p:nvSpPr>
-          <p:cNvPr id="32" name="Text 29"/>
-          <p:cNvSpPr/>
-          <p:nvPr/>
-        </p:nvSpPr>
-        <p:spPr>
-          <a:xfrm>
-            <a:off x="24035328" y="34007048"/>
+          <p:cNvPr id="44" name="Text 41"/>
+          <p:cNvSpPr/>
+          <p:nvPr/>
+        </p:nvSpPr>
+        <p:spPr>
+          <a:xfrm>
+            <a:off x="24035328" y="34304532"/>
             <a:ext cx="7352064" cy="603504"/>
           </a:xfrm>
           <a:prstGeom prst="rect">
@@ -2301,7 +2749,7 @@
               <a:buNone/>
             </a:pPr>
             <a:r>
-              <a:rPr lang="en-US" sz="4100" b="1" dirty="0">
+              <a:rPr lang="en-US" sz="3900" b="1" dirty="0">
                 <a:solidFill>
                   <a:srgbClr val="FFFFFF"/>
                 </a:solidFill>
@@ -2311,20 +2759,20 @@
               </a:rPr>
               <a:t>Conclusion</a:t>
             </a:r>
-            <a:endParaRPr lang="en-US" sz="4100" dirty="0"/>
-          </a:p>
-        </p:txBody>
-      </p:sp>
-      <p:sp>
-        <p:nvSpPr>
-          <p:cNvPr id="33" name="Text 30"/>
-          <p:cNvSpPr/>
-          <p:nvPr/>
-        </p:nvSpPr>
-        <p:spPr>
-          <a:xfrm>
-            <a:off x="23559840" y="34738568"/>
-            <a:ext cx="7827552" cy="6122944"/>
+            <a:endParaRPr lang="en-US" sz="3900" dirty="0"/>
+          </a:p>
+        </p:txBody>
+      </p:sp>
+      <p:sp>
+        <p:nvSpPr>
+          <p:cNvPr id="45" name="Text 42"/>
+          <p:cNvSpPr/>
+          <p:nvPr/>
+        </p:nvSpPr>
+        <p:spPr>
+          <a:xfrm>
+            <a:off x="23559840" y="35036052"/>
+            <a:ext cx="7827552" cy="5825460"/>
           </a:xfrm>
           <a:prstGeom prst="rect">
             <a:avLst/>
@@ -2344,7 +2792,7 @@
               <a:buChar char="•"/>
             </a:pPr>
             <a:r>
-              <a:rPr lang="en-US" sz="3800" dirty="0">
+              <a:rPr lang="en-US" sz="3600" dirty="0">
                 <a:solidFill>
                   <a:srgbClr val="EAF1F8"/>
                 </a:solidFill>
@@ -2354,7 +2802,7 @@
               </a:rPr>
               <a:t>Ileal perforation can rarely be the presenting manifestation of metastatic breast carcinoma.</a:t>
             </a:r>
-            <a:endParaRPr lang="en-US" sz="3800" dirty="0"/>
+            <a:endParaRPr lang="en-US" sz="3600" dirty="0"/>
           </a:p>
           <a:p>
             <a:pPr algn="l" marL="228600" indent="-228600">
@@ -2365,7 +2813,7 @@
               <a:buChar char="•"/>
             </a:pPr>
             <a:r>
-              <a:rPr lang="en-US" sz="3800" dirty="0">
+              <a:rPr lang="en-US" sz="3600" dirty="0">
                 <a:solidFill>
                   <a:srgbClr val="EAF1F8"/>
                 </a:solidFill>
@@ -2375,19 +2823,19 @@
               </a:rPr>
               <a:t>A high index of suspicion together with early histopathological confirmation is essential for accurate diagnosis and appropriate management.</a:t>
             </a:r>
-            <a:endParaRPr lang="en-US" sz="3800" dirty="0"/>
-          </a:p>
-        </p:txBody>
-      </p:sp>
-      <p:sp>
-        <p:nvSpPr>
-          <p:cNvPr id="34" name="Shape 31"/>
-          <p:cNvSpPr/>
-          <p:nvPr/>
-        </p:nvSpPr>
-        <p:spPr>
-          <a:xfrm>
-            <a:off x="9589968" y="6389280"/>
+            <a:endParaRPr lang="en-US" sz="3600" dirty="0"/>
+          </a:p>
+        </p:txBody>
+      </p:sp>
+      <p:sp>
+        <p:nvSpPr>
+          <p:cNvPr id="46" name="Shape 43"/>
+          <p:cNvSpPr/>
+          <p:nvPr/>
+        </p:nvSpPr>
+        <p:spPr>
+          <a:xfrm>
+            <a:off x="9589968" y="7550568"/>
             <a:ext cx="310896" cy="310896"/>
           </a:xfrm>
           <a:prstGeom prst="ellipse">
@@ -2401,13 +2849,13 @@
       </p:sp>
       <p:sp>
         <p:nvSpPr>
-          <p:cNvPr id="35" name="Text 32"/>
-          <p:cNvSpPr/>
-          <p:nvPr/>
-        </p:nvSpPr>
-        <p:spPr>
-          <a:xfrm>
-            <a:off x="10047168" y="6316128"/>
+          <p:cNvPr id="47" name="Text 44"/>
+          <p:cNvSpPr/>
+          <p:nvPr/>
+        </p:nvSpPr>
+        <p:spPr>
+          <a:xfrm>
+            <a:off x="10047168" y="7477416"/>
             <a:ext cx="12762864" cy="640080"/>
           </a:xfrm>
           <a:prstGeom prst="rect">
@@ -2424,7 +2872,7 @@
               <a:buNone/>
             </a:pPr>
             <a:r>
-              <a:rPr lang="en-US" sz="4100" b="1" dirty="0">
+              <a:rPr lang="en-US" sz="3900" b="1" dirty="0">
                 <a:solidFill>
                   <a:srgbClr val="12355B"/>
                 </a:solidFill>
@@ -2434,24 +2882,24 @@
               </a:rPr>
               <a:t>Clinical &amp; Diagnostic Sequence</a:t>
             </a:r>
-            <a:endParaRPr lang="en-US" sz="4100" dirty="0"/>
-          </a:p>
-        </p:txBody>
-      </p:sp>
-      <p:sp>
-        <p:nvSpPr>
-          <p:cNvPr id="36" name="Shape 33"/>
-          <p:cNvSpPr/>
-          <p:nvPr/>
-        </p:nvSpPr>
-        <p:spPr>
-          <a:xfrm>
-            <a:off x="9589968" y="7157376"/>
-            <a:ext cx="13220064" cy="7536298"/>
+            <a:endParaRPr lang="en-US" sz="3900" dirty="0"/>
+          </a:p>
+        </p:txBody>
+      </p:sp>
+      <p:sp>
+        <p:nvSpPr>
+          <p:cNvPr id="48" name="Shape 45"/>
+          <p:cNvSpPr/>
+          <p:nvPr/>
+        </p:nvSpPr>
+        <p:spPr>
+          <a:xfrm>
+            <a:off x="9589968" y="8318664"/>
+            <a:ext cx="13220064" cy="7914315"/>
           </a:xfrm>
           <a:prstGeom prst="roundRect">
             <a:avLst>
-              <a:gd name="adj" fmla="val 1213"/>
+              <a:gd name="adj" fmla="val 1155"/>
             </a:avLst>
           </a:prstGeom>
           <a:solidFill>
@@ -2474,18 +2922,18 @@
       </p:sp>
       <p:sp>
         <p:nvSpPr>
-          <p:cNvPr id="37" name="Shape 34"/>
-          <p:cNvSpPr/>
-          <p:nvPr/>
-        </p:nvSpPr>
-        <p:spPr>
-          <a:xfrm>
-            <a:off x="9882576" y="8026877"/>
-            <a:ext cx="5480483" cy="5797296"/>
+          <p:cNvPr id="49" name="Shape 46"/>
+          <p:cNvSpPr/>
+          <p:nvPr/>
+        </p:nvSpPr>
+        <p:spPr>
+          <a:xfrm>
+            <a:off x="13157603" y="8592984"/>
+            <a:ext cx="6084794" cy="6437376"/>
           </a:xfrm>
           <a:prstGeom prst="roundRect">
             <a:avLst>
-              <a:gd name="adj" fmla="val 1001"/>
+              <a:gd name="adj" fmla="val 902"/>
             </a:avLst>
           </a:prstGeom>
           <a:solidFill>
@@ -2508,7 +2956,7 @@
       </p:sp>
       <p:pic>
         <p:nvPicPr>
-          <p:cNvPr id="38" name="Image 1" descr="/home/user/career-ops/4-breast-lump.jpeg">    </p:cNvPr>
+          <p:cNvPr id="50" name="Image 1" descr="/home/user/career-ops/4-breast-lump.jpeg">    </p:cNvPr>
           <p:cNvPicPr>
             <a:picLocks noChangeAspect="1"/>
           </p:cNvPicPr>
@@ -2522,8 +2970,8 @@
         </p:blipFill>
         <p:spPr>
           <a:xfrm>
-            <a:off x="9946584" y="8090885"/>
-            <a:ext cx="5352467" cy="5669280"/>
+            <a:off x="13221611" y="8656992"/>
+            <a:ext cx="5956778" cy="6309360"/>
           </a:xfrm>
           <a:prstGeom prst="rect">
             <a:avLst/>
@@ -2532,14 +2980,46 @@
       </p:pic>
       <p:sp>
         <p:nvSpPr>
-          <p:cNvPr id="39" name="Text 35"/>
-          <p:cNvSpPr/>
-          <p:nvPr/>
-        </p:nvSpPr>
-        <p:spPr>
-          <a:xfrm>
-            <a:off x="15774539" y="7157376"/>
-            <a:ext cx="6742885" cy="7536298"/>
+          <p:cNvPr id="51" name="Shape 47"/>
+          <p:cNvSpPr/>
+          <p:nvPr/>
+        </p:nvSpPr>
+        <p:spPr>
+          <a:xfrm>
+            <a:off x="13047875" y="8483256"/>
+            <a:ext cx="566928" cy="566928"/>
+          </a:xfrm>
+          <a:prstGeom prst="ellipse">
+            <a:avLst/>
+          </a:prstGeom>
+          <a:solidFill>
+            <a:srgbClr val="2A9D8F"/>
+          </a:solidFill>
+          <a:ln w="25400">
+            <a:solidFill>
+              <a:srgbClr val="FFFFFF"/>
+            </a:solidFill>
+            <a:prstDash val="solid"/>
+          </a:ln>
+          <a:effectLst>
+            <a:outerShdw sx="100000" sy="100000" kx="0" ky="0" algn="bl" rotWithShape="0" blurRad="63500" dist="38100" dir="5400000">
+              <a:srgbClr val="8A8A8A">
+                <a:alpha val="32000"/>
+              </a:srgbClr>
+            </a:outerShdw>
+          </a:effectLst>
+        </p:spPr>
+      </p:sp>
+      <p:sp>
+        <p:nvSpPr>
+          <p:cNvPr id="52" name="Text 48"/>
+          <p:cNvSpPr/>
+          <p:nvPr/>
+        </p:nvSpPr>
+        <p:spPr>
+          <a:xfrm>
+            <a:off x="13047875" y="8483256"/>
+            <a:ext cx="566928" cy="566928"/>
           </a:xfrm>
           <a:prstGeom prst="rect">
             <a:avLst/>
@@ -2551,11 +3031,50 @@
           <a:bodyPr wrap="square" lIns="0" tIns="0" rIns="0" bIns="0" rtlCol="0" anchor="ctr"/>
           <a:lstStyle/>
           <a:p>
+            <a:pPr algn="ctr" indent="0" marL="0">
+              <a:buNone/>
+            </a:pPr>
+            <a:r>
+              <a:rPr lang="en-US" sz="2400" b="1" dirty="0">
+                <a:solidFill>
+                  <a:srgbClr val="FFFFFF"/>
+                </a:solidFill>
+                <a:latin typeface="Cambria" pitchFamily="34" charset="0"/>
+                <a:ea typeface="Cambria" pitchFamily="34" charset="-122"/>
+                <a:cs typeface="Cambria" pitchFamily="34" charset="-120"/>
+              </a:rPr>
+              <a:t>1</a:t>
+            </a:r>
+            <a:endParaRPr lang="en-US" sz="2400" dirty="0"/>
+          </a:p>
+        </p:txBody>
+      </p:sp>
+      <p:sp>
+        <p:nvSpPr>
+          <p:cNvPr id="53" name="Text 49"/>
+          <p:cNvSpPr/>
+          <p:nvPr/>
+        </p:nvSpPr>
+        <p:spPr>
+          <a:xfrm>
+            <a:off x="9882576" y="15140088"/>
+            <a:ext cx="12634848" cy="701040"/>
+          </a:xfrm>
+          <a:prstGeom prst="rect">
+            <a:avLst/>
+          </a:prstGeom>
+          <a:noFill/>
+          <a:ln/>
+        </p:spPr>
+        <p:txBody>
+          <a:bodyPr wrap="square" lIns="0" tIns="0" rIns="0" bIns="0" rtlCol="0" anchor="t"/>
+          <a:lstStyle/>
+          <a:p>
             <a:pPr algn="l" indent="0" marL="0">
               <a:buNone/>
             </a:pPr>
             <a:r>
-              <a:rPr lang="en-US" sz="2100" b="1" dirty="0">
+              <a:rPr lang="en-US" sz="2000" b="1" dirty="0">
                 <a:solidFill>
                   <a:srgbClr val="12355B"/>
                 </a:solidFill>
@@ -2569,7 +3088,7 @@
               <a:buNone/>
             </a:pPr>
             <a:r>
-              <a:rPr lang="en-US" sz="2100" i="1" dirty="0">
+              <a:rPr lang="en-US" sz="2000" i="1" dirty="0">
                 <a:solidFill>
                   <a:srgbClr val="5B5B5B"/>
                 </a:solidFill>
@@ -2579,19 +3098,19 @@
               </a:rPr>
               <a:t>Clinical photograph of the right breast showing the lump that had been misdiagnosed as a breast abscess.</a:t>
             </a:r>
-            <a:endParaRPr lang="en-US" sz="2100" dirty="0"/>
-          </a:p>
-        </p:txBody>
-      </p:sp>
-      <p:sp>
-        <p:nvSpPr>
-          <p:cNvPr id="40" name="Shape 36"/>
-          <p:cNvSpPr/>
-          <p:nvPr/>
-        </p:nvSpPr>
-        <p:spPr>
-          <a:xfrm>
-            <a:off x="16026264" y="14748538"/>
+            <a:endParaRPr lang="en-US" sz="2000" dirty="0"/>
+          </a:p>
+        </p:txBody>
+      </p:sp>
+      <p:sp>
+        <p:nvSpPr>
+          <p:cNvPr id="54" name="Shape 50"/>
+          <p:cNvSpPr/>
+          <p:nvPr/>
+        </p:nvSpPr>
+        <p:spPr>
+          <a:xfrm>
+            <a:off x="16026264" y="16287843"/>
             <a:ext cx="347472" cy="393192"/>
           </a:xfrm>
           <a:prstGeom prst="downArrow">
@@ -2605,18 +3124,18 @@
       </p:sp>
       <p:sp>
         <p:nvSpPr>
-          <p:cNvPr id="41" name="Shape 37"/>
-          <p:cNvSpPr/>
-          <p:nvPr/>
-        </p:nvSpPr>
-        <p:spPr>
-          <a:xfrm>
-            <a:off x="9589968" y="15196594"/>
-            <a:ext cx="13220064" cy="7481434"/>
+          <p:cNvPr id="55" name="Shape 51"/>
+          <p:cNvSpPr/>
+          <p:nvPr/>
+        </p:nvSpPr>
+        <p:spPr>
+          <a:xfrm>
+            <a:off x="9589968" y="16735899"/>
+            <a:ext cx="13220064" cy="6359835"/>
           </a:xfrm>
           <a:prstGeom prst="roundRect">
             <a:avLst>
-              <a:gd name="adj" fmla="val 1222"/>
+              <a:gd name="adj" fmla="val 1438"/>
             </a:avLst>
           </a:prstGeom>
           <a:solidFill>
@@ -2639,13 +3158,13 @@
       </p:sp>
       <p:sp>
         <p:nvSpPr>
-          <p:cNvPr id="42" name="Shape 38"/>
-          <p:cNvSpPr/>
-          <p:nvPr/>
-        </p:nvSpPr>
-        <p:spPr>
-          <a:xfrm>
-            <a:off x="10871833" y="15470914"/>
+          <p:cNvPr id="56" name="Shape 52"/>
+          <p:cNvSpPr/>
+          <p:nvPr/>
+        </p:nvSpPr>
+        <p:spPr>
+          <a:xfrm>
+            <a:off x="10871833" y="17010219"/>
             <a:ext cx="4248912" cy="4882896"/>
           </a:xfrm>
           <a:prstGeom prst="roundRect">
@@ -2673,7 +3192,7 @@
       </p:sp>
       <p:pic>
         <p:nvPicPr>
-          <p:cNvPr id="43" name="Image 2" descr="/home/user/career-ops/1-xray-pneumoperitoneum.jpeg">    </p:cNvPr>
+          <p:cNvPr id="57" name="Image 2" descr="/home/user/career-ops/1-xray-pneumoperitoneum.jpeg">    </p:cNvPr>
           <p:cNvPicPr>
             <a:picLocks noChangeAspect="1"/>
           </p:cNvPicPr>
@@ -2687,7 +3206,7 @@
         </p:blipFill>
         <p:spPr>
           <a:xfrm>
-            <a:off x="10935841" y="15534922"/>
+            <a:off x="10935841" y="17074227"/>
             <a:ext cx="4120896" cy="4754880"/>
           </a:xfrm>
           <a:prstGeom prst="rect">
@@ -2697,13 +3216,84 @@
       </p:pic>
       <p:sp>
         <p:nvSpPr>
-          <p:cNvPr id="44" name="Shape 39"/>
-          <p:cNvSpPr/>
-          <p:nvPr/>
-        </p:nvSpPr>
-        <p:spPr>
-          <a:xfrm>
-            <a:off x="15623665" y="15470914"/>
+          <p:cNvPr id="58" name="Shape 53"/>
+          <p:cNvSpPr/>
+          <p:nvPr/>
+        </p:nvSpPr>
+        <p:spPr>
+          <a:xfrm>
+            <a:off x="10762105" y="16900491"/>
+            <a:ext cx="566928" cy="566928"/>
+          </a:xfrm>
+          <a:prstGeom prst="ellipse">
+            <a:avLst/>
+          </a:prstGeom>
+          <a:solidFill>
+            <a:srgbClr val="2A9D8F"/>
+          </a:solidFill>
+          <a:ln w="25400">
+            <a:solidFill>
+              <a:srgbClr val="FFFFFF"/>
+            </a:solidFill>
+            <a:prstDash val="solid"/>
+          </a:ln>
+          <a:effectLst>
+            <a:outerShdw sx="100000" sy="100000" kx="0" ky="0" algn="bl" rotWithShape="0" blurRad="63500" dist="38100" dir="5400000">
+              <a:srgbClr val="8A8A8A">
+                <a:alpha val="32000"/>
+              </a:srgbClr>
+            </a:outerShdw>
+          </a:effectLst>
+        </p:spPr>
+      </p:sp>
+      <p:sp>
+        <p:nvSpPr>
+          <p:cNvPr id="59" name="Text 54"/>
+          <p:cNvSpPr/>
+          <p:nvPr/>
+        </p:nvSpPr>
+        <p:spPr>
+          <a:xfrm>
+            <a:off x="10762105" y="16900491"/>
+            <a:ext cx="566928" cy="566928"/>
+          </a:xfrm>
+          <a:prstGeom prst="rect">
+            <a:avLst/>
+          </a:prstGeom>
+          <a:noFill/>
+          <a:ln/>
+        </p:spPr>
+        <p:txBody>
+          <a:bodyPr wrap="square" lIns="0" tIns="0" rIns="0" bIns="0" rtlCol="0" anchor="ctr"/>
+          <a:lstStyle/>
+          <a:p>
+            <a:pPr algn="ctr" indent="0" marL="0">
+              <a:buNone/>
+            </a:pPr>
+            <a:r>
+              <a:rPr lang="en-US" sz="2400" b="1" dirty="0">
+                <a:solidFill>
+                  <a:srgbClr val="FFFFFF"/>
+                </a:solidFill>
+                <a:latin typeface="Cambria" pitchFamily="34" charset="0"/>
+                <a:ea typeface="Cambria" pitchFamily="34" charset="-122"/>
+                <a:cs typeface="Cambria" pitchFamily="34" charset="-120"/>
+              </a:rPr>
+              <a:t>2</a:t>
+            </a:r>
+            <a:endParaRPr lang="en-US" sz="2400" dirty="0"/>
+          </a:p>
+        </p:txBody>
+      </p:sp>
+      <p:sp>
+        <p:nvSpPr>
+          <p:cNvPr id="60" name="Shape 55"/>
+          <p:cNvSpPr/>
+          <p:nvPr/>
+        </p:nvSpPr>
+        <p:spPr>
+          <a:xfrm>
+            <a:off x="15623665" y="17010219"/>
             <a:ext cx="5904502" cy="4882896"/>
           </a:xfrm>
           <a:prstGeom prst="roundRect">
@@ -2731,7 +3321,7 @@
       </p:sp>
       <p:pic>
         <p:nvPicPr>
-          <p:cNvPr id="45" name="Image 3" descr="/home/user/career-ops/2-ct-abdomen.jpeg">    </p:cNvPr>
+          <p:cNvPr id="61" name="Image 3" descr="/home/user/career-ops/2-ct-abdomen.jpeg">    </p:cNvPr>
           <p:cNvPicPr>
             <a:picLocks noChangeAspect="1"/>
           </p:cNvPicPr>
@@ -2745,7 +3335,7 @@
         </p:blipFill>
         <p:spPr>
           <a:xfrm>
-            <a:off x="15687673" y="15534922"/>
+            <a:off x="15687673" y="17074227"/>
             <a:ext cx="5776486" cy="4754880"/>
           </a:xfrm>
           <a:prstGeom prst="rect">
@@ -2755,14 +3345,85 @@
       </p:pic>
       <p:sp>
         <p:nvSpPr>
-          <p:cNvPr id="46" name="Text 40"/>
-          <p:cNvSpPr/>
-          <p:nvPr/>
-        </p:nvSpPr>
-        <p:spPr>
-          <a:xfrm>
-            <a:off x="9882576" y="20463538"/>
-            <a:ext cx="12634848" cy="731520"/>
+          <p:cNvPr id="62" name="Shape 56"/>
+          <p:cNvSpPr/>
+          <p:nvPr/>
+        </p:nvSpPr>
+        <p:spPr>
+          <a:xfrm>
+            <a:off x="15513937" y="16900491"/>
+            <a:ext cx="566928" cy="566928"/>
+          </a:xfrm>
+          <a:prstGeom prst="ellipse">
+            <a:avLst/>
+          </a:prstGeom>
+          <a:solidFill>
+            <a:srgbClr val="2A9D8F"/>
+          </a:solidFill>
+          <a:ln w="25400">
+            <a:solidFill>
+              <a:srgbClr val="FFFFFF"/>
+            </a:solidFill>
+            <a:prstDash val="solid"/>
+          </a:ln>
+          <a:effectLst>
+            <a:outerShdw sx="100000" sy="100000" kx="0" ky="0" algn="bl" rotWithShape="0" blurRad="63500" dist="38100" dir="5400000">
+              <a:srgbClr val="8A8A8A">
+                <a:alpha val="32000"/>
+              </a:srgbClr>
+            </a:outerShdw>
+          </a:effectLst>
+        </p:spPr>
+      </p:sp>
+      <p:sp>
+        <p:nvSpPr>
+          <p:cNvPr id="63" name="Text 57"/>
+          <p:cNvSpPr/>
+          <p:nvPr/>
+        </p:nvSpPr>
+        <p:spPr>
+          <a:xfrm>
+            <a:off x="15513937" y="16900491"/>
+            <a:ext cx="566928" cy="566928"/>
+          </a:xfrm>
+          <a:prstGeom prst="rect">
+            <a:avLst/>
+          </a:prstGeom>
+          <a:noFill/>
+          <a:ln/>
+        </p:spPr>
+        <p:txBody>
+          <a:bodyPr wrap="square" lIns="0" tIns="0" rIns="0" bIns="0" rtlCol="0" anchor="ctr"/>
+          <a:lstStyle/>
+          <a:p>
+            <a:pPr algn="ctr" indent="0" marL="0">
+              <a:buNone/>
+            </a:pPr>
+            <a:r>
+              <a:rPr lang="en-US" sz="2400" b="1" dirty="0">
+                <a:solidFill>
+                  <a:srgbClr val="FFFFFF"/>
+                </a:solidFill>
+                <a:latin typeface="Cambria" pitchFamily="34" charset="0"/>
+                <a:ea typeface="Cambria" pitchFamily="34" charset="-122"/>
+                <a:cs typeface="Cambria" pitchFamily="34" charset="-120"/>
+              </a:rPr>
+              <a:t>3</a:t>
+            </a:r>
+            <a:endParaRPr lang="en-US" sz="2400" dirty="0"/>
+          </a:p>
+        </p:txBody>
+      </p:sp>
+      <p:sp>
+        <p:nvSpPr>
+          <p:cNvPr id="64" name="Text 58"/>
+          <p:cNvSpPr/>
+          <p:nvPr/>
+        </p:nvSpPr>
+        <p:spPr>
+          <a:xfrm>
+            <a:off x="9882576" y="22002843"/>
+            <a:ext cx="12634848" cy="701040"/>
           </a:xfrm>
           <a:prstGeom prst="rect">
             <a:avLst/>
@@ -2778,7 +3439,7 @@
               <a:buNone/>
             </a:pPr>
             <a:r>
-              <a:rPr lang="en-US" sz="2100" b="1" dirty="0">
+              <a:rPr lang="en-US" sz="2000" b="1" dirty="0">
                 <a:solidFill>
                   <a:srgbClr val="12355B"/>
                 </a:solidFill>
@@ -2792,7 +3453,7 @@
               <a:buNone/>
             </a:pPr>
             <a:r>
-              <a:rPr lang="en-US" sz="2100" i="1" dirty="0">
+              <a:rPr lang="en-US" sz="2000" i="1" dirty="0">
                 <a:solidFill>
                   <a:srgbClr val="5B5B5B"/>
                 </a:solidFill>
@@ -2806,7 +3467,7 @@
               <a:buNone/>
             </a:pPr>
             <a:r>
-              <a:rPr lang="en-US" sz="2100" b="1" dirty="0">
+              <a:rPr lang="en-US" sz="2000" b="1" dirty="0">
                 <a:solidFill>
                   <a:srgbClr val="12355B"/>
                 </a:solidFill>
@@ -2820,7 +3481,7 @@
               <a:buNone/>
             </a:pPr>
             <a:r>
-              <a:rPr lang="en-US" sz="2100" i="1" dirty="0">
+              <a:rPr lang="en-US" sz="2000" i="1" dirty="0">
                 <a:solidFill>
                   <a:srgbClr val="5B5B5B"/>
                 </a:solidFill>
@@ -2834,7 +3495,7 @@
               <a:buNone/>
             </a:pPr>
             <a:r>
-              <a:rPr lang="en-US" sz="2100" i="1" dirty="0">
+              <a:rPr lang="en-US" sz="2000" i="1" dirty="0">
                 <a:solidFill>
                   <a:srgbClr val="9AA6B2"/>
                 </a:solidFill>
@@ -2844,19 +3505,19 @@
               </a:rPr>
               <a:t>[Additional Information: CT findings]</a:t>
             </a:r>
-            <a:endParaRPr lang="en-US" sz="2100" dirty="0"/>
-          </a:p>
-        </p:txBody>
-      </p:sp>
-      <p:sp>
-        <p:nvSpPr>
-          <p:cNvPr id="47" name="Shape 41"/>
-          <p:cNvSpPr/>
-          <p:nvPr/>
-        </p:nvSpPr>
-        <p:spPr>
-          <a:xfrm>
-            <a:off x="16026264" y="22732892"/>
+            <a:endParaRPr lang="en-US" sz="2000" dirty="0"/>
+          </a:p>
+        </p:txBody>
+      </p:sp>
+      <p:sp>
+        <p:nvSpPr>
+          <p:cNvPr id="65" name="Shape 59"/>
+          <p:cNvSpPr/>
+          <p:nvPr/>
+        </p:nvSpPr>
+        <p:spPr>
+          <a:xfrm>
+            <a:off x="16026264" y="23150598"/>
             <a:ext cx="347472" cy="393192"/>
           </a:xfrm>
           <a:prstGeom prst="downArrow">
@@ -2870,18 +3531,18 @@
       </p:sp>
       <p:sp>
         <p:nvSpPr>
-          <p:cNvPr id="48" name="Shape 42"/>
-          <p:cNvSpPr/>
-          <p:nvPr/>
-        </p:nvSpPr>
-        <p:spPr>
-          <a:xfrm>
-            <a:off x="9589968" y="23180948"/>
-            <a:ext cx="13220064" cy="7810618"/>
+          <p:cNvPr id="66" name="Shape 60"/>
+          <p:cNvSpPr/>
+          <p:nvPr/>
+        </p:nvSpPr>
+        <p:spPr>
+          <a:xfrm>
+            <a:off x="9589968" y="23598654"/>
+            <a:ext cx="13220064" cy="8188635"/>
           </a:xfrm>
           <a:prstGeom prst="roundRect">
             <a:avLst>
-              <a:gd name="adj" fmla="val 1171"/>
+              <a:gd name="adj" fmla="val 1117"/>
             </a:avLst>
           </a:prstGeom>
           <a:solidFill>
@@ -2904,18 +3565,18 @@
       </p:sp>
       <p:sp>
         <p:nvSpPr>
-          <p:cNvPr id="49" name="Shape 43"/>
-          <p:cNvSpPr/>
-          <p:nvPr/>
-        </p:nvSpPr>
-        <p:spPr>
-          <a:xfrm>
-            <a:off x="9882576" y="24050450"/>
-            <a:ext cx="3313953" cy="6071616"/>
+          <p:cNvPr id="67" name="Shape 61"/>
+          <p:cNvSpPr/>
+          <p:nvPr/>
+        </p:nvSpPr>
+        <p:spPr>
+          <a:xfrm>
+            <a:off x="14371473" y="23872974"/>
+            <a:ext cx="3657054" cy="6711696"/>
           </a:xfrm>
           <a:prstGeom prst="roundRect">
             <a:avLst>
-              <a:gd name="adj" fmla="val 1656"/>
+              <a:gd name="adj" fmla="val 1500"/>
             </a:avLst>
           </a:prstGeom>
           <a:solidFill>
@@ -2938,7 +3599,7 @@
       </p:sp>
       <p:pic>
         <p:nvPicPr>
-          <p:cNvPr id="50" name="Image 4" descr="/home/user/career-ops/5-intraop-perforation.jpeg">    </p:cNvPr>
+          <p:cNvPr id="68" name="Image 4" descr="/home/user/career-ops/5-intraop-perforation.jpeg">    </p:cNvPr>
           <p:cNvPicPr>
             <a:picLocks noChangeAspect="1"/>
           </p:cNvPicPr>
@@ -2952,8 +3613,8 @@
         </p:blipFill>
         <p:spPr>
           <a:xfrm>
-            <a:off x="9946584" y="24114458"/>
-            <a:ext cx="3185937" cy="5943600"/>
+            <a:off x="14435481" y="23936982"/>
+            <a:ext cx="3529038" cy="6583680"/>
           </a:xfrm>
           <a:prstGeom prst="rect">
             <a:avLst/>
@@ -2962,14 +3623,46 @@
       </p:pic>
       <p:sp>
         <p:nvSpPr>
-          <p:cNvPr id="51" name="Text 44"/>
-          <p:cNvSpPr/>
-          <p:nvPr/>
-        </p:nvSpPr>
-        <p:spPr>
-          <a:xfrm>
-            <a:off x="13608009" y="23180948"/>
-            <a:ext cx="8909415" cy="7810618"/>
+          <p:cNvPr id="69" name="Shape 62"/>
+          <p:cNvSpPr/>
+          <p:nvPr/>
+        </p:nvSpPr>
+        <p:spPr>
+          <a:xfrm>
+            <a:off x="14261745" y="23763246"/>
+            <a:ext cx="566928" cy="566928"/>
+          </a:xfrm>
+          <a:prstGeom prst="ellipse">
+            <a:avLst/>
+          </a:prstGeom>
+          <a:solidFill>
+            <a:srgbClr val="2A9D8F"/>
+          </a:solidFill>
+          <a:ln w="25400">
+            <a:solidFill>
+              <a:srgbClr val="FFFFFF"/>
+            </a:solidFill>
+            <a:prstDash val="solid"/>
+          </a:ln>
+          <a:effectLst>
+            <a:outerShdw sx="100000" sy="100000" kx="0" ky="0" algn="bl" rotWithShape="0" blurRad="63500" dist="38100" dir="5400000">
+              <a:srgbClr val="8A8A8A">
+                <a:alpha val="32000"/>
+              </a:srgbClr>
+            </a:outerShdw>
+          </a:effectLst>
+        </p:spPr>
+      </p:sp>
+      <p:sp>
+        <p:nvSpPr>
+          <p:cNvPr id="70" name="Text 63"/>
+          <p:cNvSpPr/>
+          <p:nvPr/>
+        </p:nvSpPr>
+        <p:spPr>
+          <a:xfrm>
+            <a:off x="14261745" y="23763246"/>
+            <a:ext cx="566928" cy="566928"/>
           </a:xfrm>
           <a:prstGeom prst="rect">
             <a:avLst/>
@@ -2981,11 +3674,50 @@
           <a:bodyPr wrap="square" lIns="0" tIns="0" rIns="0" bIns="0" rtlCol="0" anchor="ctr"/>
           <a:lstStyle/>
           <a:p>
+            <a:pPr algn="ctr" indent="0" marL="0">
+              <a:buNone/>
+            </a:pPr>
+            <a:r>
+              <a:rPr lang="en-US" sz="2400" b="1" dirty="0">
+                <a:solidFill>
+                  <a:srgbClr val="FFFFFF"/>
+                </a:solidFill>
+                <a:latin typeface="Cambria" pitchFamily="34" charset="0"/>
+                <a:ea typeface="Cambria" pitchFamily="34" charset="-122"/>
+                <a:cs typeface="Cambria" pitchFamily="34" charset="-120"/>
+              </a:rPr>
+              <a:t>4</a:t>
+            </a:r>
+            <a:endParaRPr lang="en-US" sz="2400" dirty="0"/>
+          </a:p>
+        </p:txBody>
+      </p:sp>
+      <p:sp>
+        <p:nvSpPr>
+          <p:cNvPr id="71" name="Text 64"/>
+          <p:cNvSpPr/>
+          <p:nvPr/>
+        </p:nvSpPr>
+        <p:spPr>
+          <a:xfrm>
+            <a:off x="9882576" y="30694398"/>
+            <a:ext cx="12634848" cy="701040"/>
+          </a:xfrm>
+          <a:prstGeom prst="rect">
+            <a:avLst/>
+          </a:prstGeom>
+          <a:noFill/>
+          <a:ln/>
+        </p:spPr>
+        <p:txBody>
+          <a:bodyPr wrap="square" lIns="0" tIns="0" rIns="0" bIns="0" rtlCol="0" anchor="t"/>
+          <a:lstStyle/>
+          <a:p>
             <a:pPr algn="l" indent="0" marL="0">
               <a:buNone/>
             </a:pPr>
             <a:r>
-              <a:rPr lang="en-US" sz="2100" b="1" dirty="0">
+              <a:rPr lang="en-US" sz="2000" b="1" dirty="0">
                 <a:solidFill>
                   <a:srgbClr val="12355B"/>
                 </a:solidFill>
@@ -2999,7 +3731,7 @@
               <a:buNone/>
             </a:pPr>
             <a:r>
-              <a:rPr lang="en-US" sz="2100" i="1" dirty="0">
+              <a:rPr lang="en-US" sz="2000" i="1" dirty="0">
                 <a:solidFill>
                   <a:srgbClr val="5B5B5B"/>
                 </a:solidFill>
@@ -3009,19 +3741,19 @@
               </a:rPr>
               <a:t>Intraoperative photograph showing the solitary ileal perforation (≈ 0.5 × 0.5 cm), located 40 cm proximal to the ileocaecal junction.</a:t>
             </a:r>
-            <a:endParaRPr lang="en-US" sz="2100" dirty="0"/>
-          </a:p>
-        </p:txBody>
-      </p:sp>
-      <p:sp>
-        <p:nvSpPr>
-          <p:cNvPr id="52" name="Shape 45"/>
-          <p:cNvSpPr/>
-          <p:nvPr/>
-        </p:nvSpPr>
-        <p:spPr>
-          <a:xfrm>
-            <a:off x="16026264" y="31046431"/>
+            <a:endParaRPr lang="en-US" sz="2000" dirty="0"/>
+          </a:p>
+        </p:txBody>
+      </p:sp>
+      <p:sp>
+        <p:nvSpPr>
+          <p:cNvPr id="72" name="Shape 65"/>
+          <p:cNvSpPr/>
+          <p:nvPr/>
+        </p:nvSpPr>
+        <p:spPr>
+          <a:xfrm>
+            <a:off x="16026264" y="31842153"/>
             <a:ext cx="347472" cy="393192"/>
           </a:xfrm>
           <a:prstGeom prst="downArrow">
@@ -3035,18 +3767,18 @@
       </p:sp>
       <p:sp>
         <p:nvSpPr>
-          <p:cNvPr id="53" name="Shape 46"/>
-          <p:cNvSpPr/>
-          <p:nvPr/>
-        </p:nvSpPr>
-        <p:spPr>
-          <a:xfrm>
-            <a:off x="9589968" y="31494487"/>
-            <a:ext cx="13220064" cy="9796793"/>
+          <p:cNvPr id="73" name="Shape 66"/>
+          <p:cNvSpPr/>
+          <p:nvPr/>
+        </p:nvSpPr>
+        <p:spPr>
+          <a:xfrm>
+            <a:off x="9589968" y="32290209"/>
+            <a:ext cx="13220064" cy="9001071"/>
           </a:xfrm>
           <a:prstGeom prst="roundRect">
             <a:avLst>
-              <a:gd name="adj" fmla="val 933"/>
+              <a:gd name="adj" fmla="val 1016"/>
             </a:avLst>
           </a:prstGeom>
           <a:solidFill>
@@ -3069,18 +3801,18 @@
       </p:sp>
       <p:sp>
         <p:nvSpPr>
-          <p:cNvPr id="54" name="Shape 47"/>
-          <p:cNvSpPr/>
-          <p:nvPr/>
-        </p:nvSpPr>
-        <p:spPr>
-          <a:xfrm>
-            <a:off x="10184328" y="31768807"/>
-            <a:ext cx="12031344" cy="7198255"/>
+          <p:cNvPr id="74" name="Shape 67"/>
+          <p:cNvSpPr/>
+          <p:nvPr/>
+        </p:nvSpPr>
+        <p:spPr>
+          <a:xfrm>
+            <a:off x="9910008" y="32564529"/>
+            <a:ext cx="12579984" cy="7524132"/>
           </a:xfrm>
           <a:prstGeom prst="roundRect">
             <a:avLst>
-              <a:gd name="adj" fmla="val 762"/>
+              <a:gd name="adj" fmla="val 729"/>
             </a:avLst>
           </a:prstGeom>
           <a:solidFill>
@@ -3103,7 +3835,7 @@
       </p:sp>
       <p:pic>
         <p:nvPicPr>
-          <p:cNvPr id="55" name="Image 5" descr="/home/user/career-ops/3-histopath-idc.jpeg">    </p:cNvPr>
+          <p:cNvPr id="75" name="Image 5" descr="/home/user/career-ops/3-histopath-idc.jpeg">    </p:cNvPr>
           <p:cNvPicPr>
             <a:picLocks noChangeAspect="1"/>
           </p:cNvPicPr>
@@ -3117,8 +3849,8 @@
         </p:blipFill>
         <p:spPr>
           <a:xfrm>
-            <a:off x="10248336" y="31832815"/>
-            <a:ext cx="11903328" cy="7070239"/>
+            <a:off x="9974016" y="32628537"/>
+            <a:ext cx="12451968" cy="7396116"/>
           </a:xfrm>
           <a:prstGeom prst="rect">
             <a:avLst/>
@@ -3127,14 +3859,85 @@
       </p:pic>
       <p:sp>
         <p:nvSpPr>
-          <p:cNvPr id="56" name="Text 48"/>
-          <p:cNvSpPr/>
-          <p:nvPr/>
-        </p:nvSpPr>
-        <p:spPr>
-          <a:xfrm>
-            <a:off x="9882576" y="39076790"/>
-            <a:ext cx="12634848" cy="731520"/>
+          <p:cNvPr id="76" name="Shape 68"/>
+          <p:cNvSpPr/>
+          <p:nvPr/>
+        </p:nvSpPr>
+        <p:spPr>
+          <a:xfrm>
+            <a:off x="9800280" y="32454801"/>
+            <a:ext cx="566928" cy="566928"/>
+          </a:xfrm>
+          <a:prstGeom prst="ellipse">
+            <a:avLst/>
+          </a:prstGeom>
+          <a:solidFill>
+            <a:srgbClr val="2A9D8F"/>
+          </a:solidFill>
+          <a:ln w="25400">
+            <a:solidFill>
+              <a:srgbClr val="FFFFFF"/>
+            </a:solidFill>
+            <a:prstDash val="solid"/>
+          </a:ln>
+          <a:effectLst>
+            <a:outerShdw sx="100000" sy="100000" kx="0" ky="0" algn="bl" rotWithShape="0" blurRad="63500" dist="38100" dir="5400000">
+              <a:srgbClr val="8A8A8A">
+                <a:alpha val="32000"/>
+              </a:srgbClr>
+            </a:outerShdw>
+          </a:effectLst>
+        </p:spPr>
+      </p:sp>
+      <p:sp>
+        <p:nvSpPr>
+          <p:cNvPr id="77" name="Text 69"/>
+          <p:cNvSpPr/>
+          <p:nvPr/>
+        </p:nvSpPr>
+        <p:spPr>
+          <a:xfrm>
+            <a:off x="9800280" y="32454801"/>
+            <a:ext cx="566928" cy="566928"/>
+          </a:xfrm>
+          <a:prstGeom prst="rect">
+            <a:avLst/>
+          </a:prstGeom>
+          <a:noFill/>
+          <a:ln/>
+        </p:spPr>
+        <p:txBody>
+          <a:bodyPr wrap="square" lIns="0" tIns="0" rIns="0" bIns="0" rtlCol="0" anchor="ctr"/>
+          <a:lstStyle/>
+          <a:p>
+            <a:pPr algn="ctr" indent="0" marL="0">
+              <a:buNone/>
+            </a:pPr>
+            <a:r>
+              <a:rPr lang="en-US" sz="2400" b="1" dirty="0">
+                <a:solidFill>
+                  <a:srgbClr val="FFFFFF"/>
+                </a:solidFill>
+                <a:latin typeface="Cambria" pitchFamily="34" charset="0"/>
+                <a:ea typeface="Cambria" pitchFamily="34" charset="-122"/>
+                <a:cs typeface="Cambria" pitchFamily="34" charset="-120"/>
+              </a:rPr>
+              <a:t>5</a:t>
+            </a:r>
+            <a:endParaRPr lang="en-US" sz="2400" dirty="0"/>
+          </a:p>
+        </p:txBody>
+      </p:sp>
+      <p:sp>
+        <p:nvSpPr>
+          <p:cNvPr id="78" name="Text 70"/>
+          <p:cNvSpPr/>
+          <p:nvPr/>
+        </p:nvSpPr>
+        <p:spPr>
+          <a:xfrm>
+            <a:off x="9882576" y="40198389"/>
+            <a:ext cx="12634848" cy="701040"/>
           </a:xfrm>
           <a:prstGeom prst="rect">
             <a:avLst/>
@@ -3150,7 +3953,7 @@
               <a:buNone/>
             </a:pPr>
             <a:r>
-              <a:rPr lang="en-US" sz="2100" b="1" dirty="0">
+              <a:rPr lang="en-US" sz="2000" b="1" dirty="0">
                 <a:solidFill>
                   <a:srgbClr val="12355B"/>
                 </a:solidFill>
@@ -3164,7 +3967,7 @@
               <a:buNone/>
             </a:pPr>
             <a:r>
-              <a:rPr lang="en-US" sz="2100" i="1" dirty="0">
+              <a:rPr lang="en-US" sz="2000" i="1" dirty="0">
                 <a:solidFill>
                   <a:srgbClr val="5B5B5B"/>
                 </a:solidFill>
@@ -3174,13 +3977,13 @@
               </a:rPr>
               <a:t>Histopathology (H&amp;E) — invasive ductal carcinoma; metastatic deposits demonstrated at the ileal perforation site.</a:t>
             </a:r>
-            <a:endParaRPr lang="en-US" sz="2100" dirty="0"/>
-          </a:p>
-        </p:txBody>
-      </p:sp>
-      <p:sp>
-        <p:nvSpPr>
-          <p:cNvPr id="57" name="Shape 49"/>
+            <a:endParaRPr lang="en-US" sz="2000" dirty="0"/>
+          </a:p>
+        </p:txBody>
+      </p:sp>
+      <p:sp>
+        <p:nvSpPr>
+          <p:cNvPr id="79" name="Shape 71"/>
           <p:cNvSpPr/>
           <p:nvPr/>
         </p:nvSpPr>
@@ -3202,7 +4005,7 @@
       </p:sp>
       <p:sp>
         <p:nvSpPr>
-          <p:cNvPr id="58" name="Text 50"/>
+          <p:cNvPr id="80" name="Text 72"/>
           <p:cNvSpPr/>
           <p:nvPr/>
         </p:nvSpPr>
@@ -3255,7 +4058,7 @@
       </p:sp>
       <p:sp>
         <p:nvSpPr>
-          <p:cNvPr id="59" name="Text 51"/>
+          <p:cNvPr id="81" name="Text 73"/>
           <p:cNvSpPr/>
           <p:nvPr/>
         </p:nvSpPr>

</xml_diff>

<commit_message>
Poster: add verified references, sourced epidemiology line, differential diagnosis
- Key References: four verified, correctly-cited papers (McLemore 2005; Ambroggi 2012;
  Li 2022; Shen 2024) on GI/small-bowel metastasis from breast carcinoma
- Background: add a sourced epidemiology sentence (typical metastatic sites; GI spread
  rarer and more often lobular than ductal) with citation markers
- Add a Differential Diagnosis section (NSAID ulcer, infective enteritis, TB, primary
  small-bowel malignancy, metastatic malignancy)
- Adjust body type to 33pt so the expanded content fits both side columns to the footer

Co-Authored-By: Claude Opus 4.8 <noreply@anthropic.com>
Claude-Session: https://claude.ai/code/session_01Hys1rt1JVnsf8msS2XZJ53
</commit_message>
<xml_diff>
--- a/TNASICON2026-Poster-Metastatic-Ileal-Perforation.pptx
+++ b/TNASICON2026-Poster-Metastatic-Ileal-Perforation.pptx
@@ -1641,7 +1641,7 @@
         </p:nvSpPr>
         <p:spPr>
           <a:xfrm>
-            <a:off x="720000" y="11902788"/>
+            <a:off x="720000" y="7568856"/>
             <a:ext cx="310896" cy="310896"/>
           </a:xfrm>
           <a:prstGeom prst="ellipse">
@@ -1661,7 +1661,7 @@
         </p:nvSpPr>
         <p:spPr>
           <a:xfrm>
-            <a:off x="1213776" y="11793060"/>
+            <a:off x="1213776" y="7459128"/>
             <a:ext cx="7918992" cy="603504"/>
           </a:xfrm>
           <a:prstGeom prst="rect">
@@ -1678,7 +1678,7 @@
               <a:buNone/>
             </a:pPr>
             <a:r>
-              <a:rPr lang="en-US" sz="3900" b="1" dirty="0">
+              <a:rPr lang="en-US" sz="3700" b="1" dirty="0">
                 <a:solidFill>
                   <a:srgbClr val="12355B"/>
                 </a:solidFill>
@@ -1688,7 +1688,7 @@
               </a:rPr>
               <a:t>Background</a:t>
             </a:r>
-            <a:endParaRPr lang="en-US" sz="3900" dirty="0"/>
+            <a:endParaRPr lang="en-US" sz="3700" dirty="0"/>
           </a:p>
         </p:txBody>
       </p:sp>
@@ -1700,8 +1700,8 @@
         </p:nvSpPr>
         <p:spPr>
           <a:xfrm>
-            <a:off x="756576" y="12542868"/>
-            <a:ext cx="8339616" cy="5541264"/>
+            <a:off x="756576" y="8208936"/>
+            <a:ext cx="8339616" cy="7644384"/>
           </a:xfrm>
           <a:prstGeom prst="rect">
             <a:avLst/>
@@ -1721,7 +1721,7 @@
               <a:buChar char="•"/>
             </a:pPr>
             <a:r>
-              <a:rPr lang="en-US" sz="3600" dirty="0">
+              <a:rPr lang="en-US" sz="3300" dirty="0">
                 <a:solidFill>
                   <a:srgbClr val="333333"/>
                 </a:solidFill>
@@ -1729,9 +1729,9 @@
                 <a:ea typeface="Calibri" pitchFamily="34" charset="-122"/>
                 <a:cs typeface="Calibri" pitchFamily="34" charset="-120"/>
               </a:rPr>
-              <a:t>Intestinal metastasis from breast carcinoma is uncommon.</a:t>
-            </a:r>
-            <a:endParaRPr lang="en-US" sz="3600" dirty="0"/>
+              <a:t>Breast carcinoma most often metastasises to bone, liver and lung; gastrointestinal spread is rare and arises far more often from lobular than from ductal carcinoma. [1, 2]</a:t>
+            </a:r>
+            <a:endParaRPr lang="en-US" sz="3300" dirty="0"/>
           </a:p>
           <a:p>
             <a:pPr algn="l" marL="228600" indent="-228600">
@@ -1742,7 +1742,7 @@
               <a:buChar char="•"/>
             </a:pPr>
             <a:r>
-              <a:rPr lang="en-US" sz="3600" dirty="0">
+              <a:rPr lang="en-US" sz="3300" dirty="0">
                 <a:solidFill>
                   <a:srgbClr val="333333"/>
                 </a:solidFill>
@@ -1750,9 +1750,9 @@
                 <a:ea typeface="Calibri" pitchFamily="34" charset="-122"/>
                 <a:cs typeface="Calibri" pitchFamily="34" charset="-120"/>
               </a:rPr>
-              <a:t>Perforation as the initial manifestation is exceedingly rare.</a:t>
-            </a:r>
-            <a:endParaRPr lang="en-US" sz="3600" dirty="0"/>
+              <a:t>Intestinal metastasis from breast carcinoma is uncommon, and perforation as the initial manifestation is exceedingly rare.</a:t>
+            </a:r>
+            <a:endParaRPr lang="en-US" sz="3300" dirty="0"/>
           </a:p>
           <a:p>
             <a:pPr algn="l" marL="228600" indent="-228600">
@@ -1763,7 +1763,7 @@
               <a:buChar char="•"/>
             </a:pPr>
             <a:r>
-              <a:rPr lang="en-US" sz="3600" dirty="0">
+              <a:rPr lang="en-US" sz="3300" dirty="0">
                 <a:solidFill>
                   <a:srgbClr val="333333"/>
                 </a:solidFill>
@@ -1771,9 +1771,9 @@
                 <a:ea typeface="Calibri" pitchFamily="34" charset="-122"/>
                 <a:cs typeface="Calibri" pitchFamily="34" charset="-120"/>
               </a:rPr>
-              <a:t>Only a limited number of similar cases have been reported.</a:t>
-            </a:r>
-            <a:endParaRPr lang="en-US" sz="3600" dirty="0"/>
+              <a:t>Only a limited number of similar cases have been reported. [3, 4]</a:t>
+            </a:r>
+            <a:endParaRPr lang="en-US" sz="3300" dirty="0"/>
           </a:p>
           <a:p>
             <a:pPr algn="l" marL="228600" indent="-228600">
@@ -1784,7 +1784,7 @@
               <a:buChar char="•"/>
             </a:pPr>
             <a:r>
-              <a:rPr lang="en-US" sz="3600" dirty="0">
+              <a:rPr lang="en-US" sz="3300" dirty="0">
                 <a:solidFill>
                   <a:srgbClr val="333333"/>
                 </a:solidFill>
@@ -1794,7 +1794,7 @@
               </a:rPr>
               <a:t>An acute surgical abdomen may represent the first presentation of metastatic malignancy.</a:t>
             </a:r>
-            <a:endParaRPr lang="en-US" sz="3600" dirty="0"/>
+            <a:endParaRPr lang="en-US" sz="3300" dirty="0"/>
           </a:p>
         </p:txBody>
       </p:sp>
@@ -1806,7 +1806,7 @@
         </p:nvSpPr>
         <p:spPr>
           <a:xfrm>
-            <a:off x="720000" y="19638612"/>
+            <a:off x="720000" y="17672814"/>
             <a:ext cx="310896" cy="310896"/>
           </a:xfrm>
           <a:prstGeom prst="ellipse">
@@ -1826,7 +1826,7 @@
         </p:nvSpPr>
         <p:spPr>
           <a:xfrm>
-            <a:off x="1213776" y="19528884"/>
+            <a:off x="1213776" y="17563086"/>
             <a:ext cx="7918992" cy="603504"/>
           </a:xfrm>
           <a:prstGeom prst="rect">
@@ -1843,7 +1843,7 @@
               <a:buNone/>
             </a:pPr>
             <a:r>
-              <a:rPr lang="en-US" sz="3900" b="1" dirty="0">
+              <a:rPr lang="en-US" sz="3700" b="1" dirty="0">
                 <a:solidFill>
                   <a:srgbClr val="12355B"/>
                 </a:solidFill>
@@ -1853,7 +1853,7 @@
               </a:rPr>
               <a:t>Case Presentation</a:t>
             </a:r>
-            <a:endParaRPr lang="en-US" sz="3900" dirty="0"/>
+            <a:endParaRPr lang="en-US" sz="3700" dirty="0"/>
           </a:p>
         </p:txBody>
       </p:sp>
@@ -1865,8 +1865,8 @@
         </p:nvSpPr>
         <p:spPr>
           <a:xfrm>
-            <a:off x="756576" y="20278692"/>
-            <a:ext cx="8339616" cy="4892040"/>
+            <a:off x="756576" y="18312894"/>
+            <a:ext cx="8339616" cy="4526280"/>
           </a:xfrm>
           <a:prstGeom prst="rect">
             <a:avLst/>
@@ -1886,7 +1886,7 @@
               <a:buChar char="•"/>
             </a:pPr>
             <a:r>
-              <a:rPr lang="en-US" sz="3600" b="1" dirty="0">
+              <a:rPr lang="en-US" sz="3300" b="1" dirty="0">
                 <a:solidFill>
                   <a:srgbClr val="12355B"/>
                 </a:solidFill>
@@ -1896,7 +1896,7 @@
               </a:rPr>
               <a:t>38-year-old woman with abdominal pain for two days.</a:t>
             </a:r>
-            <a:endParaRPr lang="en-US" sz="3600" dirty="0"/>
+            <a:endParaRPr lang="en-US" sz="3300" dirty="0"/>
           </a:p>
           <a:p>
             <a:pPr algn="l" marL="228600" indent="-228600">
@@ -1907,7 +1907,7 @@
               <a:buChar char="•"/>
             </a:pPr>
             <a:r>
-              <a:rPr lang="en-US" sz="3600" dirty="0">
+              <a:rPr lang="en-US" sz="3300" dirty="0">
                 <a:solidFill>
                   <a:srgbClr val="333333"/>
                 </a:solidFill>
@@ -1917,7 +1917,7 @@
               </a:rPr>
               <a:t>History of chronic NSAID abuse for pain related to a right breast lump, which had been misdiagnosed as a breast abscess.</a:t>
             </a:r>
-            <a:endParaRPr lang="en-US" sz="3600" dirty="0"/>
+            <a:endParaRPr lang="en-US" sz="3300" dirty="0"/>
           </a:p>
           <a:p>
             <a:pPr algn="l" marL="228600" indent="-228600">
@@ -1928,7 +1928,7 @@
               <a:buChar char="•"/>
             </a:pPr>
             <a:r>
-              <a:rPr lang="en-US" sz="3600" dirty="0">
+              <a:rPr lang="en-US" sz="3300" dirty="0">
                 <a:solidFill>
                   <a:srgbClr val="333333"/>
                 </a:solidFill>
@@ -1938,7 +1938,7 @@
               </a:rPr>
               <a:t>On examination: tachycardic, with generalized abdominal rigidity.</a:t>
             </a:r>
-            <a:endParaRPr lang="en-US" sz="3600" dirty="0"/>
+            <a:endParaRPr lang="en-US" sz="3300" dirty="0"/>
           </a:p>
         </p:txBody>
       </p:sp>
@@ -1950,7 +1950,7 @@
         </p:nvSpPr>
         <p:spPr>
           <a:xfrm>
-            <a:off x="720000" y="26725212"/>
+            <a:off x="720000" y="24658668"/>
             <a:ext cx="310896" cy="310896"/>
           </a:xfrm>
           <a:prstGeom prst="ellipse">
@@ -1970,7 +1970,7 @@
         </p:nvSpPr>
         <p:spPr>
           <a:xfrm>
-            <a:off x="1213776" y="26615484"/>
+            <a:off x="1213776" y="24548940"/>
             <a:ext cx="7918992" cy="603504"/>
           </a:xfrm>
           <a:prstGeom prst="rect">
@@ -1987,7 +1987,7 @@
               <a:buNone/>
             </a:pPr>
             <a:r>
-              <a:rPr lang="en-US" sz="3900" b="1" dirty="0">
+              <a:rPr lang="en-US" sz="3700" b="1" dirty="0">
                 <a:solidFill>
                   <a:srgbClr val="12355B"/>
                 </a:solidFill>
@@ -1997,7 +1997,7 @@
               </a:rPr>
               <a:t>Investigations</a:t>
             </a:r>
-            <a:endParaRPr lang="en-US" sz="3900" dirty="0"/>
+            <a:endParaRPr lang="en-US" sz="3700" dirty="0"/>
           </a:p>
         </p:txBody>
       </p:sp>
@@ -2009,8 +2009,8 @@
         </p:nvSpPr>
         <p:spPr>
           <a:xfrm>
-            <a:off x="756576" y="27365292"/>
-            <a:ext cx="8339616" cy="2596896"/>
+            <a:off x="756576" y="25298748"/>
+            <a:ext cx="8339616" cy="2414016"/>
           </a:xfrm>
           <a:prstGeom prst="rect">
             <a:avLst/>
@@ -2030,7 +2030,7 @@
               <a:buChar char="•"/>
             </a:pPr>
             <a:r>
-              <a:rPr lang="en-US" sz="3600" b="1" dirty="0">
+              <a:rPr lang="en-US" sz="3300" b="1" dirty="0">
                 <a:solidFill>
                   <a:srgbClr val="12355B"/>
                 </a:solidFill>
@@ -2040,7 +2040,7 @@
               </a:rPr>
               <a:t>Erect abdominal radiograph demonstrated pneumoperitoneum.</a:t>
             </a:r>
-            <a:endParaRPr lang="en-US" sz="3600" dirty="0"/>
+            <a:endParaRPr lang="en-US" sz="3300" dirty="0"/>
           </a:p>
           <a:p>
             <a:pPr algn="l" marL="228600" indent="-228600">
@@ -2051,7 +2051,7 @@
               <a:buChar char="•"/>
             </a:pPr>
             <a:r>
-              <a:rPr lang="en-US" sz="3600" dirty="0">
+              <a:rPr lang="en-US" sz="3300" dirty="0">
                 <a:solidFill>
                   <a:srgbClr val="333333"/>
                 </a:solidFill>
@@ -2061,7 +2061,7 @@
               </a:rPr>
               <a:t>Findings prompted emergency exploratory laparotomy (see Figs 2–3).</a:t>
             </a:r>
-            <a:endParaRPr lang="en-US" sz="3600" dirty="0"/>
+            <a:endParaRPr lang="en-US" sz="3300" dirty="0"/>
           </a:p>
         </p:txBody>
       </p:sp>
@@ -2073,7 +2073,7 @@
         </p:nvSpPr>
         <p:spPr>
           <a:xfrm>
-            <a:off x="720000" y="31516668"/>
+            <a:off x="720000" y="29532258"/>
             <a:ext cx="310896" cy="310896"/>
           </a:xfrm>
           <a:prstGeom prst="ellipse">
@@ -2093,7 +2093,7 @@
         </p:nvSpPr>
         <p:spPr>
           <a:xfrm>
-            <a:off x="1213776" y="31406940"/>
+            <a:off x="1213776" y="29422530"/>
             <a:ext cx="7918992" cy="603504"/>
           </a:xfrm>
           <a:prstGeom prst="rect">
@@ -2110,7 +2110,7 @@
               <a:buNone/>
             </a:pPr>
             <a:r>
-              <a:rPr lang="en-US" sz="3900" b="1" dirty="0">
+              <a:rPr lang="en-US" sz="3700" b="1" dirty="0">
                 <a:solidFill>
                   <a:srgbClr val="12355B"/>
                 </a:solidFill>
@@ -2118,9 +2118,9 @@
                 <a:ea typeface="Cambria" pitchFamily="34" charset="-122"/>
                 <a:cs typeface="Cambria" pitchFamily="34" charset="-120"/>
               </a:rPr>
-              <a:t>Operative Findings</a:t>
-            </a:r>
-            <a:endParaRPr lang="en-US" sz="3900" dirty="0"/>
+              <a:t>Differential Diagnosis</a:t>
+            </a:r>
+            <a:endParaRPr lang="en-US" sz="3700" dirty="0"/>
           </a:p>
         </p:txBody>
       </p:sp>
@@ -2132,8 +2132,8 @@
         </p:nvSpPr>
         <p:spPr>
           <a:xfrm>
-            <a:off x="756576" y="32156748"/>
-            <a:ext cx="8339616" cy="4892040"/>
+            <a:off x="756576" y="30172338"/>
+            <a:ext cx="8339616" cy="4224528"/>
           </a:xfrm>
           <a:prstGeom prst="rect">
             <a:avLst/>
@@ -2153,7 +2153,7 @@
               <a:buChar char="•"/>
             </a:pPr>
             <a:r>
-              <a:rPr lang="en-US" sz="3600" dirty="0">
+              <a:rPr lang="en-US" sz="3300" dirty="0">
                 <a:solidFill>
                   <a:srgbClr val="333333"/>
                 </a:solidFill>
@@ -2161,9 +2161,9 @@
                 <a:ea typeface="Calibri" pitchFamily="34" charset="-122"/>
                 <a:cs typeface="Calibri" pitchFamily="34" charset="-120"/>
               </a:rPr>
-              <a:t>Emergency exploratory laparotomy performed.</a:t>
-            </a:r>
-            <a:endParaRPr lang="en-US" sz="3600" dirty="0"/>
+              <a:t>NSAID-induced ulcer perforation</a:t>
+            </a:r>
+            <a:endParaRPr lang="en-US" sz="3300" dirty="0"/>
           </a:p>
           <a:p>
             <a:pPr algn="l" marL="228600" indent="-228600">
@@ -2174,17 +2174,17 @@
               <a:buChar char="•"/>
             </a:pPr>
             <a:r>
-              <a:rPr lang="en-US" sz="3600" b="1" dirty="0">
-                <a:solidFill>
-                  <a:srgbClr val="12355B"/>
-                </a:solidFill>
-                <a:latin typeface="Calibri" pitchFamily="34" charset="0"/>
-                <a:ea typeface="Calibri" pitchFamily="34" charset="-122"/>
-                <a:cs typeface="Calibri" pitchFamily="34" charset="-120"/>
-              </a:rPr>
-              <a:t>Solitary ileal perforation ≈ 0.5 × 0.5 cm, located 40 cm proximal to the ileocaecal junction.</a:t>
-            </a:r>
-            <a:endParaRPr lang="en-US" sz="3600" dirty="0"/>
+              <a:rPr lang="en-US" sz="3300" dirty="0">
+                <a:solidFill>
+                  <a:srgbClr val="333333"/>
+                </a:solidFill>
+                <a:latin typeface="Calibri" pitchFamily="34" charset="0"/>
+                <a:ea typeface="Calibri" pitchFamily="34" charset="-122"/>
+                <a:cs typeface="Calibri" pitchFamily="34" charset="-120"/>
+              </a:rPr>
+              <a:t>Infective enteritis (e.g., enteric fever)</a:t>
+            </a:r>
+            <a:endParaRPr lang="en-US" sz="3300" dirty="0"/>
           </a:p>
           <a:p>
             <a:pPr algn="l" marL="228600" indent="-228600">
@@ -2195,7 +2195,7 @@
               <a:buChar char="•"/>
             </a:pPr>
             <a:r>
-              <a:rPr lang="en-US" sz="3600" dirty="0">
+              <a:rPr lang="en-US" sz="3300" dirty="0">
                 <a:solidFill>
                   <a:srgbClr val="333333"/>
                 </a:solidFill>
@@ -2203,91 +2203,10 @@
                 <a:ea typeface="Calibri" pitchFamily="34" charset="-122"/>
                 <a:cs typeface="Calibri" pitchFamily="34" charset="-120"/>
               </a:rPr>
-              <a:t>Primary closure of the perforation performed after obtaining a biopsy from the perforation margin.</a:t>
-            </a:r>
-            <a:endParaRPr lang="en-US" sz="3600" dirty="0"/>
-          </a:p>
-        </p:txBody>
-      </p:sp>
-      <p:sp>
-        <p:nvSpPr>
-          <p:cNvPr id="32" name="Shape 29"/>
-          <p:cNvSpPr/>
-          <p:nvPr/>
-        </p:nvSpPr>
-        <p:spPr>
-          <a:xfrm>
-            <a:off x="23267232" y="7568856"/>
-            <a:ext cx="310896" cy="310896"/>
-          </a:xfrm>
-          <a:prstGeom prst="ellipse">
-            <a:avLst/>
-          </a:prstGeom>
-          <a:solidFill>
-            <a:srgbClr val="2A9D8F"/>
-          </a:solidFill>
-          <a:ln/>
-        </p:spPr>
-      </p:sp>
-      <p:sp>
-        <p:nvSpPr>
-          <p:cNvPr id="33" name="Text 30"/>
-          <p:cNvSpPr/>
-          <p:nvPr/>
-        </p:nvSpPr>
-        <p:spPr>
-          <a:xfrm>
-            <a:off x="23761008" y="7459128"/>
-            <a:ext cx="7918992" cy="603504"/>
-          </a:xfrm>
-          <a:prstGeom prst="rect">
-            <a:avLst/>
-          </a:prstGeom>
-          <a:noFill/>
-          <a:ln/>
-        </p:spPr>
-        <p:txBody>
-          <a:bodyPr wrap="square" lIns="0" tIns="0" rIns="0" bIns="0" rtlCol="0" anchor="ctr"/>
-          <a:lstStyle/>
-          <a:p>
-            <a:pPr algn="l" indent="0" marL="0">
-              <a:buNone/>
-            </a:pPr>
-            <a:r>
-              <a:rPr lang="en-US" sz="3900" b="1" dirty="0">
-                <a:solidFill>
-                  <a:srgbClr val="12355B"/>
-                </a:solidFill>
-                <a:latin typeface="Cambria" pitchFamily="34" charset="0"/>
-                <a:ea typeface="Cambria" pitchFamily="34" charset="-122"/>
-                <a:cs typeface="Cambria" pitchFamily="34" charset="-120"/>
-              </a:rPr>
-              <a:t>Histopathology</a:t>
-            </a:r>
-            <a:endParaRPr lang="en-US" sz="3900" dirty="0"/>
-          </a:p>
-        </p:txBody>
-      </p:sp>
-      <p:sp>
-        <p:nvSpPr>
-          <p:cNvPr id="34" name="Text 31"/>
-          <p:cNvSpPr/>
-          <p:nvPr/>
-        </p:nvSpPr>
-        <p:spPr>
-          <a:xfrm>
-            <a:off x="23303808" y="8208936"/>
-            <a:ext cx="8339616" cy="3694176"/>
-          </a:xfrm>
-          <a:prstGeom prst="rect">
-            <a:avLst/>
-          </a:prstGeom>
-          <a:noFill/>
-          <a:ln/>
-        </p:spPr>
-        <p:txBody>
-          <a:bodyPr wrap="square" lIns="0" tIns="0" rIns="0" bIns="0" rtlCol="0" anchor="t"/>
-          <a:lstStyle/>
+              <a:t>Intestinal tuberculosis</a:t>
+            </a:r>
+            <a:endParaRPr lang="en-US" sz="3300" dirty="0"/>
+          </a:p>
           <a:p>
             <a:pPr algn="l" marL="228600" indent="-228600">
               <a:spcAft>
@@ -2297,17 +2216,17 @@
               <a:buChar char="•"/>
             </a:pPr>
             <a:r>
-              <a:rPr lang="en-US" sz="3600" b="1" dirty="0">
-                <a:solidFill>
-                  <a:srgbClr val="12355B"/>
-                </a:solidFill>
-                <a:latin typeface="Calibri" pitchFamily="34" charset="0"/>
-                <a:ea typeface="Calibri" pitchFamily="34" charset="-122"/>
-                <a:cs typeface="Calibri" pitchFamily="34" charset="-120"/>
-              </a:rPr>
-              <a:t>Trucut biopsy of the breast lump confirmed invasive ductal carcinoma.</a:t>
-            </a:r>
-            <a:endParaRPr lang="en-US" sz="3600" dirty="0"/>
+              <a:rPr lang="en-US" sz="3300" dirty="0">
+                <a:solidFill>
+                  <a:srgbClr val="333333"/>
+                </a:solidFill>
+                <a:latin typeface="Calibri" pitchFamily="34" charset="0"/>
+                <a:ea typeface="Calibri" pitchFamily="34" charset="-122"/>
+                <a:cs typeface="Calibri" pitchFamily="34" charset="-120"/>
+              </a:rPr>
+              <a:t>Primary small-bowel malignancy</a:t>
+            </a:r>
+            <a:endParaRPr lang="en-US" sz="3300" dirty="0"/>
           </a:p>
           <a:p>
             <a:pPr algn="l" marL="228600" indent="-228600">
@@ -2318,7 +2237,7 @@
               <a:buChar char="•"/>
             </a:pPr>
             <a:r>
-              <a:rPr lang="en-US" sz="3600" b="1" dirty="0">
+              <a:rPr lang="en-US" sz="3300" b="1" dirty="0">
                 <a:solidFill>
                   <a:srgbClr val="12355B"/>
                 </a:solidFill>
@@ -2326,21 +2245,21 @@
                 <a:ea typeface="Calibri" pitchFamily="34" charset="-122"/>
                 <a:cs typeface="Calibri" pitchFamily="34" charset="-120"/>
               </a:rPr>
-              <a:t>Histopathology of the ileal biopsy demonstrated metastatic deposits at the perforation site.</a:t>
-            </a:r>
-            <a:endParaRPr lang="en-US" sz="3600" dirty="0"/>
-          </a:p>
-        </p:txBody>
-      </p:sp>
-      <p:sp>
-        <p:nvSpPr>
-          <p:cNvPr id="35" name="Shape 32"/>
-          <p:cNvSpPr/>
-          <p:nvPr/>
-        </p:nvSpPr>
-        <p:spPr>
-          <a:xfrm>
-            <a:off x="23267232" y="12999018"/>
+              <a:t>Metastatic malignancy — confirmed in this case</a:t>
+            </a:r>
+            <a:endParaRPr lang="en-US" sz="3300" dirty="0"/>
+          </a:p>
+        </p:txBody>
+      </p:sp>
+      <p:sp>
+        <p:nvSpPr>
+          <p:cNvPr id="32" name="Shape 29"/>
+          <p:cNvSpPr/>
+          <p:nvPr/>
+        </p:nvSpPr>
+        <p:spPr>
+          <a:xfrm>
+            <a:off x="720000" y="36216360"/>
             <a:ext cx="310896" cy="310896"/>
           </a:xfrm>
           <a:prstGeom prst="ellipse">
@@ -2354,13 +2273,13 @@
       </p:sp>
       <p:sp>
         <p:nvSpPr>
-          <p:cNvPr id="36" name="Text 33"/>
-          <p:cNvSpPr/>
-          <p:nvPr/>
-        </p:nvSpPr>
-        <p:spPr>
-          <a:xfrm>
-            <a:off x="23761008" y="12889290"/>
+          <p:cNvPr id="33" name="Text 30"/>
+          <p:cNvSpPr/>
+          <p:nvPr/>
+        </p:nvSpPr>
+        <p:spPr>
+          <a:xfrm>
+            <a:off x="1213776" y="36106632"/>
             <a:ext cx="7918992" cy="603504"/>
           </a:xfrm>
           <a:prstGeom prst="rect">
@@ -2377,7 +2296,7 @@
               <a:buNone/>
             </a:pPr>
             <a:r>
-              <a:rPr lang="en-US" sz="3900" b="1" dirty="0">
+              <a:rPr lang="en-US" sz="3700" b="1" dirty="0">
                 <a:solidFill>
                   <a:srgbClr val="12355B"/>
                 </a:solidFill>
@@ -2385,22 +2304,22 @@
                 <a:ea typeface="Cambria" pitchFamily="34" charset="-122"/>
                 <a:cs typeface="Cambria" pitchFamily="34" charset="-120"/>
               </a:rPr>
-              <a:t>Discussion</a:t>
-            </a:r>
-            <a:endParaRPr lang="en-US" sz="3900" dirty="0"/>
-          </a:p>
-        </p:txBody>
-      </p:sp>
-      <p:sp>
-        <p:nvSpPr>
-          <p:cNvPr id="37" name="Text 34"/>
-          <p:cNvSpPr/>
-          <p:nvPr/>
-        </p:nvSpPr>
-        <p:spPr>
-          <a:xfrm>
-            <a:off x="23303808" y="13639098"/>
-            <a:ext cx="8339616" cy="7735824"/>
+              <a:t>Operative Findings</a:t>
+            </a:r>
+            <a:endParaRPr lang="en-US" sz="3700" dirty="0"/>
+          </a:p>
+        </p:txBody>
+      </p:sp>
+      <p:sp>
+        <p:nvSpPr>
+          <p:cNvPr id="34" name="Text 31"/>
+          <p:cNvSpPr/>
+          <p:nvPr/>
+        </p:nvSpPr>
+        <p:spPr>
+          <a:xfrm>
+            <a:off x="756576" y="36856440"/>
+            <a:ext cx="8339616" cy="4526280"/>
           </a:xfrm>
           <a:prstGeom prst="rect">
             <a:avLst/>
@@ -2420,7 +2339,7 @@
               <a:buChar char="•"/>
             </a:pPr>
             <a:r>
-              <a:rPr lang="en-US" sz="3600" dirty="0">
+              <a:rPr lang="en-US" sz="3300" dirty="0">
                 <a:solidFill>
                   <a:srgbClr val="333333"/>
                 </a:solidFill>
@@ -2428,9 +2347,9 @@
                 <a:ea typeface="Calibri" pitchFamily="34" charset="-122"/>
                 <a:cs typeface="Calibri" pitchFamily="34" charset="-120"/>
               </a:rPr>
-              <a:t>Intestinal metastasis from breast carcinoma is uncommon, and perforation as the initial manifestation is exceedingly rare.</a:t>
-            </a:r>
-            <a:endParaRPr lang="en-US" sz="3600" dirty="0"/>
+              <a:t>Emergency exploratory laparotomy performed.</a:t>
+            </a:r>
+            <a:endParaRPr lang="en-US" sz="3300" dirty="0"/>
           </a:p>
           <a:p>
             <a:pPr algn="l" marL="228600" indent="-228600">
@@ -2441,17 +2360,17 @@
               <a:buChar char="•"/>
             </a:pPr>
             <a:r>
-              <a:rPr lang="en-US" sz="3600" dirty="0">
-                <a:solidFill>
-                  <a:srgbClr val="333333"/>
-                </a:solidFill>
-                <a:latin typeface="Calibri" pitchFamily="34" charset="0"/>
-                <a:ea typeface="Calibri" pitchFamily="34" charset="-122"/>
-                <a:cs typeface="Calibri" pitchFamily="34" charset="-120"/>
-              </a:rPr>
-              <a:t>Only a limited number of similar cases have been reported.</a:t>
-            </a:r>
-            <a:endParaRPr lang="en-US" sz="3600" dirty="0"/>
+              <a:rPr lang="en-US" sz="3300" b="1" dirty="0">
+                <a:solidFill>
+                  <a:srgbClr val="12355B"/>
+                </a:solidFill>
+                <a:latin typeface="Calibri" pitchFamily="34" charset="0"/>
+                <a:ea typeface="Calibri" pitchFamily="34" charset="-122"/>
+                <a:cs typeface="Calibri" pitchFamily="34" charset="-120"/>
+              </a:rPr>
+              <a:t>Solitary ileal perforation ≈ 0.5 × 0.5 cm, located 40 cm proximal to the ileocaecal junction.</a:t>
+            </a:r>
+            <a:endParaRPr lang="en-US" sz="3300" dirty="0"/>
           </a:p>
           <a:p>
             <a:pPr algn="l" marL="228600" indent="-228600">
@@ -2462,7 +2381,7 @@
               <a:buChar char="•"/>
             </a:pPr>
             <a:r>
-              <a:rPr lang="en-US" sz="3600" dirty="0">
+              <a:rPr lang="en-US" sz="3300" dirty="0">
                 <a:solidFill>
                   <a:srgbClr val="333333"/>
                 </a:solidFill>
@@ -2470,10 +2389,91 @@
                 <a:ea typeface="Calibri" pitchFamily="34" charset="-122"/>
                 <a:cs typeface="Calibri" pitchFamily="34" charset="-120"/>
               </a:rPr>
-              <a:t>This case highlights that an acute surgical abdomen may represent the first presentation of metastatic malignancy.</a:t>
-            </a:r>
-            <a:endParaRPr lang="en-US" sz="3600" dirty="0"/>
-          </a:p>
+              <a:t>Primary closure of the perforation performed after obtaining a biopsy from the perforation margin.</a:t>
+            </a:r>
+            <a:endParaRPr lang="en-US" sz="3300" dirty="0"/>
+          </a:p>
+        </p:txBody>
+      </p:sp>
+      <p:sp>
+        <p:nvSpPr>
+          <p:cNvPr id="35" name="Shape 32"/>
+          <p:cNvSpPr/>
+          <p:nvPr/>
+        </p:nvSpPr>
+        <p:spPr>
+          <a:xfrm>
+            <a:off x="23267232" y="7568856"/>
+            <a:ext cx="310896" cy="310896"/>
+          </a:xfrm>
+          <a:prstGeom prst="ellipse">
+            <a:avLst/>
+          </a:prstGeom>
+          <a:solidFill>
+            <a:srgbClr val="2A9D8F"/>
+          </a:solidFill>
+          <a:ln/>
+        </p:spPr>
+      </p:sp>
+      <p:sp>
+        <p:nvSpPr>
+          <p:cNvPr id="36" name="Text 33"/>
+          <p:cNvSpPr/>
+          <p:nvPr/>
+        </p:nvSpPr>
+        <p:spPr>
+          <a:xfrm>
+            <a:off x="23761008" y="7459128"/>
+            <a:ext cx="7918992" cy="603504"/>
+          </a:xfrm>
+          <a:prstGeom prst="rect">
+            <a:avLst/>
+          </a:prstGeom>
+          <a:noFill/>
+          <a:ln/>
+        </p:spPr>
+        <p:txBody>
+          <a:bodyPr wrap="square" lIns="0" tIns="0" rIns="0" bIns="0" rtlCol="0" anchor="ctr"/>
+          <a:lstStyle/>
+          <a:p>
+            <a:pPr algn="l" indent="0" marL="0">
+              <a:buNone/>
+            </a:pPr>
+            <a:r>
+              <a:rPr lang="en-US" sz="3700" b="1" dirty="0">
+                <a:solidFill>
+                  <a:srgbClr val="12355B"/>
+                </a:solidFill>
+                <a:latin typeface="Cambria" pitchFamily="34" charset="0"/>
+                <a:ea typeface="Cambria" pitchFamily="34" charset="-122"/>
+                <a:cs typeface="Cambria" pitchFamily="34" charset="-120"/>
+              </a:rPr>
+              <a:t>Histopathology</a:t>
+            </a:r>
+            <a:endParaRPr lang="en-US" sz="3700" dirty="0"/>
+          </a:p>
+        </p:txBody>
+      </p:sp>
+      <p:sp>
+        <p:nvSpPr>
+          <p:cNvPr id="37" name="Text 34"/>
+          <p:cNvSpPr/>
+          <p:nvPr/>
+        </p:nvSpPr>
+        <p:spPr>
+          <a:xfrm>
+            <a:off x="23303808" y="8208936"/>
+            <a:ext cx="8339616" cy="2916936"/>
+          </a:xfrm>
+          <a:prstGeom prst="rect">
+            <a:avLst/>
+          </a:prstGeom>
+          <a:noFill/>
+          <a:ln/>
+        </p:spPr>
+        <p:txBody>
+          <a:bodyPr wrap="square" lIns="0" tIns="0" rIns="0" bIns="0" rtlCol="0" anchor="t"/>
+          <a:lstStyle/>
           <a:p>
             <a:pPr algn="l" marL="228600" indent="-228600">
               <a:spcAft>
@@ -2483,7 +2483,130 @@
               <a:buChar char="•"/>
             </a:pPr>
             <a:r>
-              <a:rPr lang="en-US" sz="3600" dirty="0">
+              <a:rPr lang="en-US" sz="3300" b="1" dirty="0">
+                <a:solidFill>
+                  <a:srgbClr val="12355B"/>
+                </a:solidFill>
+                <a:latin typeface="Calibri" pitchFamily="34" charset="0"/>
+                <a:ea typeface="Calibri" pitchFamily="34" charset="-122"/>
+                <a:cs typeface="Calibri" pitchFamily="34" charset="-120"/>
+              </a:rPr>
+              <a:t>Trucut biopsy of the breast lump confirmed invasive ductal carcinoma.</a:t>
+            </a:r>
+            <a:endParaRPr lang="en-US" sz="3300" dirty="0"/>
+          </a:p>
+          <a:p>
+            <a:pPr algn="l" marL="228600" indent="-228600">
+              <a:spcAft>
+                <a:spcPts val="900"/>
+              </a:spcAft>
+              <a:buSzPct val="100000"/>
+              <a:buChar char="•"/>
+            </a:pPr>
+            <a:r>
+              <a:rPr lang="en-US" sz="3300" b="1" dirty="0">
+                <a:solidFill>
+                  <a:srgbClr val="12355B"/>
+                </a:solidFill>
+                <a:latin typeface="Calibri" pitchFamily="34" charset="0"/>
+                <a:ea typeface="Calibri" pitchFamily="34" charset="-122"/>
+                <a:cs typeface="Calibri" pitchFamily="34" charset="-120"/>
+              </a:rPr>
+              <a:t>Histopathology of the ileal biopsy demonstrated metastatic deposits at the perforation site.</a:t>
+            </a:r>
+            <a:endParaRPr lang="en-US" sz="3300" dirty="0"/>
+          </a:p>
+        </p:txBody>
+      </p:sp>
+      <p:sp>
+        <p:nvSpPr>
+          <p:cNvPr id="38" name="Shape 35"/>
+          <p:cNvSpPr/>
+          <p:nvPr/>
+        </p:nvSpPr>
+        <p:spPr>
+          <a:xfrm>
+            <a:off x="23267232" y="12456774"/>
+            <a:ext cx="310896" cy="310896"/>
+          </a:xfrm>
+          <a:prstGeom prst="ellipse">
+            <a:avLst/>
+          </a:prstGeom>
+          <a:solidFill>
+            <a:srgbClr val="2A9D8F"/>
+          </a:solidFill>
+          <a:ln/>
+        </p:spPr>
+      </p:sp>
+      <p:sp>
+        <p:nvSpPr>
+          <p:cNvPr id="39" name="Text 36"/>
+          <p:cNvSpPr/>
+          <p:nvPr/>
+        </p:nvSpPr>
+        <p:spPr>
+          <a:xfrm>
+            <a:off x="23761008" y="12347046"/>
+            <a:ext cx="7918992" cy="603504"/>
+          </a:xfrm>
+          <a:prstGeom prst="rect">
+            <a:avLst/>
+          </a:prstGeom>
+          <a:noFill/>
+          <a:ln/>
+        </p:spPr>
+        <p:txBody>
+          <a:bodyPr wrap="square" lIns="0" tIns="0" rIns="0" bIns="0" rtlCol="0" anchor="ctr"/>
+          <a:lstStyle/>
+          <a:p>
+            <a:pPr algn="l" indent="0" marL="0">
+              <a:buNone/>
+            </a:pPr>
+            <a:r>
+              <a:rPr lang="en-US" sz="3700" b="1" dirty="0">
+                <a:solidFill>
+                  <a:srgbClr val="12355B"/>
+                </a:solidFill>
+                <a:latin typeface="Cambria" pitchFamily="34" charset="0"/>
+                <a:ea typeface="Cambria" pitchFamily="34" charset="-122"/>
+                <a:cs typeface="Cambria" pitchFamily="34" charset="-120"/>
+              </a:rPr>
+              <a:t>Discussion</a:t>
+            </a:r>
+            <a:endParaRPr lang="en-US" sz="3700" dirty="0"/>
+          </a:p>
+        </p:txBody>
+      </p:sp>
+      <p:sp>
+        <p:nvSpPr>
+          <p:cNvPr id="40" name="Text 37"/>
+          <p:cNvSpPr/>
+          <p:nvPr/>
+        </p:nvSpPr>
+        <p:spPr>
+          <a:xfrm>
+            <a:off x="23303808" y="13096854"/>
+            <a:ext cx="8339616" cy="7141464"/>
+          </a:xfrm>
+          <a:prstGeom prst="rect">
+            <a:avLst/>
+          </a:prstGeom>
+          <a:noFill/>
+          <a:ln/>
+        </p:spPr>
+        <p:txBody>
+          <a:bodyPr wrap="square" lIns="0" tIns="0" rIns="0" bIns="0" rtlCol="0" anchor="t"/>
+          <a:lstStyle/>
+          <a:p>
+            <a:pPr algn="l" marL="228600" indent="-228600">
+              <a:spcAft>
+                <a:spcPts val="900"/>
+              </a:spcAft>
+              <a:buSzPct val="100000"/>
+              <a:buChar char="•"/>
+            </a:pPr>
+            <a:r>
+              <a:rPr lang="en-US" sz="3300" dirty="0">
                 <a:solidFill>
                   <a:srgbClr val="333333"/>
                 </a:solidFill>
@@ -2491,26 +2614,89 @@
                 <a:ea typeface="Calibri" pitchFamily="34" charset="-122"/>
                 <a:cs typeface="Calibri" pitchFamily="34" charset="-120"/>
               </a:rPr>
+              <a:t>Intestinal metastasis from breast carcinoma is uncommon, and perforation as the initial manifestation is exceedingly rare.</a:t>
+            </a:r>
+            <a:endParaRPr lang="en-US" sz="3300" dirty="0"/>
+          </a:p>
+          <a:p>
+            <a:pPr algn="l" marL="228600" indent="-228600">
+              <a:spcAft>
+                <a:spcPts val="900"/>
+              </a:spcAft>
+              <a:buSzPct val="100000"/>
+              <a:buChar char="•"/>
+            </a:pPr>
+            <a:r>
+              <a:rPr lang="en-US" sz="3300" dirty="0">
+                <a:solidFill>
+                  <a:srgbClr val="333333"/>
+                </a:solidFill>
+                <a:latin typeface="Calibri" pitchFamily="34" charset="0"/>
+                <a:ea typeface="Calibri" pitchFamily="34" charset="-122"/>
+                <a:cs typeface="Calibri" pitchFamily="34" charset="-120"/>
+              </a:rPr>
+              <a:t>Only a limited number of similar cases have been reported.</a:t>
+            </a:r>
+            <a:endParaRPr lang="en-US" sz="3300" dirty="0"/>
+          </a:p>
+          <a:p>
+            <a:pPr algn="l" marL="228600" indent="-228600">
+              <a:spcAft>
+                <a:spcPts val="900"/>
+              </a:spcAft>
+              <a:buSzPct val="100000"/>
+              <a:buChar char="•"/>
+            </a:pPr>
+            <a:r>
+              <a:rPr lang="en-US" sz="3300" dirty="0">
+                <a:solidFill>
+                  <a:srgbClr val="333333"/>
+                </a:solidFill>
+                <a:latin typeface="Calibri" pitchFamily="34" charset="0"/>
+                <a:ea typeface="Calibri" pitchFamily="34" charset="-122"/>
+                <a:cs typeface="Calibri" pitchFamily="34" charset="-120"/>
+              </a:rPr>
+              <a:t>This case highlights that an acute surgical abdomen may represent the first presentation of metastatic malignancy.</a:t>
+            </a:r>
+            <a:endParaRPr lang="en-US" sz="3300" dirty="0"/>
+          </a:p>
+          <a:p>
+            <a:pPr algn="l" marL="228600" indent="-228600">
+              <a:spcAft>
+                <a:spcPts val="900"/>
+              </a:spcAft>
+              <a:buSzPct val="100000"/>
+              <a:buChar char="•"/>
+            </a:pPr>
+            <a:r>
+              <a:rPr lang="en-US" sz="3300" dirty="0">
+                <a:solidFill>
+                  <a:srgbClr val="333333"/>
+                </a:solidFill>
+                <a:latin typeface="Calibri" pitchFamily="34" charset="0"/>
+                <a:ea typeface="Calibri" pitchFamily="34" charset="-122"/>
+                <a:cs typeface="Calibri" pitchFamily="34" charset="-120"/>
+              </a:rPr>
               <a:t>Management requires emergency surgery followed by evaluation of the primary breast malignancy.</a:t>
             </a:r>
-            <a:endParaRPr lang="en-US" sz="3600" dirty="0"/>
-          </a:p>
-        </p:txBody>
-      </p:sp>
-      <p:sp>
-        <p:nvSpPr>
-          <p:cNvPr id="38" name="Shape 35"/>
-          <p:cNvSpPr/>
-          <p:nvPr/>
-        </p:nvSpPr>
-        <p:spPr>
-          <a:xfrm>
-            <a:off x="23267232" y="22379388"/>
-            <a:ext cx="8412768" cy="10308031"/>
+            <a:endParaRPr lang="en-US" sz="3300" dirty="0"/>
+          </a:p>
+        </p:txBody>
+      </p:sp>
+      <p:sp>
+        <p:nvSpPr>
+          <p:cNvPr id="41" name="Shape 38"/>
+          <p:cNvSpPr/>
+          <p:nvPr/>
+        </p:nvSpPr>
+        <p:spPr>
+          <a:xfrm>
+            <a:off x="23267232" y="21477780"/>
+            <a:ext cx="8412768" cy="7183526"/>
           </a:xfrm>
           <a:prstGeom prst="roundRect">
             <a:avLst>
-              <a:gd name="adj" fmla="val 1087"/>
+              <a:gd name="adj" fmla="val 1273"/>
             </a:avLst>
           </a:prstGeom>
           <a:solidFill>
@@ -2533,13 +2719,13 @@
       </p:sp>
       <p:sp>
         <p:nvSpPr>
-          <p:cNvPr id="39" name="Shape 36"/>
-          <p:cNvSpPr/>
-          <p:nvPr/>
-        </p:nvSpPr>
-        <p:spPr>
-          <a:xfrm>
-            <a:off x="23559840" y="22973748"/>
+          <p:cNvPr id="42" name="Shape 39"/>
+          <p:cNvSpPr/>
+          <p:nvPr/>
+        </p:nvSpPr>
+        <p:spPr>
+          <a:xfrm>
+            <a:off x="23559840" y="21962412"/>
             <a:ext cx="310896" cy="310896"/>
           </a:xfrm>
           <a:prstGeom prst="ellipse">
@@ -2553,13 +2739,13 @@
       </p:sp>
       <p:sp>
         <p:nvSpPr>
-          <p:cNvPr id="40" name="Text 37"/>
-          <p:cNvSpPr/>
-          <p:nvPr/>
-        </p:nvSpPr>
-        <p:spPr>
-          <a:xfrm>
-            <a:off x="24035328" y="22900596"/>
+          <p:cNvPr id="43" name="Text 40"/>
+          <p:cNvSpPr/>
+          <p:nvPr/>
+        </p:nvSpPr>
+        <p:spPr>
+          <a:xfrm>
+            <a:off x="24035328" y="21889260"/>
             <a:ext cx="7352064" cy="603504"/>
           </a:xfrm>
           <a:prstGeom prst="rect">
@@ -2576,7 +2762,7 @@
               <a:buNone/>
             </a:pPr>
             <a:r>
-              <a:rPr lang="en-US" sz="3900" b="1" dirty="0">
+              <a:rPr lang="en-US" sz="3700" b="1" dirty="0">
                 <a:solidFill>
                   <a:srgbClr val="12355B"/>
                 </a:solidFill>
@@ -2586,20 +2772,20 @@
               </a:rPr>
               <a:t>Why This Case Is Unique</a:t>
             </a:r>
-            <a:endParaRPr lang="en-US" sz="3900" dirty="0"/>
-          </a:p>
-        </p:txBody>
-      </p:sp>
-      <p:sp>
-        <p:nvSpPr>
-          <p:cNvPr id="41" name="Text 38"/>
-          <p:cNvSpPr/>
-          <p:nvPr/>
-        </p:nvSpPr>
-        <p:spPr>
-          <a:xfrm>
-            <a:off x="23559840" y="23632116"/>
-            <a:ext cx="7827552" cy="8625535"/>
+            <a:endParaRPr lang="en-US" sz="3700" dirty="0"/>
+          </a:p>
+        </p:txBody>
+      </p:sp>
+      <p:sp>
+        <p:nvSpPr>
+          <p:cNvPr id="44" name="Text 41"/>
+          <p:cNvSpPr/>
+          <p:nvPr/>
+        </p:nvSpPr>
+        <p:spPr>
+          <a:xfrm>
+            <a:off x="23559840" y="22620780"/>
+            <a:ext cx="7827552" cy="5720486"/>
           </a:xfrm>
           <a:prstGeom prst="rect">
             <a:avLst/>
@@ -2619,7 +2805,7 @@
               <a:buChar char="•"/>
             </a:pPr>
             <a:r>
-              <a:rPr lang="en-US" sz="3600" dirty="0">
+              <a:rPr lang="en-US" sz="3300" dirty="0">
                 <a:solidFill>
                   <a:srgbClr val="5A4A12"/>
                 </a:solidFill>
@@ -2629,7 +2815,7 @@
               </a:rPr>
               <a:t>Ileal perforation was the initial manifestation of previously unrecognised metastatic breast carcinoma.</a:t>
             </a:r>
-            <a:endParaRPr lang="en-US" sz="3600" dirty="0"/>
+            <a:endParaRPr lang="en-US" sz="3300" dirty="0"/>
           </a:p>
           <a:p>
             <a:pPr algn="l" marL="228600" indent="-228600">
@@ -2640,7 +2826,7 @@
               <a:buChar char="•"/>
             </a:pPr>
             <a:r>
-              <a:rPr lang="en-US" sz="3600" dirty="0">
+              <a:rPr lang="en-US" sz="3300" dirty="0">
                 <a:solidFill>
                   <a:srgbClr val="5A4A12"/>
                 </a:solidFill>
@@ -2650,7 +2836,7 @@
               </a:rPr>
               <a:t>Perforation as the first presentation is exceedingly rare, with only a limited number of reported cases.</a:t>
             </a:r>
-            <a:endParaRPr lang="en-US" sz="3600" dirty="0"/>
+            <a:endParaRPr lang="en-US" sz="3300" dirty="0"/>
           </a:p>
           <a:p>
             <a:pPr algn="l" marL="228600" indent="-228600">
@@ -2661,7 +2847,7 @@
               <a:buChar char="•"/>
             </a:pPr>
             <a:r>
-              <a:rPr lang="en-US" sz="3600" dirty="0">
+              <a:rPr lang="en-US" sz="3300" dirty="0">
                 <a:solidFill>
                   <a:srgbClr val="5A4A12"/>
                 </a:solidFill>
@@ -2671,24 +2857,24 @@
               </a:rPr>
               <a:t>Demonstrates that an acute surgical abdomen may be the first presentation of metastatic malignancy.</a:t>
             </a:r>
-            <a:endParaRPr lang="en-US" sz="3600" dirty="0"/>
-          </a:p>
-        </p:txBody>
-      </p:sp>
-      <p:sp>
-        <p:nvSpPr>
-          <p:cNvPr id="42" name="Shape 39"/>
-          <p:cNvSpPr/>
-          <p:nvPr/>
-        </p:nvSpPr>
-        <p:spPr>
-          <a:xfrm>
-            <a:off x="23267232" y="33783324"/>
-            <a:ext cx="8412768" cy="7507956"/>
+            <a:endParaRPr lang="en-US" sz="3300" dirty="0"/>
+          </a:p>
+        </p:txBody>
+      </p:sp>
+      <p:sp>
+        <p:nvSpPr>
+          <p:cNvPr id="45" name="Shape 42"/>
+          <p:cNvSpPr/>
+          <p:nvPr/>
+        </p:nvSpPr>
+        <p:spPr>
+          <a:xfrm>
+            <a:off x="23267232" y="29992209"/>
+            <a:ext cx="8412768" cy="5922203"/>
           </a:xfrm>
           <a:prstGeom prst="roundRect">
             <a:avLst>
-              <a:gd name="adj" fmla="val 1218"/>
+              <a:gd name="adj" fmla="val 1544"/>
             </a:avLst>
           </a:prstGeom>
           <a:solidFill>
@@ -2706,13 +2892,13 @@
       </p:sp>
       <p:sp>
         <p:nvSpPr>
-          <p:cNvPr id="43" name="Shape 40"/>
-          <p:cNvSpPr/>
-          <p:nvPr/>
-        </p:nvSpPr>
-        <p:spPr>
-          <a:xfrm>
-            <a:off x="23559840" y="34377684"/>
+          <p:cNvPr id="46" name="Shape 43"/>
+          <p:cNvSpPr/>
+          <p:nvPr/>
+        </p:nvSpPr>
+        <p:spPr>
+          <a:xfrm>
+            <a:off x="23559840" y="30476841"/>
             <a:ext cx="310896" cy="310896"/>
           </a:xfrm>
           <a:prstGeom prst="ellipse">
@@ -2726,13 +2912,13 @@
       </p:sp>
       <p:sp>
         <p:nvSpPr>
-          <p:cNvPr id="44" name="Text 41"/>
-          <p:cNvSpPr/>
-          <p:nvPr/>
-        </p:nvSpPr>
-        <p:spPr>
-          <a:xfrm>
-            <a:off x="24035328" y="34304532"/>
+          <p:cNvPr id="47" name="Text 44"/>
+          <p:cNvSpPr/>
+          <p:nvPr/>
+        </p:nvSpPr>
+        <p:spPr>
+          <a:xfrm>
+            <a:off x="24035328" y="30403689"/>
             <a:ext cx="7352064" cy="603504"/>
           </a:xfrm>
           <a:prstGeom prst="rect">
@@ -2749,7 +2935,7 @@
               <a:buNone/>
             </a:pPr>
             <a:r>
-              <a:rPr lang="en-US" sz="3900" b="1" dirty="0">
+              <a:rPr lang="en-US" sz="3700" b="1" dirty="0">
                 <a:solidFill>
                   <a:srgbClr val="FFFFFF"/>
                 </a:solidFill>
@@ -2759,20 +2945,20 @@
               </a:rPr>
               <a:t>Conclusion</a:t>
             </a:r>
-            <a:endParaRPr lang="en-US" sz="3900" dirty="0"/>
-          </a:p>
-        </p:txBody>
-      </p:sp>
-      <p:sp>
-        <p:nvSpPr>
-          <p:cNvPr id="45" name="Text 42"/>
-          <p:cNvSpPr/>
-          <p:nvPr/>
-        </p:nvSpPr>
-        <p:spPr>
-          <a:xfrm>
-            <a:off x="23559840" y="35036052"/>
-            <a:ext cx="7827552" cy="5825460"/>
+            <a:endParaRPr lang="en-US" sz="3700" dirty="0"/>
+          </a:p>
+        </p:txBody>
+      </p:sp>
+      <p:sp>
+        <p:nvSpPr>
+          <p:cNvPr id="48" name="Text 45"/>
+          <p:cNvSpPr/>
+          <p:nvPr/>
+        </p:nvSpPr>
+        <p:spPr>
+          <a:xfrm>
+            <a:off x="23559840" y="31135209"/>
+            <a:ext cx="7827552" cy="4459163"/>
           </a:xfrm>
           <a:prstGeom prst="rect">
             <a:avLst/>
@@ -2792,7 +2978,7 @@
               <a:buChar char="•"/>
             </a:pPr>
             <a:r>
-              <a:rPr lang="en-US" sz="3600" dirty="0">
+              <a:rPr lang="en-US" sz="3300" dirty="0">
                 <a:solidFill>
                   <a:srgbClr val="EAF1F8"/>
                 </a:solidFill>
@@ -2802,7 +2988,7 @@
               </a:rPr>
               <a:t>Ileal perforation can rarely be the presenting manifestation of metastatic breast carcinoma.</a:t>
             </a:r>
-            <a:endParaRPr lang="en-US" sz="3600" dirty="0"/>
+            <a:endParaRPr lang="en-US" sz="3300" dirty="0"/>
           </a:p>
           <a:p>
             <a:pPr algn="l" marL="228600" indent="-228600">
@@ -2813,7 +2999,7 @@
               <a:buChar char="•"/>
             </a:pPr>
             <a:r>
-              <a:rPr lang="en-US" sz="3600" dirty="0">
+              <a:rPr lang="en-US" sz="3300" dirty="0">
                 <a:solidFill>
                   <a:srgbClr val="EAF1F8"/>
                 </a:solidFill>
@@ -2823,19 +3009,19 @@
               </a:rPr>
               <a:t>A high index of suspicion together with early histopathological confirmation is essential for accurate diagnosis and appropriate management.</a:t>
             </a:r>
-            <a:endParaRPr lang="en-US" sz="3600" dirty="0"/>
-          </a:p>
-        </p:txBody>
-      </p:sp>
-      <p:sp>
-        <p:nvSpPr>
-          <p:cNvPr id="46" name="Shape 43"/>
-          <p:cNvSpPr/>
-          <p:nvPr/>
-        </p:nvSpPr>
-        <p:spPr>
-          <a:xfrm>
-            <a:off x="9589968" y="7550568"/>
+            <a:endParaRPr lang="en-US" sz="3300" dirty="0"/>
+          </a:p>
+        </p:txBody>
+      </p:sp>
+      <p:sp>
+        <p:nvSpPr>
+          <p:cNvPr id="49" name="Shape 46"/>
+          <p:cNvSpPr/>
+          <p:nvPr/>
+        </p:nvSpPr>
+        <p:spPr>
+          <a:xfrm>
+            <a:off x="23267232" y="37336754"/>
             <a:ext cx="310896" cy="310896"/>
           </a:xfrm>
           <a:prstGeom prst="ellipse">
@@ -2849,14 +3035,14 @@
       </p:sp>
       <p:sp>
         <p:nvSpPr>
-          <p:cNvPr id="47" name="Text 44"/>
-          <p:cNvSpPr/>
-          <p:nvPr/>
-        </p:nvSpPr>
-        <p:spPr>
-          <a:xfrm>
-            <a:off x="10047168" y="7477416"/>
-            <a:ext cx="12762864" cy="640080"/>
+          <p:cNvPr id="50" name="Text 47"/>
+          <p:cNvSpPr/>
+          <p:nvPr/>
+        </p:nvSpPr>
+        <p:spPr>
+          <a:xfrm>
+            <a:off x="23761008" y="37227026"/>
+            <a:ext cx="7918992" cy="566928"/>
           </a:xfrm>
           <a:prstGeom prst="rect">
             <a:avLst/>
@@ -2872,7 +3058,7 @@
               <a:buNone/>
             </a:pPr>
             <a:r>
-              <a:rPr lang="en-US" sz="3900" b="1" dirty="0">
+              <a:rPr lang="en-US" sz="3700" b="1" dirty="0">
                 <a:solidFill>
                   <a:srgbClr val="12355B"/>
                 </a:solidFill>
@@ -2880,15 +3066,176 @@
                 <a:ea typeface="Cambria" pitchFamily="34" charset="-122"/>
                 <a:cs typeface="Cambria" pitchFamily="34" charset="-120"/>
               </a:rPr>
+              <a:t>Key References</a:t>
+            </a:r>
+            <a:endParaRPr lang="en-US" sz="3700" dirty="0"/>
+          </a:p>
+        </p:txBody>
+      </p:sp>
+      <p:sp>
+        <p:nvSpPr>
+          <p:cNvPr id="51" name="Text 48"/>
+          <p:cNvSpPr/>
+          <p:nvPr/>
+        </p:nvSpPr>
+        <p:spPr>
+          <a:xfrm>
+            <a:off x="23303808" y="37940258"/>
+            <a:ext cx="8339616" cy="3351022"/>
+          </a:xfrm>
+          <a:prstGeom prst="rect">
+            <a:avLst/>
+          </a:prstGeom>
+          <a:noFill/>
+          <a:ln/>
+        </p:spPr>
+        <p:txBody>
+          <a:bodyPr wrap="square" lIns="0" tIns="0" rIns="0" bIns="0" rtlCol="0" anchor="t"/>
+          <a:lstStyle/>
+          <a:p>
+            <a:pPr algn="l" indent="0" marL="0">
+              <a:spcAft>
+                <a:spcPts val="700"/>
+              </a:spcAft>
+              <a:buNone/>
+            </a:pPr>
+            <a:r>
+              <a:rPr lang="en-US" sz="1700" dirty="0">
+                <a:solidFill>
+                  <a:srgbClr val="555555"/>
+                </a:solidFill>
+                <a:latin typeface="Calibri" pitchFamily="34" charset="0"/>
+                <a:ea typeface="Calibri" pitchFamily="34" charset="-122"/>
+                <a:cs typeface="Calibri" pitchFamily="34" charset="-120"/>
+              </a:rPr>
+              <a:t>1.  McLemore EC, et al. Breast cancer: presentation and intervention in women with gastrointestinal metastasis and carcinomatosis. Ann Surg Oncol. 2005;12(11):886–894.</a:t>
+            </a:r>
+            <a:endParaRPr lang="en-US" sz="1700" dirty="0"/>
+          </a:p>
+          <a:p>
+            <a:pPr algn="l" indent="0" marL="0">
+              <a:spcAft>
+                <a:spcPts val="700"/>
+              </a:spcAft>
+              <a:buNone/>
+            </a:pPr>
+            <a:r>
+              <a:rPr lang="en-US" sz="1700" dirty="0">
+                <a:solidFill>
+                  <a:srgbClr val="555555"/>
+                </a:solidFill>
+                <a:latin typeface="Calibri" pitchFamily="34" charset="0"/>
+                <a:ea typeface="Calibri" pitchFamily="34" charset="-122"/>
+                <a:cs typeface="Calibri" pitchFamily="34" charset="-120"/>
+              </a:rPr>
+              <a:t>2.  Ambroggi M, et al. Metastatic breast cancer to the gastrointestinal tract: report of five cases and review of the literature. Int J Breast Cancer. 2012;2012:439023.</a:t>
+            </a:r>
+            <a:endParaRPr lang="en-US" sz="1700" dirty="0"/>
+          </a:p>
+          <a:p>
+            <a:pPr algn="l" indent="0" marL="0">
+              <a:spcAft>
+                <a:spcPts val="700"/>
+              </a:spcAft>
+              <a:buNone/>
+            </a:pPr>
+            <a:r>
+              <a:rPr lang="en-US" sz="1700" dirty="0">
+                <a:solidFill>
+                  <a:srgbClr val="555555"/>
+                </a:solidFill>
+                <a:latin typeface="Calibri" pitchFamily="34" charset="0"/>
+                <a:ea typeface="Calibri" pitchFamily="34" charset="-122"/>
+                <a:cs typeface="Calibri" pitchFamily="34" charset="-120"/>
+              </a:rPr>
+              <a:t>3.  Li Y, et al. Small intestinal metastatic breast cancer: a case report and literature review. Front Oncol. 2022;12:900832.</a:t>
+            </a:r>
+            <a:endParaRPr lang="en-US" sz="1700" dirty="0"/>
+          </a:p>
+          <a:p>
+            <a:pPr algn="l" indent="0" marL="0">
+              <a:spcAft>
+                <a:spcPts val="700"/>
+              </a:spcAft>
+              <a:buNone/>
+            </a:pPr>
+            <a:r>
+              <a:rPr lang="en-US" sz="1700" dirty="0">
+                <a:solidFill>
+                  <a:srgbClr val="555555"/>
+                </a:solidFill>
+                <a:latin typeface="Calibri" pitchFamily="34" charset="0"/>
+                <a:ea typeface="Calibri" pitchFamily="34" charset="-122"/>
+                <a:cs typeface="Calibri" pitchFamily="34" charset="-120"/>
+              </a:rPr>
+              <a:t>4.  Shen F, et al. Small intestinal metastasis from primary breast cancer: a case report and review of the literature. Front Immunol. 2024;15:1475018.</a:t>
+            </a:r>
+            <a:endParaRPr lang="en-US" sz="1700" dirty="0"/>
+          </a:p>
+        </p:txBody>
+      </p:sp>
+      <p:sp>
+        <p:nvSpPr>
+          <p:cNvPr id="52" name="Shape 49"/>
+          <p:cNvSpPr/>
+          <p:nvPr/>
+        </p:nvSpPr>
+        <p:spPr>
+          <a:xfrm>
+            <a:off x="9589968" y="7550568"/>
+            <a:ext cx="310896" cy="310896"/>
+          </a:xfrm>
+          <a:prstGeom prst="ellipse">
+            <a:avLst/>
+          </a:prstGeom>
+          <a:solidFill>
+            <a:srgbClr val="2A9D8F"/>
+          </a:solidFill>
+          <a:ln/>
+        </p:spPr>
+      </p:sp>
+      <p:sp>
+        <p:nvSpPr>
+          <p:cNvPr id="53" name="Text 50"/>
+          <p:cNvSpPr/>
+          <p:nvPr/>
+        </p:nvSpPr>
+        <p:spPr>
+          <a:xfrm>
+            <a:off x="10047168" y="7477416"/>
+            <a:ext cx="12762864" cy="640080"/>
+          </a:xfrm>
+          <a:prstGeom prst="rect">
+            <a:avLst/>
+          </a:prstGeom>
+          <a:noFill/>
+          <a:ln/>
+        </p:spPr>
+        <p:txBody>
+          <a:bodyPr wrap="square" lIns="0" tIns="0" rIns="0" bIns="0" rtlCol="0" anchor="ctr"/>
+          <a:lstStyle/>
+          <a:p>
+            <a:pPr algn="l" indent="0" marL="0">
+              <a:buNone/>
+            </a:pPr>
+            <a:r>
+              <a:rPr lang="en-US" sz="3700" b="1" dirty="0">
+                <a:solidFill>
+                  <a:srgbClr val="12355B"/>
+                </a:solidFill>
+                <a:latin typeface="Cambria" pitchFamily="34" charset="0"/>
+                <a:ea typeface="Cambria" pitchFamily="34" charset="-122"/>
+                <a:cs typeface="Cambria" pitchFamily="34" charset="-120"/>
+              </a:rPr>
               <a:t>Clinical &amp; Diagnostic Sequence</a:t>
             </a:r>
-            <a:endParaRPr lang="en-US" sz="3900" dirty="0"/>
-          </a:p>
-        </p:txBody>
-      </p:sp>
-      <p:sp>
-        <p:nvSpPr>
-          <p:cNvPr id="48" name="Shape 45"/>
+            <a:endParaRPr lang="en-US" sz="3700" dirty="0"/>
+          </a:p>
+        </p:txBody>
+      </p:sp>
+      <p:sp>
+        <p:nvSpPr>
+          <p:cNvPr id="54" name="Shape 51"/>
           <p:cNvSpPr/>
           <p:nvPr/>
         </p:nvSpPr>
@@ -2922,7 +3269,7 @@
       </p:sp>
       <p:sp>
         <p:nvSpPr>
-          <p:cNvPr id="49" name="Shape 46"/>
+          <p:cNvPr id="55" name="Shape 52"/>
           <p:cNvSpPr/>
           <p:nvPr/>
         </p:nvSpPr>
@@ -2956,7 +3303,7 @@
       </p:sp>
       <p:pic>
         <p:nvPicPr>
-          <p:cNvPr id="50" name="Image 1" descr="/home/user/career-ops/4-breast-lump.jpeg">    </p:cNvPr>
+          <p:cNvPr id="56" name="Image 1" descr="/home/user/career-ops/4-breast-lump.jpeg">    </p:cNvPr>
           <p:cNvPicPr>
             <a:picLocks noChangeAspect="1"/>
           </p:cNvPicPr>
@@ -2980,7 +3327,7 @@
       </p:pic>
       <p:sp>
         <p:nvSpPr>
-          <p:cNvPr id="51" name="Shape 47"/>
+          <p:cNvPr id="57" name="Shape 53"/>
           <p:cNvSpPr/>
           <p:nvPr/>
         </p:nvSpPr>
@@ -3012,7 +3359,7 @@
       </p:sp>
       <p:sp>
         <p:nvSpPr>
-          <p:cNvPr id="52" name="Text 48"/>
+          <p:cNvPr id="58" name="Text 54"/>
           <p:cNvSpPr/>
           <p:nvPr/>
         </p:nvSpPr>
@@ -3051,7 +3398,7 @@
       </p:sp>
       <p:sp>
         <p:nvSpPr>
-          <p:cNvPr id="53" name="Text 49"/>
+          <p:cNvPr id="59" name="Text 55"/>
           <p:cNvSpPr/>
           <p:nvPr/>
         </p:nvSpPr>
@@ -3104,7 +3451,7 @@
       </p:sp>
       <p:sp>
         <p:nvSpPr>
-          <p:cNvPr id="54" name="Shape 50"/>
+          <p:cNvPr id="60" name="Shape 56"/>
           <p:cNvSpPr/>
           <p:nvPr/>
         </p:nvSpPr>
@@ -3124,7 +3471,7 @@
       </p:sp>
       <p:sp>
         <p:nvSpPr>
-          <p:cNvPr id="55" name="Shape 51"/>
+          <p:cNvPr id="61" name="Shape 57"/>
           <p:cNvSpPr/>
           <p:nvPr/>
         </p:nvSpPr>
@@ -3158,7 +3505,7 @@
       </p:sp>
       <p:sp>
         <p:nvSpPr>
-          <p:cNvPr id="56" name="Shape 52"/>
+          <p:cNvPr id="62" name="Shape 58"/>
           <p:cNvSpPr/>
           <p:nvPr/>
         </p:nvSpPr>
@@ -3192,7 +3539,7 @@
       </p:sp>
       <p:pic>
         <p:nvPicPr>
-          <p:cNvPr id="57" name="Image 2" descr="/home/user/career-ops/1-xray-pneumoperitoneum.jpeg">    </p:cNvPr>
+          <p:cNvPr id="63" name="Image 2" descr="/home/user/career-ops/1-xray-pneumoperitoneum.jpeg">    </p:cNvPr>
           <p:cNvPicPr>
             <a:picLocks noChangeAspect="1"/>
           </p:cNvPicPr>
@@ -3216,7 +3563,7 @@
       </p:pic>
       <p:sp>
         <p:nvSpPr>
-          <p:cNvPr id="58" name="Shape 53"/>
+          <p:cNvPr id="64" name="Shape 59"/>
           <p:cNvSpPr/>
           <p:nvPr/>
         </p:nvSpPr>
@@ -3248,7 +3595,7 @@
       </p:sp>
       <p:sp>
         <p:nvSpPr>
-          <p:cNvPr id="59" name="Text 54"/>
+          <p:cNvPr id="65" name="Text 60"/>
           <p:cNvSpPr/>
           <p:nvPr/>
         </p:nvSpPr>
@@ -3287,7 +3634,7 @@
       </p:sp>
       <p:sp>
         <p:nvSpPr>
-          <p:cNvPr id="60" name="Shape 55"/>
+          <p:cNvPr id="66" name="Shape 61"/>
           <p:cNvSpPr/>
           <p:nvPr/>
         </p:nvSpPr>
@@ -3321,7 +3668,7 @@
       </p:sp>
       <p:pic>
         <p:nvPicPr>
-          <p:cNvPr id="61" name="Image 3" descr="/home/user/career-ops/2-ct-abdomen.jpeg">    </p:cNvPr>
+          <p:cNvPr id="67" name="Image 3" descr="/home/user/career-ops/2-ct-abdomen.jpeg">    </p:cNvPr>
           <p:cNvPicPr>
             <a:picLocks noChangeAspect="1"/>
           </p:cNvPicPr>
@@ -3345,7 +3692,7 @@
       </p:pic>
       <p:sp>
         <p:nvSpPr>
-          <p:cNvPr id="62" name="Shape 56"/>
+          <p:cNvPr id="68" name="Shape 62"/>
           <p:cNvSpPr/>
           <p:nvPr/>
         </p:nvSpPr>
@@ -3377,7 +3724,7 @@
       </p:sp>
       <p:sp>
         <p:nvSpPr>
-          <p:cNvPr id="63" name="Text 57"/>
+          <p:cNvPr id="69" name="Text 63"/>
           <p:cNvSpPr/>
           <p:nvPr/>
         </p:nvSpPr>
@@ -3416,7 +3763,7 @@
       </p:sp>
       <p:sp>
         <p:nvSpPr>
-          <p:cNvPr id="64" name="Text 58"/>
+          <p:cNvPr id="70" name="Text 64"/>
           <p:cNvSpPr/>
           <p:nvPr/>
         </p:nvSpPr>
@@ -3511,7 +3858,7 @@
       </p:sp>
       <p:sp>
         <p:nvSpPr>
-          <p:cNvPr id="65" name="Shape 59"/>
+          <p:cNvPr id="71" name="Shape 65"/>
           <p:cNvSpPr/>
           <p:nvPr/>
         </p:nvSpPr>
@@ -3531,7 +3878,7 @@
       </p:sp>
       <p:sp>
         <p:nvSpPr>
-          <p:cNvPr id="66" name="Shape 60"/>
+          <p:cNvPr id="72" name="Shape 66"/>
           <p:cNvSpPr/>
           <p:nvPr/>
         </p:nvSpPr>
@@ -3565,7 +3912,7 @@
       </p:sp>
       <p:sp>
         <p:nvSpPr>
-          <p:cNvPr id="67" name="Shape 61"/>
+          <p:cNvPr id="73" name="Shape 67"/>
           <p:cNvSpPr/>
           <p:nvPr/>
         </p:nvSpPr>
@@ -3599,7 +3946,7 @@
       </p:sp>
       <p:pic>
         <p:nvPicPr>
-          <p:cNvPr id="68" name="Image 4" descr="/home/user/career-ops/5-intraop-perforation.jpeg">    </p:cNvPr>
+          <p:cNvPr id="74" name="Image 4" descr="/home/user/career-ops/5-intraop-perforation.jpeg">    </p:cNvPr>
           <p:cNvPicPr>
             <a:picLocks noChangeAspect="1"/>
           </p:cNvPicPr>
@@ -3623,7 +3970,7 @@
       </p:pic>
       <p:sp>
         <p:nvSpPr>
-          <p:cNvPr id="69" name="Shape 62"/>
+          <p:cNvPr id="75" name="Shape 68"/>
           <p:cNvSpPr/>
           <p:nvPr/>
         </p:nvSpPr>
@@ -3655,7 +4002,7 @@
       </p:sp>
       <p:sp>
         <p:nvSpPr>
-          <p:cNvPr id="70" name="Text 63"/>
+          <p:cNvPr id="76" name="Text 69"/>
           <p:cNvSpPr/>
           <p:nvPr/>
         </p:nvSpPr>
@@ -3694,7 +4041,7 @@
       </p:sp>
       <p:sp>
         <p:nvSpPr>
-          <p:cNvPr id="71" name="Text 64"/>
+          <p:cNvPr id="77" name="Text 70"/>
           <p:cNvSpPr/>
           <p:nvPr/>
         </p:nvSpPr>
@@ -3747,7 +4094,7 @@
       </p:sp>
       <p:sp>
         <p:nvSpPr>
-          <p:cNvPr id="72" name="Shape 65"/>
+          <p:cNvPr id="78" name="Shape 71"/>
           <p:cNvSpPr/>
           <p:nvPr/>
         </p:nvSpPr>
@@ -3767,7 +4114,7 @@
       </p:sp>
       <p:sp>
         <p:nvSpPr>
-          <p:cNvPr id="73" name="Shape 66"/>
+          <p:cNvPr id="79" name="Shape 72"/>
           <p:cNvSpPr/>
           <p:nvPr/>
         </p:nvSpPr>
@@ -3801,7 +4148,7 @@
       </p:sp>
       <p:sp>
         <p:nvSpPr>
-          <p:cNvPr id="74" name="Shape 67"/>
+          <p:cNvPr id="80" name="Shape 73"/>
           <p:cNvSpPr/>
           <p:nvPr/>
         </p:nvSpPr>
@@ -3835,7 +4182,7 @@
       </p:sp>
       <p:pic>
         <p:nvPicPr>
-          <p:cNvPr id="75" name="Image 5" descr="/home/user/career-ops/3-histopath-idc.jpeg">    </p:cNvPr>
+          <p:cNvPr id="81" name="Image 5" descr="/home/user/career-ops/3-histopath-idc.jpeg">    </p:cNvPr>
           <p:cNvPicPr>
             <a:picLocks noChangeAspect="1"/>
           </p:cNvPicPr>
@@ -3859,7 +4206,7 @@
       </p:pic>
       <p:sp>
         <p:nvSpPr>
-          <p:cNvPr id="76" name="Shape 68"/>
+          <p:cNvPr id="82" name="Shape 74"/>
           <p:cNvSpPr/>
           <p:nvPr/>
         </p:nvSpPr>
@@ -3891,7 +4238,7 @@
       </p:sp>
       <p:sp>
         <p:nvSpPr>
-          <p:cNvPr id="77" name="Text 69"/>
+          <p:cNvPr id="83" name="Text 75"/>
           <p:cNvSpPr/>
           <p:nvPr/>
         </p:nvSpPr>
@@ -3930,7 +4277,7 @@
       </p:sp>
       <p:sp>
         <p:nvSpPr>
-          <p:cNvPr id="78" name="Text 70"/>
+          <p:cNvPr id="84" name="Text 76"/>
           <p:cNvSpPr/>
           <p:nvPr/>
         </p:nvSpPr>
@@ -3983,7 +4330,7 @@
       </p:sp>
       <p:sp>
         <p:nvSpPr>
-          <p:cNvPr id="79" name="Shape 71"/>
+          <p:cNvPr id="85" name="Shape 77"/>
           <p:cNvSpPr/>
           <p:nvPr/>
         </p:nvSpPr>
@@ -4005,7 +4352,7 @@
       </p:sp>
       <p:sp>
         <p:nvSpPr>
-          <p:cNvPr id="80" name="Text 72"/>
+          <p:cNvPr id="86" name="Text 78"/>
           <p:cNvSpPr/>
           <p:nvPr/>
         </p:nvSpPr>
@@ -4058,7 +4405,7 @@
       </p:sp>
       <p:sp>
         <p:nvSpPr>
-          <p:cNvPr id="81" name="Text 73"/>
+          <p:cNvPr id="87" name="Text 79"/>
           <p:cNvSpPr/>
           <p:nvPr/>
         </p:nvSpPr>

</xml_diff>

<commit_message>
Poster: improved version — add IHC confirmation + management, cut redundancy
- Histopathology: add immunohistochemistry confirmation of breast origin
  (GATA3/GCDFP-15/mammaglobin/ER; E-cadherin for ductal type), cited to Gown 2016
- Discussion: add management line; remove points now covered in Background
- Background: consolidate to two non-redundant, sourced statements
- Add reference 5 (Gown AM, Histopathology 2016) — five verified references total
- Rebalance type (body 32pt) so all expanded content fits both columns to the footer

Co-Authored-By: Claude Opus 4.8 <noreply@anthropic.com>
Claude-Session: https://claude.ai/code/session_01Hys1rt1JVnsf8msS2XZJ53
</commit_message>
<xml_diff>
--- a/TNASICON2026-Poster-Metastatic-Ileal-Perforation.pptx
+++ b/TNASICON2026-Poster-Metastatic-Ileal-Perforation.pptx
@@ -1641,7 +1641,7 @@
         </p:nvSpPr>
         <p:spPr>
           <a:xfrm>
-            <a:off x="720000" y="7568856"/>
+            <a:off x="720000" y="9487248"/>
             <a:ext cx="310896" cy="310896"/>
           </a:xfrm>
           <a:prstGeom prst="ellipse">
@@ -1661,7 +1661,7 @@
         </p:nvSpPr>
         <p:spPr>
           <a:xfrm>
-            <a:off x="1213776" y="7459128"/>
+            <a:off x="1213776" y="9377520"/>
             <a:ext cx="7918992" cy="603504"/>
           </a:xfrm>
           <a:prstGeom prst="rect">
@@ -1700,8 +1700,8 @@
         </p:nvSpPr>
         <p:spPr>
           <a:xfrm>
-            <a:off x="756576" y="8208936"/>
-            <a:ext cx="8339616" cy="7644384"/>
+            <a:off x="756576" y="10127328"/>
+            <a:ext cx="8339616" cy="5279136"/>
           </a:xfrm>
           <a:prstGeom prst="rect">
             <a:avLst/>
@@ -1721,7 +1721,7 @@
               <a:buChar char="•"/>
             </a:pPr>
             <a:r>
-              <a:rPr lang="en-US" sz="3300" dirty="0">
+              <a:rPr lang="en-US" sz="3200" dirty="0">
                 <a:solidFill>
                   <a:srgbClr val="333333"/>
                 </a:solidFill>
@@ -1731,7 +1731,7 @@
               </a:rPr>
               <a:t>Breast carcinoma most often metastasises to bone, liver and lung; gastrointestinal spread is rare and arises far more often from lobular than from ductal carcinoma. [1, 2]</a:t>
             </a:r>
-            <a:endParaRPr lang="en-US" sz="3300" dirty="0"/>
+            <a:endParaRPr lang="en-US" sz="3200" dirty="0"/>
           </a:p>
           <a:p>
             <a:pPr algn="l" marL="228600" indent="-228600">
@@ -1742,7 +1742,7 @@
               <a:buChar char="•"/>
             </a:pPr>
             <a:r>
-              <a:rPr lang="en-US" sz="3300" dirty="0">
+              <a:rPr lang="en-US" sz="3200" dirty="0">
                 <a:solidFill>
                   <a:srgbClr val="333333"/>
                 </a:solidFill>
@@ -1750,10 +1750,91 @@
                 <a:ea typeface="Calibri" pitchFamily="34" charset="-122"/>
                 <a:cs typeface="Calibri" pitchFamily="34" charset="-120"/>
               </a:rPr>
-              <a:t>Intestinal metastasis from breast carcinoma is uncommon, and perforation as the initial manifestation is exceedingly rare.</a:t>
-            </a:r>
-            <a:endParaRPr lang="en-US" sz="3300" dirty="0"/>
-          </a:p>
+              <a:t>Intestinal metastasis from breast carcinoma is uncommon, and perforation as the initial manifestation is exceedingly rare — only a limited number of cases have been reported. [3, 4]</a:t>
+            </a:r>
+            <a:endParaRPr lang="en-US" sz="3200" dirty="0"/>
+          </a:p>
+        </p:txBody>
+      </p:sp>
+      <p:sp>
+        <p:nvSpPr>
+          <p:cNvPr id="23" name="Shape 20"/>
+          <p:cNvSpPr/>
+          <p:nvPr/>
+        </p:nvSpPr>
+        <p:spPr>
+          <a:xfrm>
+            <a:off x="720000" y="16960944"/>
+            <a:ext cx="310896" cy="310896"/>
+          </a:xfrm>
+          <a:prstGeom prst="ellipse">
+            <a:avLst/>
+          </a:prstGeom>
+          <a:solidFill>
+            <a:srgbClr val="2A9D8F"/>
+          </a:solidFill>
+          <a:ln/>
+        </p:spPr>
+      </p:sp>
+      <p:sp>
+        <p:nvSpPr>
+          <p:cNvPr id="24" name="Text 21"/>
+          <p:cNvSpPr/>
+          <p:nvPr/>
+        </p:nvSpPr>
+        <p:spPr>
+          <a:xfrm>
+            <a:off x="1213776" y="16851216"/>
+            <a:ext cx="7918992" cy="603504"/>
+          </a:xfrm>
+          <a:prstGeom prst="rect">
+            <a:avLst/>
+          </a:prstGeom>
+          <a:noFill/>
+          <a:ln/>
+        </p:spPr>
+        <p:txBody>
+          <a:bodyPr wrap="square" lIns="0" tIns="0" rIns="0" bIns="0" rtlCol="0" anchor="ctr"/>
+          <a:lstStyle/>
+          <a:p>
+            <a:pPr algn="l" indent="0" marL="0">
+              <a:buNone/>
+            </a:pPr>
+            <a:r>
+              <a:rPr lang="en-US" sz="3700" b="1" dirty="0">
+                <a:solidFill>
+                  <a:srgbClr val="12355B"/>
+                </a:solidFill>
+                <a:latin typeface="Cambria" pitchFamily="34" charset="0"/>
+                <a:ea typeface="Cambria" pitchFamily="34" charset="-122"/>
+                <a:cs typeface="Cambria" pitchFamily="34" charset="-120"/>
+              </a:rPr>
+              <a:t>Case Presentation</a:t>
+            </a:r>
+            <a:endParaRPr lang="en-US" sz="3700" dirty="0"/>
+          </a:p>
+        </p:txBody>
+      </p:sp>
+      <p:sp>
+        <p:nvSpPr>
+          <p:cNvPr id="25" name="Text 22"/>
+          <p:cNvSpPr/>
+          <p:nvPr/>
+        </p:nvSpPr>
+        <p:spPr>
+          <a:xfrm>
+            <a:off x="756576" y="17601024"/>
+            <a:ext cx="8339616" cy="4404360"/>
+          </a:xfrm>
+          <a:prstGeom prst="rect">
+            <a:avLst/>
+          </a:prstGeom>
+          <a:noFill/>
+          <a:ln/>
+        </p:spPr>
+        <p:txBody>
+          <a:bodyPr wrap="square" lIns="0" tIns="0" rIns="0" bIns="0" rtlCol="0" anchor="t"/>
+          <a:lstStyle/>
           <a:p>
             <a:pPr algn="l" marL="228600" indent="-228600">
               <a:spcAft>
@@ -1763,17 +1844,17 @@
               <a:buChar char="•"/>
             </a:pPr>
             <a:r>
-              <a:rPr lang="en-US" sz="3300" dirty="0">
-                <a:solidFill>
-                  <a:srgbClr val="333333"/>
-                </a:solidFill>
-                <a:latin typeface="Calibri" pitchFamily="34" charset="0"/>
-                <a:ea typeface="Calibri" pitchFamily="34" charset="-122"/>
-                <a:cs typeface="Calibri" pitchFamily="34" charset="-120"/>
-              </a:rPr>
-              <a:t>Only a limited number of similar cases have been reported. [3, 4]</a:t>
-            </a:r>
-            <a:endParaRPr lang="en-US" sz="3300" dirty="0"/>
+              <a:rPr lang="en-US" sz="3200" b="1" dirty="0">
+                <a:solidFill>
+                  <a:srgbClr val="12355B"/>
+                </a:solidFill>
+                <a:latin typeface="Calibri" pitchFamily="34" charset="0"/>
+                <a:ea typeface="Calibri" pitchFamily="34" charset="-122"/>
+                <a:cs typeface="Calibri" pitchFamily="34" charset="-120"/>
+              </a:rPr>
+              <a:t>38-year-old woman with abdominal pain for two days.</a:t>
+            </a:r>
+            <a:endParaRPr lang="en-US" sz="3200" dirty="0"/>
           </a:p>
           <a:p>
             <a:pPr algn="l" marL="228600" indent="-228600">
@@ -1784,7 +1865,7 @@
               <a:buChar char="•"/>
             </a:pPr>
             <a:r>
-              <a:rPr lang="en-US" sz="3300" dirty="0">
+              <a:rPr lang="en-US" sz="3200" dirty="0">
                 <a:solidFill>
                   <a:srgbClr val="333333"/>
                 </a:solidFill>
@@ -1792,91 +1873,10 @@
                 <a:ea typeface="Calibri" pitchFamily="34" charset="-122"/>
                 <a:cs typeface="Calibri" pitchFamily="34" charset="-120"/>
               </a:rPr>
-              <a:t>An acute surgical abdomen may represent the first presentation of metastatic malignancy.</a:t>
-            </a:r>
-            <a:endParaRPr lang="en-US" sz="3300" dirty="0"/>
-          </a:p>
-        </p:txBody>
-      </p:sp>
-      <p:sp>
-        <p:nvSpPr>
-          <p:cNvPr id="23" name="Shape 20"/>
-          <p:cNvSpPr/>
-          <p:nvPr/>
-        </p:nvSpPr>
-        <p:spPr>
-          <a:xfrm>
-            <a:off x="720000" y="17672814"/>
-            <a:ext cx="310896" cy="310896"/>
-          </a:xfrm>
-          <a:prstGeom prst="ellipse">
-            <a:avLst/>
-          </a:prstGeom>
-          <a:solidFill>
-            <a:srgbClr val="2A9D8F"/>
-          </a:solidFill>
-          <a:ln/>
-        </p:spPr>
-      </p:sp>
-      <p:sp>
-        <p:nvSpPr>
-          <p:cNvPr id="24" name="Text 21"/>
-          <p:cNvSpPr/>
-          <p:nvPr/>
-        </p:nvSpPr>
-        <p:spPr>
-          <a:xfrm>
-            <a:off x="1213776" y="17563086"/>
-            <a:ext cx="7918992" cy="603504"/>
-          </a:xfrm>
-          <a:prstGeom prst="rect">
-            <a:avLst/>
-          </a:prstGeom>
-          <a:noFill/>
-          <a:ln/>
-        </p:spPr>
-        <p:txBody>
-          <a:bodyPr wrap="square" lIns="0" tIns="0" rIns="0" bIns="0" rtlCol="0" anchor="ctr"/>
-          <a:lstStyle/>
-          <a:p>
-            <a:pPr algn="l" indent="0" marL="0">
-              <a:buNone/>
-            </a:pPr>
-            <a:r>
-              <a:rPr lang="en-US" sz="3700" b="1" dirty="0">
-                <a:solidFill>
-                  <a:srgbClr val="12355B"/>
-                </a:solidFill>
-                <a:latin typeface="Cambria" pitchFamily="34" charset="0"/>
-                <a:ea typeface="Cambria" pitchFamily="34" charset="-122"/>
-                <a:cs typeface="Cambria" pitchFamily="34" charset="-120"/>
-              </a:rPr>
-              <a:t>Case Presentation</a:t>
-            </a:r>
-            <a:endParaRPr lang="en-US" sz="3700" dirty="0"/>
-          </a:p>
-        </p:txBody>
-      </p:sp>
-      <p:sp>
-        <p:nvSpPr>
-          <p:cNvPr id="25" name="Text 22"/>
-          <p:cNvSpPr/>
-          <p:nvPr/>
-        </p:nvSpPr>
-        <p:spPr>
-          <a:xfrm>
-            <a:off x="756576" y="18312894"/>
-            <a:ext cx="8339616" cy="4526280"/>
-          </a:xfrm>
-          <a:prstGeom prst="rect">
-            <a:avLst/>
-          </a:prstGeom>
-          <a:noFill/>
-          <a:ln/>
-        </p:spPr>
-        <p:txBody>
-          <a:bodyPr wrap="square" lIns="0" tIns="0" rIns="0" bIns="0" rtlCol="0" anchor="t"/>
-          <a:lstStyle/>
+              <a:t>History of chronic NSAID abuse for pain related to a right breast lump, which had been misdiagnosed as a breast abscess.</a:t>
+            </a:r>
+            <a:endParaRPr lang="en-US" sz="3200" dirty="0"/>
+          </a:p>
           <a:p>
             <a:pPr algn="l" marL="228600" indent="-228600">
               <a:spcAft>
@@ -1886,18 +1886,99 @@
               <a:buChar char="•"/>
             </a:pPr>
             <a:r>
-              <a:rPr lang="en-US" sz="3300" b="1" dirty="0">
+              <a:rPr lang="en-US" sz="3200" dirty="0">
+                <a:solidFill>
+                  <a:srgbClr val="333333"/>
+                </a:solidFill>
+                <a:latin typeface="Calibri" pitchFamily="34" charset="0"/>
+                <a:ea typeface="Calibri" pitchFamily="34" charset="-122"/>
+                <a:cs typeface="Calibri" pitchFamily="34" charset="-120"/>
+              </a:rPr>
+              <a:t>On examination: tachycardic, with generalized abdominal rigidity.</a:t>
+            </a:r>
+            <a:endParaRPr lang="en-US" sz="3200" dirty="0"/>
+          </a:p>
+        </p:txBody>
+      </p:sp>
+      <p:sp>
+        <p:nvSpPr>
+          <p:cNvPr id="26" name="Shape 23"/>
+          <p:cNvSpPr/>
+          <p:nvPr/>
+        </p:nvSpPr>
+        <p:spPr>
+          <a:xfrm>
+            <a:off x="720000" y="23559864"/>
+            <a:ext cx="310896" cy="310896"/>
+          </a:xfrm>
+          <a:prstGeom prst="ellipse">
+            <a:avLst/>
+          </a:prstGeom>
+          <a:solidFill>
+            <a:srgbClr val="2A9D8F"/>
+          </a:solidFill>
+          <a:ln/>
+        </p:spPr>
+      </p:sp>
+      <p:sp>
+        <p:nvSpPr>
+          <p:cNvPr id="27" name="Text 24"/>
+          <p:cNvSpPr/>
+          <p:nvPr/>
+        </p:nvSpPr>
+        <p:spPr>
+          <a:xfrm>
+            <a:off x="1213776" y="23450136"/>
+            <a:ext cx="7918992" cy="603504"/>
+          </a:xfrm>
+          <a:prstGeom prst="rect">
+            <a:avLst/>
+          </a:prstGeom>
+          <a:noFill/>
+          <a:ln/>
+        </p:spPr>
+        <p:txBody>
+          <a:bodyPr wrap="square" lIns="0" tIns="0" rIns="0" bIns="0" rtlCol="0" anchor="ctr"/>
+          <a:lstStyle/>
+          <a:p>
+            <a:pPr algn="l" indent="0" marL="0">
+              <a:buNone/>
+            </a:pPr>
+            <a:r>
+              <a:rPr lang="en-US" sz="3700" b="1" dirty="0">
                 <a:solidFill>
                   <a:srgbClr val="12355B"/>
                 </a:solidFill>
-                <a:latin typeface="Calibri" pitchFamily="34" charset="0"/>
-                <a:ea typeface="Calibri" pitchFamily="34" charset="-122"/>
-                <a:cs typeface="Calibri" pitchFamily="34" charset="-120"/>
-              </a:rPr>
-              <a:t>38-year-old woman with abdominal pain for two days.</a:t>
-            </a:r>
-            <a:endParaRPr lang="en-US" sz="3300" dirty="0"/>
-          </a:p>
+                <a:latin typeface="Cambria" pitchFamily="34" charset="0"/>
+                <a:ea typeface="Cambria" pitchFamily="34" charset="-122"/>
+                <a:cs typeface="Cambria" pitchFamily="34" charset="-120"/>
+              </a:rPr>
+              <a:t>Investigations</a:t>
+            </a:r>
+            <a:endParaRPr lang="en-US" sz="3700" dirty="0"/>
+          </a:p>
+        </p:txBody>
+      </p:sp>
+      <p:sp>
+        <p:nvSpPr>
+          <p:cNvPr id="28" name="Text 25"/>
+          <p:cNvSpPr/>
+          <p:nvPr/>
+        </p:nvSpPr>
+        <p:spPr>
+          <a:xfrm>
+            <a:off x="756576" y="24199944"/>
+            <a:ext cx="8339616" cy="2353056"/>
+          </a:xfrm>
+          <a:prstGeom prst="rect">
+            <a:avLst/>
+          </a:prstGeom>
+          <a:noFill/>
+          <a:ln/>
+        </p:spPr>
+        <p:txBody>
+          <a:bodyPr wrap="square" lIns="0" tIns="0" rIns="0" bIns="0" rtlCol="0" anchor="t"/>
+          <a:lstStyle/>
           <a:p>
             <a:pPr algn="l" marL="228600" indent="-228600">
               <a:spcAft>
@@ -1907,17 +1988,17 @@
               <a:buChar char="•"/>
             </a:pPr>
             <a:r>
-              <a:rPr lang="en-US" sz="3300" dirty="0">
-                <a:solidFill>
-                  <a:srgbClr val="333333"/>
-                </a:solidFill>
-                <a:latin typeface="Calibri" pitchFamily="34" charset="0"/>
-                <a:ea typeface="Calibri" pitchFamily="34" charset="-122"/>
-                <a:cs typeface="Calibri" pitchFamily="34" charset="-120"/>
-              </a:rPr>
-              <a:t>History of chronic NSAID abuse for pain related to a right breast lump, which had been misdiagnosed as a breast abscess.</a:t>
-            </a:r>
-            <a:endParaRPr lang="en-US" sz="3300" dirty="0"/>
+              <a:rPr lang="en-US" sz="3200" b="1" dirty="0">
+                <a:solidFill>
+                  <a:srgbClr val="12355B"/>
+                </a:solidFill>
+                <a:latin typeface="Calibri" pitchFamily="34" charset="0"/>
+                <a:ea typeface="Calibri" pitchFamily="34" charset="-122"/>
+                <a:cs typeface="Calibri" pitchFamily="34" charset="-120"/>
+              </a:rPr>
+              <a:t>Erect abdominal radiograph demonstrated pneumoperitoneum.</a:t>
+            </a:r>
+            <a:endParaRPr lang="en-US" sz="3200" dirty="0"/>
           </a:p>
           <a:p>
             <a:pPr algn="l" marL="228600" indent="-228600">
@@ -1928,7 +2009,7 @@
               <a:buChar char="•"/>
             </a:pPr>
             <a:r>
-              <a:rPr lang="en-US" sz="3300" dirty="0">
+              <a:rPr lang="en-US" sz="3200" dirty="0">
                 <a:solidFill>
                   <a:srgbClr val="333333"/>
                 </a:solidFill>
@@ -1936,21 +2017,21 @@
                 <a:ea typeface="Calibri" pitchFamily="34" charset="-122"/>
                 <a:cs typeface="Calibri" pitchFamily="34" charset="-120"/>
               </a:rPr>
-              <a:t>On examination: tachycardic, with generalized abdominal rigidity.</a:t>
-            </a:r>
-            <a:endParaRPr lang="en-US" sz="3300" dirty="0"/>
-          </a:p>
-        </p:txBody>
-      </p:sp>
-      <p:sp>
-        <p:nvSpPr>
-          <p:cNvPr id="26" name="Shape 23"/>
-          <p:cNvSpPr/>
-          <p:nvPr/>
-        </p:nvSpPr>
-        <p:spPr>
-          <a:xfrm>
-            <a:off x="720000" y="24658668"/>
+              <a:t>Findings prompted emergency exploratory laparotomy (see Figs 2–3).</a:t>
+            </a:r>
+            <a:endParaRPr lang="en-US" sz="3200" dirty="0"/>
+          </a:p>
+        </p:txBody>
+      </p:sp>
+      <p:sp>
+        <p:nvSpPr>
+          <p:cNvPr id="29" name="Shape 26"/>
+          <p:cNvSpPr/>
+          <p:nvPr/>
+        </p:nvSpPr>
+        <p:spPr>
+          <a:xfrm>
+            <a:off x="720000" y="28107480"/>
             <a:ext cx="310896" cy="310896"/>
           </a:xfrm>
           <a:prstGeom prst="ellipse">
@@ -1964,13 +2045,13 @@
       </p:sp>
       <p:sp>
         <p:nvSpPr>
-          <p:cNvPr id="27" name="Text 24"/>
-          <p:cNvSpPr/>
-          <p:nvPr/>
-        </p:nvSpPr>
-        <p:spPr>
-          <a:xfrm>
-            <a:off x="1213776" y="24548940"/>
+          <p:cNvPr id="30" name="Text 27"/>
+          <p:cNvSpPr/>
+          <p:nvPr/>
+        </p:nvSpPr>
+        <p:spPr>
+          <a:xfrm>
+            <a:off x="1213776" y="27997752"/>
             <a:ext cx="7918992" cy="603504"/>
           </a:xfrm>
           <a:prstGeom prst="rect">
@@ -1995,7 +2076,7 @@
                 <a:ea typeface="Cambria" pitchFamily="34" charset="-122"/>
                 <a:cs typeface="Cambria" pitchFamily="34" charset="-120"/>
               </a:rPr>
-              <a:t>Investigations</a:t>
+              <a:t>Differential Diagnosis</a:t>
             </a:r>
             <a:endParaRPr lang="en-US" sz="3700" dirty="0"/>
           </a:p>
@@ -2003,14 +2084,14 @@
       </p:sp>
       <p:sp>
         <p:nvSpPr>
-          <p:cNvPr id="28" name="Text 25"/>
-          <p:cNvSpPr/>
-          <p:nvPr/>
-        </p:nvSpPr>
-        <p:spPr>
-          <a:xfrm>
-            <a:off x="756576" y="25298748"/>
-            <a:ext cx="8339616" cy="2414016"/>
+          <p:cNvPr id="31" name="Text 28"/>
+          <p:cNvSpPr/>
+          <p:nvPr/>
+        </p:nvSpPr>
+        <p:spPr>
+          <a:xfrm>
+            <a:off x="756576" y="28747560"/>
+            <a:ext cx="8339616" cy="4117848"/>
           </a:xfrm>
           <a:prstGeom prst="rect">
             <a:avLst/>
@@ -2030,17 +2111,17 @@
               <a:buChar char="•"/>
             </a:pPr>
             <a:r>
-              <a:rPr lang="en-US" sz="3300" b="1" dirty="0">
-                <a:solidFill>
-                  <a:srgbClr val="12355B"/>
-                </a:solidFill>
-                <a:latin typeface="Calibri" pitchFamily="34" charset="0"/>
-                <a:ea typeface="Calibri" pitchFamily="34" charset="-122"/>
-                <a:cs typeface="Calibri" pitchFamily="34" charset="-120"/>
-              </a:rPr>
-              <a:t>Erect abdominal radiograph demonstrated pneumoperitoneum.</a:t>
-            </a:r>
-            <a:endParaRPr lang="en-US" sz="3300" dirty="0"/>
+              <a:rPr lang="en-US" sz="3200" dirty="0">
+                <a:solidFill>
+                  <a:srgbClr val="333333"/>
+                </a:solidFill>
+                <a:latin typeface="Calibri" pitchFamily="34" charset="0"/>
+                <a:ea typeface="Calibri" pitchFamily="34" charset="-122"/>
+                <a:cs typeface="Calibri" pitchFamily="34" charset="-120"/>
+              </a:rPr>
+              <a:t>NSAID-induced ulcer perforation</a:t>
+            </a:r>
+            <a:endParaRPr lang="en-US" sz="3200" dirty="0"/>
           </a:p>
           <a:p>
             <a:pPr algn="l" marL="228600" indent="-228600">
@@ -2051,7 +2132,7 @@
               <a:buChar char="•"/>
             </a:pPr>
             <a:r>
-              <a:rPr lang="en-US" sz="3300" dirty="0">
+              <a:rPr lang="en-US" sz="3200" dirty="0">
                 <a:solidFill>
                   <a:srgbClr val="333333"/>
                 </a:solidFill>
@@ -2059,91 +2140,10 @@
                 <a:ea typeface="Calibri" pitchFamily="34" charset="-122"/>
                 <a:cs typeface="Calibri" pitchFamily="34" charset="-120"/>
               </a:rPr>
-              <a:t>Findings prompted emergency exploratory laparotomy (see Figs 2–3).</a:t>
-            </a:r>
-            <a:endParaRPr lang="en-US" sz="3300" dirty="0"/>
-          </a:p>
-        </p:txBody>
-      </p:sp>
-      <p:sp>
-        <p:nvSpPr>
-          <p:cNvPr id="29" name="Shape 26"/>
-          <p:cNvSpPr/>
-          <p:nvPr/>
-        </p:nvSpPr>
-        <p:spPr>
-          <a:xfrm>
-            <a:off x="720000" y="29532258"/>
-            <a:ext cx="310896" cy="310896"/>
-          </a:xfrm>
-          <a:prstGeom prst="ellipse">
-            <a:avLst/>
-          </a:prstGeom>
-          <a:solidFill>
-            <a:srgbClr val="2A9D8F"/>
-          </a:solidFill>
-          <a:ln/>
-        </p:spPr>
-      </p:sp>
-      <p:sp>
-        <p:nvSpPr>
-          <p:cNvPr id="30" name="Text 27"/>
-          <p:cNvSpPr/>
-          <p:nvPr/>
-        </p:nvSpPr>
-        <p:spPr>
-          <a:xfrm>
-            <a:off x="1213776" y="29422530"/>
-            <a:ext cx="7918992" cy="603504"/>
-          </a:xfrm>
-          <a:prstGeom prst="rect">
-            <a:avLst/>
-          </a:prstGeom>
-          <a:noFill/>
-          <a:ln/>
-        </p:spPr>
-        <p:txBody>
-          <a:bodyPr wrap="square" lIns="0" tIns="0" rIns="0" bIns="0" rtlCol="0" anchor="ctr"/>
-          <a:lstStyle/>
-          <a:p>
-            <a:pPr algn="l" indent="0" marL="0">
-              <a:buNone/>
-            </a:pPr>
-            <a:r>
-              <a:rPr lang="en-US" sz="3700" b="1" dirty="0">
-                <a:solidFill>
-                  <a:srgbClr val="12355B"/>
-                </a:solidFill>
-                <a:latin typeface="Cambria" pitchFamily="34" charset="0"/>
-                <a:ea typeface="Cambria" pitchFamily="34" charset="-122"/>
-                <a:cs typeface="Cambria" pitchFamily="34" charset="-120"/>
-              </a:rPr>
-              <a:t>Differential Diagnosis</a:t>
-            </a:r>
-            <a:endParaRPr lang="en-US" sz="3700" dirty="0"/>
-          </a:p>
-        </p:txBody>
-      </p:sp>
-      <p:sp>
-        <p:nvSpPr>
-          <p:cNvPr id="31" name="Text 28"/>
-          <p:cNvSpPr/>
-          <p:nvPr/>
-        </p:nvSpPr>
-        <p:spPr>
-          <a:xfrm>
-            <a:off x="756576" y="30172338"/>
-            <a:ext cx="8339616" cy="4224528"/>
-          </a:xfrm>
-          <a:prstGeom prst="rect">
-            <a:avLst/>
-          </a:prstGeom>
-          <a:noFill/>
-          <a:ln/>
-        </p:spPr>
-        <p:txBody>
-          <a:bodyPr wrap="square" lIns="0" tIns="0" rIns="0" bIns="0" rtlCol="0" anchor="t"/>
-          <a:lstStyle/>
+              <a:t>Infective enteritis (e.g., enteric fever)</a:t>
+            </a:r>
+            <a:endParaRPr lang="en-US" sz="3200" dirty="0"/>
+          </a:p>
           <a:p>
             <a:pPr algn="l" marL="228600" indent="-228600">
               <a:spcAft>
@@ -2153,7 +2153,7 @@
               <a:buChar char="•"/>
             </a:pPr>
             <a:r>
-              <a:rPr lang="en-US" sz="3300" dirty="0">
+              <a:rPr lang="en-US" sz="3200" dirty="0">
                 <a:solidFill>
                   <a:srgbClr val="333333"/>
                 </a:solidFill>
@@ -2161,9 +2161,9 @@
                 <a:ea typeface="Calibri" pitchFamily="34" charset="-122"/>
                 <a:cs typeface="Calibri" pitchFamily="34" charset="-120"/>
               </a:rPr>
-              <a:t>NSAID-induced ulcer perforation</a:t>
-            </a:r>
-            <a:endParaRPr lang="en-US" sz="3300" dirty="0"/>
+              <a:t>Intestinal tuberculosis</a:t>
+            </a:r>
+            <a:endParaRPr lang="en-US" sz="3200" dirty="0"/>
           </a:p>
           <a:p>
             <a:pPr algn="l" marL="228600" indent="-228600">
@@ -2174,7 +2174,7 @@
               <a:buChar char="•"/>
             </a:pPr>
             <a:r>
-              <a:rPr lang="en-US" sz="3300" dirty="0">
+              <a:rPr lang="en-US" sz="3200" dirty="0">
                 <a:solidFill>
                   <a:srgbClr val="333333"/>
                 </a:solidFill>
@@ -2182,9 +2182,9 @@
                 <a:ea typeface="Calibri" pitchFamily="34" charset="-122"/>
                 <a:cs typeface="Calibri" pitchFamily="34" charset="-120"/>
               </a:rPr>
-              <a:t>Infective enteritis (e.g., enteric fever)</a:t>
-            </a:r>
-            <a:endParaRPr lang="en-US" sz="3300" dirty="0"/>
+              <a:t>Primary small-bowel malignancy</a:t>
+            </a:r>
+            <a:endParaRPr lang="en-US" sz="3200" dirty="0"/>
           </a:p>
           <a:p>
             <a:pPr algn="l" marL="228600" indent="-228600">
@@ -2195,18 +2195,99 @@
               <a:buChar char="•"/>
             </a:pPr>
             <a:r>
-              <a:rPr lang="en-US" sz="3300" dirty="0">
-                <a:solidFill>
-                  <a:srgbClr val="333333"/>
-                </a:solidFill>
-                <a:latin typeface="Calibri" pitchFamily="34" charset="0"/>
-                <a:ea typeface="Calibri" pitchFamily="34" charset="-122"/>
-                <a:cs typeface="Calibri" pitchFamily="34" charset="-120"/>
-              </a:rPr>
-              <a:t>Intestinal tuberculosis</a:t>
-            </a:r>
-            <a:endParaRPr lang="en-US" sz="3300" dirty="0"/>
-          </a:p>
+              <a:rPr lang="en-US" sz="3200" b="1" dirty="0">
+                <a:solidFill>
+                  <a:srgbClr val="12355B"/>
+                </a:solidFill>
+                <a:latin typeface="Calibri" pitchFamily="34" charset="0"/>
+                <a:ea typeface="Calibri" pitchFamily="34" charset="-122"/>
+                <a:cs typeface="Calibri" pitchFamily="34" charset="-120"/>
+              </a:rPr>
+              <a:t>Metastatic malignancy — confirmed in this case</a:t>
+            </a:r>
+            <a:endParaRPr lang="en-US" sz="3200" dirty="0"/>
+          </a:p>
+        </p:txBody>
+      </p:sp>
+      <p:sp>
+        <p:nvSpPr>
+          <p:cNvPr id="32" name="Shape 29"/>
+          <p:cNvSpPr/>
+          <p:nvPr/>
+        </p:nvSpPr>
+        <p:spPr>
+          <a:xfrm>
+            <a:off x="720000" y="34419888"/>
+            <a:ext cx="310896" cy="310896"/>
+          </a:xfrm>
+          <a:prstGeom prst="ellipse">
+            <a:avLst/>
+          </a:prstGeom>
+          <a:solidFill>
+            <a:srgbClr val="2A9D8F"/>
+          </a:solidFill>
+          <a:ln/>
+        </p:spPr>
+      </p:sp>
+      <p:sp>
+        <p:nvSpPr>
+          <p:cNvPr id="33" name="Text 30"/>
+          <p:cNvSpPr/>
+          <p:nvPr/>
+        </p:nvSpPr>
+        <p:spPr>
+          <a:xfrm>
+            <a:off x="1213776" y="34310160"/>
+            <a:ext cx="7918992" cy="603504"/>
+          </a:xfrm>
+          <a:prstGeom prst="rect">
+            <a:avLst/>
+          </a:prstGeom>
+          <a:noFill/>
+          <a:ln/>
+        </p:spPr>
+        <p:txBody>
+          <a:bodyPr wrap="square" lIns="0" tIns="0" rIns="0" bIns="0" rtlCol="0" anchor="ctr"/>
+          <a:lstStyle/>
+          <a:p>
+            <a:pPr algn="l" indent="0" marL="0">
+              <a:buNone/>
+            </a:pPr>
+            <a:r>
+              <a:rPr lang="en-US" sz="3700" b="1" dirty="0">
+                <a:solidFill>
+                  <a:srgbClr val="12355B"/>
+                </a:solidFill>
+                <a:latin typeface="Cambria" pitchFamily="34" charset="0"/>
+                <a:ea typeface="Cambria" pitchFamily="34" charset="-122"/>
+                <a:cs typeface="Cambria" pitchFamily="34" charset="-120"/>
+              </a:rPr>
+              <a:t>Operative Findings</a:t>
+            </a:r>
+            <a:endParaRPr lang="en-US" sz="3700" dirty="0"/>
+          </a:p>
+        </p:txBody>
+      </p:sp>
+      <p:sp>
+        <p:nvSpPr>
+          <p:cNvPr id="34" name="Text 31"/>
+          <p:cNvSpPr/>
+          <p:nvPr/>
+        </p:nvSpPr>
+        <p:spPr>
+          <a:xfrm>
+            <a:off x="756576" y="35059968"/>
+            <a:ext cx="8339616" cy="4404360"/>
+          </a:xfrm>
+          <a:prstGeom prst="rect">
+            <a:avLst/>
+          </a:prstGeom>
+          <a:noFill/>
+          <a:ln/>
+        </p:spPr>
+        <p:txBody>
+          <a:bodyPr wrap="square" lIns="0" tIns="0" rIns="0" bIns="0" rtlCol="0" anchor="t"/>
+          <a:lstStyle/>
           <a:p>
             <a:pPr algn="l" marL="228600" indent="-228600">
               <a:spcAft>
@@ -2216,7 +2297,7 @@
               <a:buChar char="•"/>
             </a:pPr>
             <a:r>
-              <a:rPr lang="en-US" sz="3300" dirty="0">
+              <a:rPr lang="en-US" sz="3200" dirty="0">
                 <a:solidFill>
                   <a:srgbClr val="333333"/>
                 </a:solidFill>
@@ -2224,9 +2305,9 @@
                 <a:ea typeface="Calibri" pitchFamily="34" charset="-122"/>
                 <a:cs typeface="Calibri" pitchFamily="34" charset="-120"/>
               </a:rPr>
-              <a:t>Primary small-bowel malignancy</a:t>
-            </a:r>
-            <a:endParaRPr lang="en-US" sz="3300" dirty="0"/>
+              <a:t>Emergency exploratory laparotomy performed.</a:t>
+            </a:r>
+            <a:endParaRPr lang="en-US" sz="3200" dirty="0"/>
           </a:p>
           <a:p>
             <a:pPr algn="l" marL="228600" indent="-228600">
@@ -2237,7 +2318,7 @@
               <a:buChar char="•"/>
             </a:pPr>
             <a:r>
-              <a:rPr lang="en-US" sz="3300" b="1" dirty="0">
+              <a:rPr lang="en-US" sz="3200" b="1" dirty="0">
                 <a:solidFill>
                   <a:srgbClr val="12355B"/>
                 </a:solidFill>
@@ -2245,91 +2326,10 @@
                 <a:ea typeface="Calibri" pitchFamily="34" charset="-122"/>
                 <a:cs typeface="Calibri" pitchFamily="34" charset="-120"/>
               </a:rPr>
-              <a:t>Metastatic malignancy — confirmed in this case</a:t>
-            </a:r>
-            <a:endParaRPr lang="en-US" sz="3300" dirty="0"/>
-          </a:p>
-        </p:txBody>
-      </p:sp>
-      <p:sp>
-        <p:nvSpPr>
-          <p:cNvPr id="32" name="Shape 29"/>
-          <p:cNvSpPr/>
-          <p:nvPr/>
-        </p:nvSpPr>
-        <p:spPr>
-          <a:xfrm>
-            <a:off x="720000" y="36216360"/>
-            <a:ext cx="310896" cy="310896"/>
-          </a:xfrm>
-          <a:prstGeom prst="ellipse">
-            <a:avLst/>
-          </a:prstGeom>
-          <a:solidFill>
-            <a:srgbClr val="2A9D8F"/>
-          </a:solidFill>
-          <a:ln/>
-        </p:spPr>
-      </p:sp>
-      <p:sp>
-        <p:nvSpPr>
-          <p:cNvPr id="33" name="Text 30"/>
-          <p:cNvSpPr/>
-          <p:nvPr/>
-        </p:nvSpPr>
-        <p:spPr>
-          <a:xfrm>
-            <a:off x="1213776" y="36106632"/>
-            <a:ext cx="7918992" cy="603504"/>
-          </a:xfrm>
-          <a:prstGeom prst="rect">
-            <a:avLst/>
-          </a:prstGeom>
-          <a:noFill/>
-          <a:ln/>
-        </p:spPr>
-        <p:txBody>
-          <a:bodyPr wrap="square" lIns="0" tIns="0" rIns="0" bIns="0" rtlCol="0" anchor="ctr"/>
-          <a:lstStyle/>
-          <a:p>
-            <a:pPr algn="l" indent="0" marL="0">
-              <a:buNone/>
-            </a:pPr>
-            <a:r>
-              <a:rPr lang="en-US" sz="3700" b="1" dirty="0">
-                <a:solidFill>
-                  <a:srgbClr val="12355B"/>
-                </a:solidFill>
-                <a:latin typeface="Cambria" pitchFamily="34" charset="0"/>
-                <a:ea typeface="Cambria" pitchFamily="34" charset="-122"/>
-                <a:cs typeface="Cambria" pitchFamily="34" charset="-120"/>
-              </a:rPr>
-              <a:t>Operative Findings</a:t>
-            </a:r>
-            <a:endParaRPr lang="en-US" sz="3700" dirty="0"/>
-          </a:p>
-        </p:txBody>
-      </p:sp>
-      <p:sp>
-        <p:nvSpPr>
-          <p:cNvPr id="34" name="Text 31"/>
-          <p:cNvSpPr/>
-          <p:nvPr/>
-        </p:nvSpPr>
-        <p:spPr>
-          <a:xfrm>
-            <a:off x="756576" y="36856440"/>
-            <a:ext cx="8339616" cy="4526280"/>
-          </a:xfrm>
-          <a:prstGeom prst="rect">
-            <a:avLst/>
-          </a:prstGeom>
-          <a:noFill/>
-          <a:ln/>
-        </p:spPr>
-        <p:txBody>
-          <a:bodyPr wrap="square" lIns="0" tIns="0" rIns="0" bIns="0" rtlCol="0" anchor="t"/>
-          <a:lstStyle/>
+              <a:t>Solitary ileal perforation ≈ 0.5 × 0.5 cm, located 40 cm proximal to the ileocaecal junction.</a:t>
+            </a:r>
+            <a:endParaRPr lang="en-US" sz="3200" dirty="0"/>
+          </a:p>
           <a:p>
             <a:pPr algn="l" marL="228600" indent="-228600">
               <a:spcAft>
@@ -2339,7 +2339,7 @@
               <a:buChar char="•"/>
             </a:pPr>
             <a:r>
-              <a:rPr lang="en-US" sz="3300" dirty="0">
+              <a:rPr lang="en-US" sz="3200" dirty="0">
                 <a:solidFill>
                   <a:srgbClr val="333333"/>
                 </a:solidFill>
@@ -2347,10 +2347,91 @@
                 <a:ea typeface="Calibri" pitchFamily="34" charset="-122"/>
                 <a:cs typeface="Calibri" pitchFamily="34" charset="-120"/>
               </a:rPr>
-              <a:t>Emergency exploratory laparotomy performed.</a:t>
-            </a:r>
-            <a:endParaRPr lang="en-US" sz="3300" dirty="0"/>
-          </a:p>
+              <a:t>Primary closure of the perforation performed after obtaining a biopsy from the perforation margin.</a:t>
+            </a:r>
+            <a:endParaRPr lang="en-US" sz="3200" dirty="0"/>
+          </a:p>
+        </p:txBody>
+      </p:sp>
+      <p:sp>
+        <p:nvSpPr>
+          <p:cNvPr id="35" name="Shape 32"/>
+          <p:cNvSpPr/>
+          <p:nvPr/>
+        </p:nvSpPr>
+        <p:spPr>
+          <a:xfrm>
+            <a:off x="23267232" y="7568856"/>
+            <a:ext cx="310896" cy="310896"/>
+          </a:xfrm>
+          <a:prstGeom prst="ellipse">
+            <a:avLst/>
+          </a:prstGeom>
+          <a:solidFill>
+            <a:srgbClr val="2A9D8F"/>
+          </a:solidFill>
+          <a:ln/>
+        </p:spPr>
+      </p:sp>
+      <p:sp>
+        <p:nvSpPr>
+          <p:cNvPr id="36" name="Text 33"/>
+          <p:cNvSpPr/>
+          <p:nvPr/>
+        </p:nvSpPr>
+        <p:spPr>
+          <a:xfrm>
+            <a:off x="23761008" y="7459128"/>
+            <a:ext cx="7918992" cy="603504"/>
+          </a:xfrm>
+          <a:prstGeom prst="rect">
+            <a:avLst/>
+          </a:prstGeom>
+          <a:noFill/>
+          <a:ln/>
+        </p:spPr>
+        <p:txBody>
+          <a:bodyPr wrap="square" lIns="0" tIns="0" rIns="0" bIns="0" rtlCol="0" anchor="ctr"/>
+          <a:lstStyle/>
+          <a:p>
+            <a:pPr algn="l" indent="0" marL="0">
+              <a:buNone/>
+            </a:pPr>
+            <a:r>
+              <a:rPr lang="en-US" sz="3700" b="1" dirty="0">
+                <a:solidFill>
+                  <a:srgbClr val="12355B"/>
+                </a:solidFill>
+                <a:latin typeface="Cambria" pitchFamily="34" charset="0"/>
+                <a:ea typeface="Cambria" pitchFamily="34" charset="-122"/>
+                <a:cs typeface="Cambria" pitchFamily="34" charset="-120"/>
+              </a:rPr>
+              <a:t>Histopathology</a:t>
+            </a:r>
+            <a:endParaRPr lang="en-US" sz="3700" dirty="0"/>
+          </a:p>
+        </p:txBody>
+      </p:sp>
+      <p:sp>
+        <p:nvSpPr>
+          <p:cNvPr id="37" name="Text 34"/>
+          <p:cNvSpPr/>
+          <p:nvPr/>
+        </p:nvSpPr>
+        <p:spPr>
+          <a:xfrm>
+            <a:off x="23303808" y="8208936"/>
+            <a:ext cx="8339616" cy="5379720"/>
+          </a:xfrm>
+          <a:prstGeom prst="rect">
+            <a:avLst/>
+          </a:prstGeom>
+          <a:noFill/>
+          <a:ln/>
+        </p:spPr>
+        <p:txBody>
+          <a:bodyPr wrap="square" lIns="0" tIns="0" rIns="0" bIns="0" rtlCol="0" anchor="t"/>
+          <a:lstStyle/>
           <a:p>
             <a:pPr algn="l" marL="228600" indent="-228600">
               <a:spcAft>
@@ -2360,7 +2441,7 @@
               <a:buChar char="•"/>
             </a:pPr>
             <a:r>
-              <a:rPr lang="en-US" sz="3300" b="1" dirty="0">
+              <a:rPr lang="en-US" sz="3200" b="1" dirty="0">
                 <a:solidFill>
                   <a:srgbClr val="12355B"/>
                 </a:solidFill>
@@ -2368,9 +2449,9 @@
                 <a:ea typeface="Calibri" pitchFamily="34" charset="-122"/>
                 <a:cs typeface="Calibri" pitchFamily="34" charset="-120"/>
               </a:rPr>
-              <a:t>Solitary ileal perforation ≈ 0.5 × 0.5 cm, located 40 cm proximal to the ileocaecal junction.</a:t>
-            </a:r>
-            <a:endParaRPr lang="en-US" sz="3300" dirty="0"/>
+              <a:t>Trucut biopsy of the breast lump confirmed invasive ductal carcinoma.</a:t>
+            </a:r>
+            <a:endParaRPr lang="en-US" sz="3200" dirty="0"/>
           </a:p>
           <a:p>
             <a:pPr algn="l" marL="228600" indent="-228600">
@@ -2381,99 +2462,18 @@
               <a:buChar char="•"/>
             </a:pPr>
             <a:r>
-              <a:rPr lang="en-US" sz="3300" dirty="0">
-                <a:solidFill>
-                  <a:srgbClr val="333333"/>
-                </a:solidFill>
-                <a:latin typeface="Calibri" pitchFamily="34" charset="0"/>
-                <a:ea typeface="Calibri" pitchFamily="34" charset="-122"/>
-                <a:cs typeface="Calibri" pitchFamily="34" charset="-120"/>
-              </a:rPr>
-              <a:t>Primary closure of the perforation performed after obtaining a biopsy from the perforation margin.</a:t>
-            </a:r>
-            <a:endParaRPr lang="en-US" sz="3300" dirty="0"/>
-          </a:p>
-        </p:txBody>
-      </p:sp>
-      <p:sp>
-        <p:nvSpPr>
-          <p:cNvPr id="35" name="Shape 32"/>
-          <p:cNvSpPr/>
-          <p:nvPr/>
-        </p:nvSpPr>
-        <p:spPr>
-          <a:xfrm>
-            <a:off x="23267232" y="7568856"/>
-            <a:ext cx="310896" cy="310896"/>
-          </a:xfrm>
-          <a:prstGeom prst="ellipse">
-            <a:avLst/>
-          </a:prstGeom>
-          <a:solidFill>
-            <a:srgbClr val="2A9D8F"/>
-          </a:solidFill>
-          <a:ln/>
-        </p:spPr>
-      </p:sp>
-      <p:sp>
-        <p:nvSpPr>
-          <p:cNvPr id="36" name="Text 33"/>
-          <p:cNvSpPr/>
-          <p:nvPr/>
-        </p:nvSpPr>
-        <p:spPr>
-          <a:xfrm>
-            <a:off x="23761008" y="7459128"/>
-            <a:ext cx="7918992" cy="603504"/>
-          </a:xfrm>
-          <a:prstGeom prst="rect">
-            <a:avLst/>
-          </a:prstGeom>
-          <a:noFill/>
-          <a:ln/>
-        </p:spPr>
-        <p:txBody>
-          <a:bodyPr wrap="square" lIns="0" tIns="0" rIns="0" bIns="0" rtlCol="0" anchor="ctr"/>
-          <a:lstStyle/>
-          <a:p>
-            <a:pPr algn="l" indent="0" marL="0">
-              <a:buNone/>
-            </a:pPr>
-            <a:r>
-              <a:rPr lang="en-US" sz="3700" b="1" dirty="0">
+              <a:rPr lang="en-US" sz="3200" b="1" dirty="0">
                 <a:solidFill>
                   <a:srgbClr val="12355B"/>
                 </a:solidFill>
-                <a:latin typeface="Cambria" pitchFamily="34" charset="0"/>
-                <a:ea typeface="Cambria" pitchFamily="34" charset="-122"/>
-                <a:cs typeface="Cambria" pitchFamily="34" charset="-120"/>
-              </a:rPr>
-              <a:t>Histopathology</a:t>
-            </a:r>
-            <a:endParaRPr lang="en-US" sz="3700" dirty="0"/>
-          </a:p>
-        </p:txBody>
-      </p:sp>
-      <p:sp>
-        <p:nvSpPr>
-          <p:cNvPr id="37" name="Text 34"/>
-          <p:cNvSpPr/>
-          <p:nvPr/>
-        </p:nvSpPr>
-        <p:spPr>
-          <a:xfrm>
-            <a:off x="23303808" y="8208936"/>
-            <a:ext cx="8339616" cy="2916936"/>
-          </a:xfrm>
-          <a:prstGeom prst="rect">
-            <a:avLst/>
-          </a:prstGeom>
-          <a:noFill/>
-          <a:ln/>
-        </p:spPr>
-        <p:txBody>
-          <a:bodyPr wrap="square" lIns="0" tIns="0" rIns="0" bIns="0" rtlCol="0" anchor="t"/>
-          <a:lstStyle/>
+                <a:latin typeface="Calibri" pitchFamily="34" charset="0"/>
+                <a:ea typeface="Calibri" pitchFamily="34" charset="-122"/>
+                <a:cs typeface="Calibri" pitchFamily="34" charset="-120"/>
+              </a:rPr>
+              <a:t>Ileal perforation-margin biopsy demonstrated metastatic deposits at the perforation site.</a:t>
+            </a:r>
+            <a:endParaRPr lang="en-US" sz="3200" dirty="0"/>
+          </a:p>
           <a:p>
             <a:pPr algn="l" marL="228600" indent="-228600">
               <a:spcAft>
@@ -2483,18 +2483,99 @@
               <a:buChar char="•"/>
             </a:pPr>
             <a:r>
-              <a:rPr lang="en-US" sz="3300" b="1" dirty="0">
+              <a:rPr lang="en-US" sz="3200" dirty="0">
+                <a:solidFill>
+                  <a:srgbClr val="333333"/>
+                </a:solidFill>
+                <a:latin typeface="Calibri" pitchFamily="34" charset="0"/>
+                <a:ea typeface="Calibri" pitchFamily="34" charset="-122"/>
+                <a:cs typeface="Calibri" pitchFamily="34" charset="-120"/>
+              </a:rPr>
+              <a:t>Breast origin of intestinal metastases is confirmed on immunohistochemistry — GATA3 (most sensitive), GCDFP-15, mammaglobin and ER; E-cadherin positivity supports ductal type. [5]</a:t>
+            </a:r>
+            <a:endParaRPr lang="en-US" sz="3200" dirty="0"/>
+          </a:p>
+        </p:txBody>
+      </p:sp>
+      <p:sp>
+        <p:nvSpPr>
+          <p:cNvPr id="38" name="Shape 35"/>
+          <p:cNvSpPr/>
+          <p:nvPr/>
+        </p:nvSpPr>
+        <p:spPr>
+          <a:xfrm>
+            <a:off x="23267232" y="14254711"/>
+            <a:ext cx="310896" cy="310896"/>
+          </a:xfrm>
+          <a:prstGeom prst="ellipse">
+            <a:avLst/>
+          </a:prstGeom>
+          <a:solidFill>
+            <a:srgbClr val="2A9D8F"/>
+          </a:solidFill>
+          <a:ln/>
+        </p:spPr>
+      </p:sp>
+      <p:sp>
+        <p:nvSpPr>
+          <p:cNvPr id="39" name="Text 36"/>
+          <p:cNvSpPr/>
+          <p:nvPr/>
+        </p:nvSpPr>
+        <p:spPr>
+          <a:xfrm>
+            <a:off x="23761008" y="14144983"/>
+            <a:ext cx="7918992" cy="603504"/>
+          </a:xfrm>
+          <a:prstGeom prst="rect">
+            <a:avLst/>
+          </a:prstGeom>
+          <a:noFill/>
+          <a:ln/>
+        </p:spPr>
+        <p:txBody>
+          <a:bodyPr wrap="square" lIns="0" tIns="0" rIns="0" bIns="0" rtlCol="0" anchor="ctr"/>
+          <a:lstStyle/>
+          <a:p>
+            <a:pPr algn="l" indent="0" marL="0">
+              <a:buNone/>
+            </a:pPr>
+            <a:r>
+              <a:rPr lang="en-US" sz="3700" b="1" dirty="0">
                 <a:solidFill>
                   <a:srgbClr val="12355B"/>
                 </a:solidFill>
-                <a:latin typeface="Calibri" pitchFamily="34" charset="0"/>
-                <a:ea typeface="Calibri" pitchFamily="34" charset="-122"/>
-                <a:cs typeface="Calibri" pitchFamily="34" charset="-120"/>
-              </a:rPr>
-              <a:t>Trucut biopsy of the breast lump confirmed invasive ductal carcinoma.</a:t>
-            </a:r>
-            <a:endParaRPr lang="en-US" sz="3300" dirty="0"/>
-          </a:p>
+                <a:latin typeface="Cambria" pitchFamily="34" charset="0"/>
+                <a:ea typeface="Cambria" pitchFamily="34" charset="-122"/>
+                <a:cs typeface="Cambria" pitchFamily="34" charset="-120"/>
+              </a:rPr>
+              <a:t>Discussion</a:t>
+            </a:r>
+            <a:endParaRPr lang="en-US" sz="3700" dirty="0"/>
+          </a:p>
+        </p:txBody>
+      </p:sp>
+      <p:sp>
+        <p:nvSpPr>
+          <p:cNvPr id="40" name="Text 37"/>
+          <p:cNvSpPr/>
+          <p:nvPr/>
+        </p:nvSpPr>
+        <p:spPr>
+          <a:xfrm>
+            <a:off x="23303808" y="14894791"/>
+            <a:ext cx="8339616" cy="7918704"/>
+          </a:xfrm>
+          <a:prstGeom prst="rect">
+            <a:avLst/>
+          </a:prstGeom>
+          <a:noFill/>
+          <a:ln/>
+        </p:spPr>
+        <p:txBody>
+          <a:bodyPr wrap="square" lIns="0" tIns="0" rIns="0" bIns="0" rtlCol="0" anchor="t"/>
+          <a:lstStyle/>
           <a:p>
             <a:pPr algn="l" marL="228600" indent="-228600">
               <a:spcAft>
@@ -2504,99 +2585,18 @@
               <a:buChar char="•"/>
             </a:pPr>
             <a:r>
-              <a:rPr lang="en-US" sz="3300" b="1" dirty="0">
-                <a:solidFill>
-                  <a:srgbClr val="12355B"/>
-                </a:solidFill>
-                <a:latin typeface="Calibri" pitchFamily="34" charset="0"/>
-                <a:ea typeface="Calibri" pitchFamily="34" charset="-122"/>
-                <a:cs typeface="Calibri" pitchFamily="34" charset="-120"/>
-              </a:rPr>
-              <a:t>Histopathology of the ileal biopsy demonstrated metastatic deposits at the perforation site.</a:t>
-            </a:r>
-            <a:endParaRPr lang="en-US" sz="3300" dirty="0"/>
-          </a:p>
-        </p:txBody>
-      </p:sp>
-      <p:sp>
-        <p:nvSpPr>
-          <p:cNvPr id="38" name="Shape 35"/>
-          <p:cNvSpPr/>
-          <p:nvPr/>
-        </p:nvSpPr>
-        <p:spPr>
-          <a:xfrm>
-            <a:off x="23267232" y="12456774"/>
-            <a:ext cx="310896" cy="310896"/>
-          </a:xfrm>
-          <a:prstGeom prst="ellipse">
-            <a:avLst/>
-          </a:prstGeom>
-          <a:solidFill>
-            <a:srgbClr val="2A9D8F"/>
-          </a:solidFill>
-          <a:ln/>
-        </p:spPr>
-      </p:sp>
-      <p:sp>
-        <p:nvSpPr>
-          <p:cNvPr id="39" name="Text 36"/>
-          <p:cNvSpPr/>
-          <p:nvPr/>
-        </p:nvSpPr>
-        <p:spPr>
-          <a:xfrm>
-            <a:off x="23761008" y="12347046"/>
-            <a:ext cx="7918992" cy="603504"/>
-          </a:xfrm>
-          <a:prstGeom prst="rect">
-            <a:avLst/>
-          </a:prstGeom>
-          <a:noFill/>
-          <a:ln/>
-        </p:spPr>
-        <p:txBody>
-          <a:bodyPr wrap="square" lIns="0" tIns="0" rIns="0" bIns="0" rtlCol="0" anchor="ctr"/>
-          <a:lstStyle/>
-          <a:p>
-            <a:pPr algn="l" indent="0" marL="0">
-              <a:buNone/>
-            </a:pPr>
-            <a:r>
-              <a:rPr lang="en-US" sz="3700" b="1" dirty="0">
-                <a:solidFill>
-                  <a:srgbClr val="12355B"/>
-                </a:solidFill>
-                <a:latin typeface="Cambria" pitchFamily="34" charset="0"/>
-                <a:ea typeface="Cambria" pitchFamily="34" charset="-122"/>
-                <a:cs typeface="Cambria" pitchFamily="34" charset="-120"/>
-              </a:rPr>
-              <a:t>Discussion</a:t>
-            </a:r>
-            <a:endParaRPr lang="en-US" sz="3700" dirty="0"/>
-          </a:p>
-        </p:txBody>
-      </p:sp>
-      <p:sp>
-        <p:nvSpPr>
-          <p:cNvPr id="40" name="Text 37"/>
-          <p:cNvSpPr/>
-          <p:nvPr/>
-        </p:nvSpPr>
-        <p:spPr>
-          <a:xfrm>
-            <a:off x="23303808" y="13096854"/>
-            <a:ext cx="8339616" cy="7141464"/>
-          </a:xfrm>
-          <a:prstGeom prst="rect">
-            <a:avLst/>
-          </a:prstGeom>
-          <a:noFill/>
-          <a:ln/>
-        </p:spPr>
-        <p:txBody>
-          <a:bodyPr wrap="square" lIns="0" tIns="0" rIns="0" bIns="0" rtlCol="0" anchor="t"/>
-          <a:lstStyle/>
+              <a:rPr lang="en-US" sz="3200" dirty="0">
+                <a:solidFill>
+                  <a:srgbClr val="333333"/>
+                </a:solidFill>
+                <a:latin typeface="Calibri" pitchFamily="34" charset="0"/>
+                <a:ea typeface="Calibri" pitchFamily="34" charset="-122"/>
+                <a:cs typeface="Calibri" pitchFamily="34" charset="-120"/>
+              </a:rPr>
+              <a:t>The gastrointestinal tract is an unusual site for breast metastasis; the small bowel is rarer still, and perforation as the initial manifestation is exceptional.</a:t>
+            </a:r>
+            <a:endParaRPr lang="en-US" sz="3200" dirty="0"/>
+          </a:p>
           <a:p>
             <a:pPr algn="l" marL="228600" indent="-228600">
               <a:spcAft>
@@ -2606,7 +2606,7 @@
               <a:buChar char="•"/>
             </a:pPr>
             <a:r>
-              <a:rPr lang="en-US" sz="3300" dirty="0">
+              <a:rPr lang="en-US" sz="3200" dirty="0">
                 <a:solidFill>
                   <a:srgbClr val="333333"/>
                 </a:solidFill>
@@ -2614,9 +2614,9 @@
                 <a:ea typeface="Calibri" pitchFamily="34" charset="-122"/>
                 <a:cs typeface="Calibri" pitchFamily="34" charset="-120"/>
               </a:rPr>
-              <a:t>Intestinal metastasis from breast carcinoma is uncommon, and perforation as the initial manifestation is exceedingly rare.</a:t>
-            </a:r>
-            <a:endParaRPr lang="en-US" sz="3300" dirty="0"/>
+              <a:t>Diagnostic trap: acute peritonitis overshadows the primary, and the breast lump had been dismissed as an abscess — delaying the true diagnosis.</a:t>
+            </a:r>
+            <a:endParaRPr lang="en-US" sz="3200" dirty="0"/>
           </a:p>
           <a:p>
             <a:pPr algn="l" marL="228600" indent="-228600">
@@ -2627,7 +2627,7 @@
               <a:buChar char="•"/>
             </a:pPr>
             <a:r>
-              <a:rPr lang="en-US" sz="3300" dirty="0">
+              <a:rPr lang="en-US" sz="3200" dirty="0">
                 <a:solidFill>
                   <a:srgbClr val="333333"/>
                 </a:solidFill>
@@ -2635,9 +2635,9 @@
                 <a:ea typeface="Calibri" pitchFamily="34" charset="-122"/>
                 <a:cs typeface="Calibri" pitchFamily="34" charset="-120"/>
               </a:rPr>
-              <a:t>Only a limited number of similar cases have been reported.</a:t>
-            </a:r>
-            <a:endParaRPr lang="en-US" sz="3300" dirty="0"/>
+              <a:t>An acute surgical abdomen may be the first presentation of metastatic malignancy.</a:t>
+            </a:r>
+            <a:endParaRPr lang="en-US" sz="3200" dirty="0"/>
           </a:p>
           <a:p>
             <a:pPr algn="l" marL="228600" indent="-228600">
@@ -2648,7 +2648,7 @@
               <a:buChar char="•"/>
             </a:pPr>
             <a:r>
-              <a:rPr lang="en-US" sz="3300" dirty="0">
+              <a:rPr lang="en-US" sz="3200" dirty="0">
                 <a:solidFill>
                   <a:srgbClr val="333333"/>
                 </a:solidFill>
@@ -2656,30 +2656,9 @@
                 <a:ea typeface="Calibri" pitchFamily="34" charset="-122"/>
                 <a:cs typeface="Calibri" pitchFamily="34" charset="-120"/>
               </a:rPr>
-              <a:t>This case highlights that an acute surgical abdomen may represent the first presentation of metastatic malignancy.</a:t>
-            </a:r>
-            <a:endParaRPr lang="en-US" sz="3300" dirty="0"/>
-          </a:p>
-          <a:p>
-            <a:pPr algn="l" marL="228600" indent="-228600">
-              <a:spcAft>
-                <a:spcPts val="900"/>
-              </a:spcAft>
-              <a:buSzPct val="100000"/>
-              <a:buChar char="•"/>
-            </a:pPr>
-            <a:r>
-              <a:rPr lang="en-US" sz="3300" dirty="0">
-                <a:solidFill>
-                  <a:srgbClr val="333333"/>
-                </a:solidFill>
-                <a:latin typeface="Calibri" pitchFamily="34" charset="0"/>
-                <a:ea typeface="Calibri" pitchFamily="34" charset="-122"/>
-                <a:cs typeface="Calibri" pitchFamily="34" charset="-120"/>
-              </a:rPr>
-              <a:t>Management requires emergency surgery followed by evaluation of the primary breast malignancy.</a:t>
-            </a:r>
-            <a:endParaRPr lang="en-US" sz="3300" dirty="0"/>
+              <a:t>Management requires emergency surgery followed by evaluation and treatment of the primary breast malignancy.</a:t>
+            </a:r>
+            <a:endParaRPr lang="en-US" sz="3200" dirty="0"/>
           </a:p>
         </p:txBody>
       </p:sp>
@@ -2691,12 +2670,12 @@
         </p:nvSpPr>
         <p:spPr>
           <a:xfrm>
-            <a:off x="23267232" y="21477780"/>
-            <a:ext cx="8412768" cy="7183526"/>
+            <a:off x="23267232" y="23388109"/>
+            <a:ext cx="8412768" cy="6761988"/>
           </a:xfrm>
           <a:prstGeom prst="roundRect">
             <a:avLst>
-              <a:gd name="adj" fmla="val 1273"/>
+              <a:gd name="adj" fmla="val 1352"/>
             </a:avLst>
           </a:prstGeom>
           <a:solidFill>
@@ -2725,7 +2704,7 @@
         </p:nvSpPr>
         <p:spPr>
           <a:xfrm>
-            <a:off x="23559840" y="21962412"/>
+            <a:off x="23559840" y="23845309"/>
             <a:ext cx="310896" cy="310896"/>
           </a:xfrm>
           <a:prstGeom prst="ellipse">
@@ -2745,7 +2724,7 @@
         </p:nvSpPr>
         <p:spPr>
           <a:xfrm>
-            <a:off x="24035328" y="21889260"/>
+            <a:off x="24035328" y="23772157"/>
             <a:ext cx="7352064" cy="603504"/>
           </a:xfrm>
           <a:prstGeom prst="rect">
@@ -2784,8 +2763,8 @@
         </p:nvSpPr>
         <p:spPr>
           <a:xfrm>
-            <a:off x="23559840" y="22620780"/>
-            <a:ext cx="7827552" cy="5720486"/>
+            <a:off x="23559840" y="24503677"/>
+            <a:ext cx="7827552" cy="5372100"/>
           </a:xfrm>
           <a:prstGeom prst="rect">
             <a:avLst/>
@@ -2805,7 +2784,7 @@
               <a:buChar char="•"/>
             </a:pPr>
             <a:r>
-              <a:rPr lang="en-US" sz="3300" dirty="0">
+              <a:rPr lang="en-US" sz="3200" dirty="0">
                 <a:solidFill>
                   <a:srgbClr val="5A4A12"/>
                 </a:solidFill>
@@ -2815,7 +2794,7 @@
               </a:rPr>
               <a:t>Ileal perforation was the initial manifestation of previously unrecognised metastatic breast carcinoma.</a:t>
             </a:r>
-            <a:endParaRPr lang="en-US" sz="3300" dirty="0"/>
+            <a:endParaRPr lang="en-US" sz="3200" dirty="0"/>
           </a:p>
           <a:p>
             <a:pPr algn="l" marL="228600" indent="-228600">
@@ -2826,7 +2805,7 @@
               <a:buChar char="•"/>
             </a:pPr>
             <a:r>
-              <a:rPr lang="en-US" sz="3300" dirty="0">
+              <a:rPr lang="en-US" sz="3200" dirty="0">
                 <a:solidFill>
                   <a:srgbClr val="5A4A12"/>
                 </a:solidFill>
@@ -2836,7 +2815,7 @@
               </a:rPr>
               <a:t>Perforation as the first presentation is exceedingly rare, with only a limited number of reported cases.</a:t>
             </a:r>
-            <a:endParaRPr lang="en-US" sz="3300" dirty="0"/>
+            <a:endParaRPr lang="en-US" sz="3200" dirty="0"/>
           </a:p>
           <a:p>
             <a:pPr algn="l" marL="228600" indent="-228600">
@@ -2847,7 +2826,7 @@
               <a:buChar char="•"/>
             </a:pPr>
             <a:r>
-              <a:rPr lang="en-US" sz="3300" dirty="0">
+              <a:rPr lang="en-US" sz="3200" dirty="0">
                 <a:solidFill>
                   <a:srgbClr val="5A4A12"/>
                 </a:solidFill>
@@ -2857,7 +2836,7 @@
               </a:rPr>
               <a:t>Demonstrates that an acute surgical abdomen may be the first presentation of metastatic malignancy.</a:t>
             </a:r>
-            <a:endParaRPr lang="en-US" sz="3300" dirty="0"/>
+            <a:endParaRPr lang="en-US" sz="3200" dirty="0"/>
           </a:p>
         </p:txBody>
       </p:sp>
@@ -2869,12 +2848,12 @@
         </p:nvSpPr>
         <p:spPr>
           <a:xfrm>
-            <a:off x="23267232" y="29992209"/>
-            <a:ext cx="8412768" cy="5922203"/>
+            <a:off x="23267232" y="30816152"/>
+            <a:ext cx="8412768" cy="5578450"/>
           </a:xfrm>
           <a:prstGeom prst="roundRect">
             <a:avLst>
-              <a:gd name="adj" fmla="val 1544"/>
+              <a:gd name="adj" fmla="val 1639"/>
             </a:avLst>
           </a:prstGeom>
           <a:solidFill>
@@ -2898,7 +2877,7 @@
         </p:nvSpPr>
         <p:spPr>
           <a:xfrm>
-            <a:off x="23559840" y="30476841"/>
+            <a:off x="23559840" y="31273352"/>
             <a:ext cx="310896" cy="310896"/>
           </a:xfrm>
           <a:prstGeom prst="ellipse">
@@ -2918,7 +2897,7 @@
         </p:nvSpPr>
         <p:spPr>
           <a:xfrm>
-            <a:off x="24035328" y="30403689"/>
+            <a:off x="24035328" y="31200200"/>
             <a:ext cx="7352064" cy="603504"/>
           </a:xfrm>
           <a:prstGeom prst="rect">
@@ -2957,8 +2936,8 @@
         </p:nvSpPr>
         <p:spPr>
           <a:xfrm>
-            <a:off x="23559840" y="31135209"/>
-            <a:ext cx="7827552" cy="4459163"/>
+            <a:off x="23559840" y="31931720"/>
+            <a:ext cx="7827552" cy="4188562"/>
           </a:xfrm>
           <a:prstGeom prst="rect">
             <a:avLst/>
@@ -2978,7 +2957,7 @@
               <a:buChar char="•"/>
             </a:pPr>
             <a:r>
-              <a:rPr lang="en-US" sz="3300" dirty="0">
+              <a:rPr lang="en-US" sz="3200" dirty="0">
                 <a:solidFill>
                   <a:srgbClr val="EAF1F8"/>
                 </a:solidFill>
@@ -2988,7 +2967,7 @@
               </a:rPr>
               <a:t>Ileal perforation can rarely be the presenting manifestation of metastatic breast carcinoma.</a:t>
             </a:r>
-            <a:endParaRPr lang="en-US" sz="3300" dirty="0"/>
+            <a:endParaRPr lang="en-US" sz="3200" dirty="0"/>
           </a:p>
           <a:p>
             <a:pPr algn="l" marL="228600" indent="-228600">
@@ -2999,7 +2978,7 @@
               <a:buChar char="•"/>
             </a:pPr>
             <a:r>
-              <a:rPr lang="en-US" sz="3300" dirty="0">
+              <a:rPr lang="en-US" sz="3200" dirty="0">
                 <a:solidFill>
                   <a:srgbClr val="EAF1F8"/>
                 </a:solidFill>
@@ -3009,7 +2988,7 @@
               </a:rPr>
               <a:t>A high index of suspicion together with early histopathological confirmation is essential for accurate diagnosis and appropriate management.</a:t>
             </a:r>
-            <a:endParaRPr lang="en-US" sz="3300" dirty="0"/>
+            <a:endParaRPr lang="en-US" sz="3200" dirty="0"/>
           </a:p>
         </p:txBody>
       </p:sp>
@@ -3021,7 +3000,7 @@
         </p:nvSpPr>
         <p:spPr>
           <a:xfrm>
-            <a:off x="23267232" y="37336754"/>
+            <a:off x="23267232" y="37152096"/>
             <a:ext cx="310896" cy="310896"/>
           </a:xfrm>
           <a:prstGeom prst="ellipse">
@@ -3041,7 +3020,7 @@
         </p:nvSpPr>
         <p:spPr>
           <a:xfrm>
-            <a:off x="23761008" y="37227026"/>
+            <a:off x="23761008" y="37042368"/>
             <a:ext cx="7918992" cy="566928"/>
           </a:xfrm>
           <a:prstGeom prst="rect">
@@ -3080,8 +3059,8 @@
         </p:nvSpPr>
         <p:spPr>
           <a:xfrm>
-            <a:off x="23303808" y="37940258"/>
-            <a:ext cx="8339616" cy="3351022"/>
+            <a:off x="23303808" y="37755600"/>
+            <a:ext cx="8339616" cy="3535680"/>
           </a:xfrm>
           <a:prstGeom prst="rect">
             <a:avLst/>
@@ -3100,7 +3079,7 @@
               <a:buNone/>
             </a:pPr>
             <a:r>
-              <a:rPr lang="en-US" sz="1700" dirty="0">
+              <a:rPr lang="en-US" sz="1600" dirty="0">
                 <a:solidFill>
                   <a:srgbClr val="555555"/>
                 </a:solidFill>
@@ -3110,7 +3089,7 @@
               </a:rPr>
               <a:t>1.  McLemore EC, et al. Breast cancer: presentation and intervention in women with gastrointestinal metastasis and carcinomatosis. Ann Surg Oncol. 2005;12(11):886–894.</a:t>
             </a:r>
-            <a:endParaRPr lang="en-US" sz="1700" dirty="0"/>
+            <a:endParaRPr lang="en-US" sz="1600" dirty="0"/>
           </a:p>
           <a:p>
             <a:pPr algn="l" indent="0" marL="0">
@@ -3120,7 +3099,7 @@
               <a:buNone/>
             </a:pPr>
             <a:r>
-              <a:rPr lang="en-US" sz="1700" dirty="0">
+              <a:rPr lang="en-US" sz="1600" dirty="0">
                 <a:solidFill>
                   <a:srgbClr val="555555"/>
                 </a:solidFill>
@@ -3130,7 +3109,7 @@
               </a:rPr>
               <a:t>2.  Ambroggi M, et al. Metastatic breast cancer to the gastrointestinal tract: report of five cases and review of the literature. Int J Breast Cancer. 2012;2012:439023.</a:t>
             </a:r>
-            <a:endParaRPr lang="en-US" sz="1700" dirty="0"/>
+            <a:endParaRPr lang="en-US" sz="1600" dirty="0"/>
           </a:p>
           <a:p>
             <a:pPr algn="l" indent="0" marL="0">
@@ -3140,7 +3119,7 @@
               <a:buNone/>
             </a:pPr>
             <a:r>
-              <a:rPr lang="en-US" sz="1700" dirty="0">
+              <a:rPr lang="en-US" sz="1600" dirty="0">
                 <a:solidFill>
                   <a:srgbClr val="555555"/>
                 </a:solidFill>
@@ -3150,7 +3129,7 @@
               </a:rPr>
               <a:t>3.  Li Y, et al. Small intestinal metastatic breast cancer: a case report and literature review. Front Oncol. 2022;12:900832.</a:t>
             </a:r>
-            <a:endParaRPr lang="en-US" sz="1700" dirty="0"/>
+            <a:endParaRPr lang="en-US" sz="1600" dirty="0"/>
           </a:p>
           <a:p>
             <a:pPr algn="l" indent="0" marL="0">
@@ -3160,7 +3139,7 @@
               <a:buNone/>
             </a:pPr>
             <a:r>
-              <a:rPr lang="en-US" sz="1700" dirty="0">
+              <a:rPr lang="en-US" sz="1600" dirty="0">
                 <a:solidFill>
                   <a:srgbClr val="555555"/>
                 </a:solidFill>
@@ -3170,7 +3149,27 @@
               </a:rPr>
               <a:t>4.  Shen F, et al. Small intestinal metastasis from primary breast cancer: a case report and review of the literature. Front Immunol. 2024;15:1475018.</a:t>
             </a:r>
-            <a:endParaRPr lang="en-US" sz="1700" dirty="0"/>
+            <a:endParaRPr lang="en-US" sz="1600" dirty="0"/>
+          </a:p>
+          <a:p>
+            <a:pPr algn="l" indent="0" marL="0">
+              <a:spcAft>
+                <a:spcPts val="700"/>
+              </a:spcAft>
+              <a:buNone/>
+            </a:pPr>
+            <a:r>
+              <a:rPr lang="en-US" sz="1600" dirty="0">
+                <a:solidFill>
+                  <a:srgbClr val="555555"/>
+                </a:solidFill>
+                <a:latin typeface="Calibri" pitchFamily="34" charset="0"/>
+                <a:ea typeface="Calibri" pitchFamily="34" charset="-122"/>
+                <a:cs typeface="Calibri" pitchFamily="34" charset="-120"/>
+              </a:rPr>
+              <a:t>5.  Gown AM. Markers of metastatic carcinoma of breast origin. Histopathology. 2016;68(1):86–95.</a:t>
+            </a:r>
+            <a:endParaRPr lang="en-US" sz="1600" dirty="0"/>
           </a:p>
         </p:txBody>
       </p:sp>

</xml_diff>

<commit_message>
Poster: rebalance columns and fill page top-to-bottom
Move Histopathology into column 1 so the two text columns carry comparable
content, and justify every column to fill from the stat band down to the footer
instead of centring a shorter column and leaving voids.

Co-Authored-By: Claude Opus 4.8 <noreply@anthropic.com>
Claude-Session: https://claude.ai/code/session_01Hys1rt1JVnsf8msS2XZJ53
</commit_message>
<xml_diff>
--- a/TNASICON2026-Poster-Metastatic-Ileal-Perforation.pptx
+++ b/TNASICON2026-Poster-Metastatic-Ileal-Perforation.pptx
@@ -1641,7 +1641,7 @@
         </p:nvSpPr>
         <p:spPr>
           <a:xfrm>
-            <a:off x="720000" y="9487248"/>
+            <a:off x="720000" y="7568856"/>
             <a:ext cx="310896" cy="310896"/>
           </a:xfrm>
           <a:prstGeom prst="ellipse">
@@ -1661,7 +1661,7 @@
         </p:nvSpPr>
         <p:spPr>
           <a:xfrm>
-            <a:off x="1213776" y="9377520"/>
+            <a:off x="1213776" y="7459128"/>
             <a:ext cx="7918992" cy="603504"/>
           </a:xfrm>
           <a:prstGeom prst="rect">
@@ -1700,8 +1700,8 @@
         </p:nvSpPr>
         <p:spPr>
           <a:xfrm>
-            <a:off x="756576" y="10127328"/>
-            <a:ext cx="8339616" cy="5279136"/>
+            <a:off x="756576" y="8208936"/>
+            <a:ext cx="8339616" cy="5126736"/>
           </a:xfrm>
           <a:prstGeom prst="rect">
             <a:avLst/>
@@ -1721,7 +1721,7 @@
               <a:buChar char="•"/>
             </a:pPr>
             <a:r>
-              <a:rPr lang="en-US" sz="3200" dirty="0">
+              <a:rPr lang="en-US" sz="3100" dirty="0">
                 <a:solidFill>
                   <a:srgbClr val="333333"/>
                 </a:solidFill>
@@ -1731,7 +1731,7 @@
               </a:rPr>
               <a:t>Breast carcinoma most often metastasises to bone, liver and lung; gastrointestinal spread is rare and arises far more often from lobular than from ductal carcinoma. [1, 2]</a:t>
             </a:r>
-            <a:endParaRPr lang="en-US" sz="3200" dirty="0"/>
+            <a:endParaRPr lang="en-US" sz="3100" dirty="0"/>
           </a:p>
           <a:p>
             <a:pPr algn="l" marL="228600" indent="-228600">
@@ -1742,7 +1742,7 @@
               <a:buChar char="•"/>
             </a:pPr>
             <a:r>
-              <a:rPr lang="en-US" sz="3200" dirty="0">
+              <a:rPr lang="en-US" sz="3100" dirty="0">
                 <a:solidFill>
                   <a:srgbClr val="333333"/>
                 </a:solidFill>
@@ -1752,7 +1752,7 @@
               </a:rPr>
               <a:t>Intestinal metastasis from breast carcinoma is uncommon, and perforation as the initial manifestation is exceedingly rare — only a limited number of cases have been reported. [3, 4]</a:t>
             </a:r>
-            <a:endParaRPr lang="en-US" sz="3200" dirty="0"/>
+            <a:endParaRPr lang="en-US" sz="3100" dirty="0"/>
           </a:p>
         </p:txBody>
       </p:sp>
@@ -1764,7 +1764,7 @@
         </p:nvSpPr>
         <p:spPr>
           <a:xfrm>
-            <a:off x="720000" y="16960944"/>
+            <a:off x="720000" y="14285909"/>
             <a:ext cx="310896" cy="310896"/>
           </a:xfrm>
           <a:prstGeom prst="ellipse">
@@ -1784,7 +1784,7 @@
         </p:nvSpPr>
         <p:spPr>
           <a:xfrm>
-            <a:off x="1213776" y="16851216"/>
+            <a:off x="1213776" y="14176181"/>
             <a:ext cx="7918992" cy="603504"/>
           </a:xfrm>
           <a:prstGeom prst="rect">
@@ -1823,8 +1823,8 @@
         </p:nvSpPr>
         <p:spPr>
           <a:xfrm>
-            <a:off x="756576" y="17601024"/>
-            <a:ext cx="8339616" cy="4404360"/>
+            <a:off x="756576" y="14925989"/>
+            <a:ext cx="8339616" cy="4282440"/>
           </a:xfrm>
           <a:prstGeom prst="rect">
             <a:avLst/>
@@ -1844,7 +1844,7 @@
               <a:buChar char="•"/>
             </a:pPr>
             <a:r>
-              <a:rPr lang="en-US" sz="3200" b="1" dirty="0">
+              <a:rPr lang="en-US" sz="3100" b="1" dirty="0">
                 <a:solidFill>
                   <a:srgbClr val="12355B"/>
                 </a:solidFill>
@@ -1854,7 +1854,7 @@
               </a:rPr>
               <a:t>38-year-old woman with abdominal pain for two days.</a:t>
             </a:r>
-            <a:endParaRPr lang="en-US" sz="3200" dirty="0"/>
+            <a:endParaRPr lang="en-US" sz="3100" dirty="0"/>
           </a:p>
           <a:p>
             <a:pPr algn="l" marL="228600" indent="-228600">
@@ -1865,7 +1865,7 @@
               <a:buChar char="•"/>
             </a:pPr>
             <a:r>
-              <a:rPr lang="en-US" sz="3200" dirty="0">
+              <a:rPr lang="en-US" sz="3100" dirty="0">
                 <a:solidFill>
                   <a:srgbClr val="333333"/>
                 </a:solidFill>
@@ -1875,7 +1875,7 @@
               </a:rPr>
               <a:t>History of chronic NSAID abuse for pain related to a right breast lump, which had been misdiagnosed as a breast abscess.</a:t>
             </a:r>
-            <a:endParaRPr lang="en-US" sz="3200" dirty="0"/>
+            <a:endParaRPr lang="en-US" sz="3100" dirty="0"/>
           </a:p>
           <a:p>
             <a:pPr algn="l" marL="228600" indent="-228600">
@@ -1886,7 +1886,7 @@
               <a:buChar char="•"/>
             </a:pPr>
             <a:r>
-              <a:rPr lang="en-US" sz="3200" dirty="0">
+              <a:rPr lang="en-US" sz="3100" dirty="0">
                 <a:solidFill>
                   <a:srgbClr val="333333"/>
                 </a:solidFill>
@@ -1896,7 +1896,7 @@
               </a:rPr>
               <a:t>On examination: tachycardic, with generalized abdominal rigidity.</a:t>
             </a:r>
-            <a:endParaRPr lang="en-US" sz="3200" dirty="0"/>
+            <a:endParaRPr lang="en-US" sz="3100" dirty="0"/>
           </a:p>
         </p:txBody>
       </p:sp>
@@ -1908,7 +1908,7 @@
         </p:nvSpPr>
         <p:spPr>
           <a:xfrm>
-            <a:off x="720000" y="23559864"/>
+            <a:off x="720000" y="20158666"/>
             <a:ext cx="310896" cy="310896"/>
           </a:xfrm>
           <a:prstGeom prst="ellipse">
@@ -1928,7 +1928,7 @@
         </p:nvSpPr>
         <p:spPr>
           <a:xfrm>
-            <a:off x="1213776" y="23450136"/>
+            <a:off x="1213776" y="20048938"/>
             <a:ext cx="7918992" cy="603504"/>
           </a:xfrm>
           <a:prstGeom prst="rect">
@@ -1967,8 +1967,8 @@
         </p:nvSpPr>
         <p:spPr>
           <a:xfrm>
-            <a:off x="756576" y="24199944"/>
-            <a:ext cx="8339616" cy="2353056"/>
+            <a:off x="756576" y="20798746"/>
+            <a:ext cx="8339616" cy="2292096"/>
           </a:xfrm>
           <a:prstGeom prst="rect">
             <a:avLst/>
@@ -1988,7 +1988,7 @@
               <a:buChar char="•"/>
             </a:pPr>
             <a:r>
-              <a:rPr lang="en-US" sz="3200" b="1" dirty="0">
+              <a:rPr lang="en-US" sz="3100" b="1" dirty="0">
                 <a:solidFill>
                   <a:srgbClr val="12355B"/>
                 </a:solidFill>
@@ -1998,7 +1998,7 @@
               </a:rPr>
               <a:t>Erect abdominal radiograph demonstrated pneumoperitoneum.</a:t>
             </a:r>
-            <a:endParaRPr lang="en-US" sz="3200" dirty="0"/>
+            <a:endParaRPr lang="en-US" sz="3100" dirty="0"/>
           </a:p>
           <a:p>
             <a:pPr algn="l" marL="228600" indent="-228600">
@@ -2009,7 +2009,7 @@
               <a:buChar char="•"/>
             </a:pPr>
             <a:r>
-              <a:rPr lang="en-US" sz="3200" dirty="0">
+              <a:rPr lang="en-US" sz="3100" dirty="0">
                 <a:solidFill>
                   <a:srgbClr val="333333"/>
                 </a:solidFill>
@@ -2019,7 +2019,7 @@
               </a:rPr>
               <a:t>Findings prompted emergency exploratory laparotomy (see Figs 2–3).</a:t>
             </a:r>
-            <a:endParaRPr lang="en-US" sz="3200" dirty="0"/>
+            <a:endParaRPr lang="en-US" sz="3100" dirty="0"/>
           </a:p>
         </p:txBody>
       </p:sp>
@@ -2031,7 +2031,7 @@
         </p:nvSpPr>
         <p:spPr>
           <a:xfrm>
-            <a:off x="720000" y="28107480"/>
+            <a:off x="720000" y="24041078"/>
             <a:ext cx="310896" cy="310896"/>
           </a:xfrm>
           <a:prstGeom prst="ellipse">
@@ -2051,7 +2051,7 @@
         </p:nvSpPr>
         <p:spPr>
           <a:xfrm>
-            <a:off x="1213776" y="27997752"/>
+            <a:off x="1213776" y="23931350"/>
             <a:ext cx="7918992" cy="603504"/>
           </a:xfrm>
           <a:prstGeom prst="rect">
@@ -2090,8 +2090,8 @@
         </p:nvSpPr>
         <p:spPr>
           <a:xfrm>
-            <a:off x="756576" y="28747560"/>
-            <a:ext cx="8339616" cy="4117848"/>
+            <a:off x="756576" y="24681158"/>
+            <a:ext cx="8339616" cy="4011168"/>
           </a:xfrm>
           <a:prstGeom prst="rect">
             <a:avLst/>
@@ -2111,7 +2111,7 @@
               <a:buChar char="•"/>
             </a:pPr>
             <a:r>
-              <a:rPr lang="en-US" sz="3200" dirty="0">
+              <a:rPr lang="en-US" sz="3100" dirty="0">
                 <a:solidFill>
                   <a:srgbClr val="333333"/>
                 </a:solidFill>
@@ -2121,7 +2121,7 @@
               </a:rPr>
               <a:t>NSAID-induced ulcer perforation</a:t>
             </a:r>
-            <a:endParaRPr lang="en-US" sz="3200" dirty="0"/>
+            <a:endParaRPr lang="en-US" sz="3100" dirty="0"/>
           </a:p>
           <a:p>
             <a:pPr algn="l" marL="228600" indent="-228600">
@@ -2132,7 +2132,7 @@
               <a:buChar char="•"/>
             </a:pPr>
             <a:r>
-              <a:rPr lang="en-US" sz="3200" dirty="0">
+              <a:rPr lang="en-US" sz="3100" dirty="0">
                 <a:solidFill>
                   <a:srgbClr val="333333"/>
                 </a:solidFill>
@@ -2142,7 +2142,7 @@
               </a:rPr>
               <a:t>Infective enteritis (e.g., enteric fever)</a:t>
             </a:r>
-            <a:endParaRPr lang="en-US" sz="3200" dirty="0"/>
+            <a:endParaRPr lang="en-US" sz="3100" dirty="0"/>
           </a:p>
           <a:p>
             <a:pPr algn="l" marL="228600" indent="-228600">
@@ -2153,7 +2153,7 @@
               <a:buChar char="•"/>
             </a:pPr>
             <a:r>
-              <a:rPr lang="en-US" sz="3200" dirty="0">
+              <a:rPr lang="en-US" sz="3100" dirty="0">
                 <a:solidFill>
                   <a:srgbClr val="333333"/>
                 </a:solidFill>
@@ -2163,7 +2163,7 @@
               </a:rPr>
               <a:t>Intestinal tuberculosis</a:t>
             </a:r>
-            <a:endParaRPr lang="en-US" sz="3200" dirty="0"/>
+            <a:endParaRPr lang="en-US" sz="3100" dirty="0"/>
           </a:p>
           <a:p>
             <a:pPr algn="l" marL="228600" indent="-228600">
@@ -2174,7 +2174,7 @@
               <a:buChar char="•"/>
             </a:pPr>
             <a:r>
-              <a:rPr lang="en-US" sz="3200" dirty="0">
+              <a:rPr lang="en-US" sz="3100" dirty="0">
                 <a:solidFill>
                   <a:srgbClr val="333333"/>
                 </a:solidFill>
@@ -2184,7 +2184,7 @@
               </a:rPr>
               <a:t>Primary small-bowel malignancy</a:t>
             </a:r>
-            <a:endParaRPr lang="en-US" sz="3200" dirty="0"/>
+            <a:endParaRPr lang="en-US" sz="3100" dirty="0"/>
           </a:p>
           <a:p>
             <a:pPr algn="l" marL="228600" indent="-228600">
@@ -2195,7 +2195,7 @@
               <a:buChar char="•"/>
             </a:pPr>
             <a:r>
-              <a:rPr lang="en-US" sz="3200" b="1" dirty="0">
+              <a:rPr lang="en-US" sz="3100" b="1" dirty="0">
                 <a:solidFill>
                   <a:srgbClr val="12355B"/>
                 </a:solidFill>
@@ -2205,7 +2205,7 @@
               </a:rPr>
               <a:t>Metastatic malignancy — confirmed in this case</a:t>
             </a:r>
-            <a:endParaRPr lang="en-US" sz="3200" dirty="0"/>
+            <a:endParaRPr lang="en-US" sz="3100" dirty="0"/>
           </a:p>
         </p:txBody>
       </p:sp>
@@ -2217,7 +2217,7 @@
         </p:nvSpPr>
         <p:spPr>
           <a:xfrm>
-            <a:off x="720000" y="34419888"/>
+            <a:off x="720000" y="29642563"/>
             <a:ext cx="310896" cy="310896"/>
           </a:xfrm>
           <a:prstGeom prst="ellipse">
@@ -2237,7 +2237,7 @@
         </p:nvSpPr>
         <p:spPr>
           <a:xfrm>
-            <a:off x="1213776" y="34310160"/>
+            <a:off x="1213776" y="29532835"/>
             <a:ext cx="7918992" cy="603504"/>
           </a:xfrm>
           <a:prstGeom prst="rect">
@@ -2276,8 +2276,8 @@
         </p:nvSpPr>
         <p:spPr>
           <a:xfrm>
-            <a:off x="756576" y="35059968"/>
-            <a:ext cx="8339616" cy="4404360"/>
+            <a:off x="756576" y="30282643"/>
+            <a:ext cx="8339616" cy="4282440"/>
           </a:xfrm>
           <a:prstGeom prst="rect">
             <a:avLst/>
@@ -2297,7 +2297,7 @@
               <a:buChar char="•"/>
             </a:pPr>
             <a:r>
-              <a:rPr lang="en-US" sz="3200" dirty="0">
+              <a:rPr lang="en-US" sz="3100" dirty="0">
                 <a:solidFill>
                   <a:srgbClr val="333333"/>
                 </a:solidFill>
@@ -2307,7 +2307,7 @@
               </a:rPr>
               <a:t>Emergency exploratory laparotomy performed.</a:t>
             </a:r>
-            <a:endParaRPr lang="en-US" sz="3200" dirty="0"/>
+            <a:endParaRPr lang="en-US" sz="3100" dirty="0"/>
           </a:p>
           <a:p>
             <a:pPr algn="l" marL="228600" indent="-228600">
@@ -2318,7 +2318,7 @@
               <a:buChar char="•"/>
             </a:pPr>
             <a:r>
-              <a:rPr lang="en-US" sz="3200" b="1" dirty="0">
+              <a:rPr lang="en-US" sz="3100" b="1" dirty="0">
                 <a:solidFill>
                   <a:srgbClr val="12355B"/>
                 </a:solidFill>
@@ -2328,7 +2328,7 @@
               </a:rPr>
               <a:t>Solitary ileal perforation ≈ 0.5 × 0.5 cm, located 40 cm proximal to the ileocaecal junction.</a:t>
             </a:r>
-            <a:endParaRPr lang="en-US" sz="3200" dirty="0"/>
+            <a:endParaRPr lang="en-US" sz="3100" dirty="0"/>
           </a:p>
           <a:p>
             <a:pPr algn="l" marL="228600" indent="-228600">
@@ -2339,7 +2339,7 @@
               <a:buChar char="•"/>
             </a:pPr>
             <a:r>
-              <a:rPr lang="en-US" sz="3200" dirty="0">
+              <a:rPr lang="en-US" sz="3100" dirty="0">
                 <a:solidFill>
                   <a:srgbClr val="333333"/>
                 </a:solidFill>
@@ -2349,7 +2349,7 @@
               </a:rPr>
               <a:t>Primary closure of the perforation performed after obtaining a biopsy from the perforation margin.</a:t>
             </a:r>
-            <a:endParaRPr lang="en-US" sz="3200" dirty="0"/>
+            <a:endParaRPr lang="en-US" sz="3100" dirty="0"/>
           </a:p>
         </p:txBody>
       </p:sp>
@@ -2361,7 +2361,7 @@
         </p:nvSpPr>
         <p:spPr>
           <a:xfrm>
-            <a:off x="23267232" y="7568856"/>
+            <a:off x="720000" y="35515320"/>
             <a:ext cx="310896" cy="310896"/>
           </a:xfrm>
           <a:prstGeom prst="ellipse">
@@ -2381,7 +2381,7 @@
         </p:nvSpPr>
         <p:spPr>
           <a:xfrm>
-            <a:off x="23761008" y="7459128"/>
+            <a:off x="1213776" y="35405592"/>
             <a:ext cx="7918992" cy="603504"/>
           </a:xfrm>
           <a:prstGeom prst="rect">
@@ -2420,8 +2420,8 @@
         </p:nvSpPr>
         <p:spPr>
           <a:xfrm>
-            <a:off x="23303808" y="8208936"/>
-            <a:ext cx="8339616" cy="5379720"/>
+            <a:off x="756576" y="36155400"/>
+            <a:ext cx="8339616" cy="5227320"/>
           </a:xfrm>
           <a:prstGeom prst="rect">
             <a:avLst/>
@@ -2441,7 +2441,7 @@
               <a:buChar char="•"/>
             </a:pPr>
             <a:r>
-              <a:rPr lang="en-US" sz="3200" b="1" dirty="0">
+              <a:rPr lang="en-US" sz="3100" b="1" dirty="0">
                 <a:solidFill>
                   <a:srgbClr val="12355B"/>
                 </a:solidFill>
@@ -2451,7 +2451,7 @@
               </a:rPr>
               <a:t>Trucut biopsy of the breast lump confirmed invasive ductal carcinoma.</a:t>
             </a:r>
-            <a:endParaRPr lang="en-US" sz="3200" dirty="0"/>
+            <a:endParaRPr lang="en-US" sz="3100" dirty="0"/>
           </a:p>
           <a:p>
             <a:pPr algn="l" marL="228600" indent="-228600">
@@ -2462,7 +2462,7 @@
               <a:buChar char="•"/>
             </a:pPr>
             <a:r>
-              <a:rPr lang="en-US" sz="3200" b="1" dirty="0">
+              <a:rPr lang="en-US" sz="3100" b="1" dirty="0">
                 <a:solidFill>
                   <a:srgbClr val="12355B"/>
                 </a:solidFill>
@@ -2472,7 +2472,7 @@
               </a:rPr>
               <a:t>Ileal perforation-margin biopsy demonstrated metastatic deposits at the perforation site.</a:t>
             </a:r>
-            <a:endParaRPr lang="en-US" sz="3200" dirty="0"/>
+            <a:endParaRPr lang="en-US" sz="3100" dirty="0"/>
           </a:p>
           <a:p>
             <a:pPr algn="l" marL="228600" indent="-228600">
@@ -2483,7 +2483,7 @@
               <a:buChar char="•"/>
             </a:pPr>
             <a:r>
-              <a:rPr lang="en-US" sz="3200" dirty="0">
+              <a:rPr lang="en-US" sz="3100" dirty="0">
                 <a:solidFill>
                   <a:srgbClr val="333333"/>
                 </a:solidFill>
@@ -2493,7 +2493,7 @@
               </a:rPr>
               <a:t>Breast origin of intestinal metastases is confirmed on immunohistochemistry — GATA3 (most sensitive), GCDFP-15, mammaglobin and ER; E-cadherin positivity supports ductal type. [5]</a:t>
             </a:r>
-            <a:endParaRPr lang="en-US" sz="3200" dirty="0"/>
+            <a:endParaRPr lang="en-US" sz="3100" dirty="0"/>
           </a:p>
         </p:txBody>
       </p:sp>
@@ -2505,7 +2505,7 @@
         </p:nvSpPr>
         <p:spPr>
           <a:xfrm>
-            <a:off x="23267232" y="14254711"/>
+            <a:off x="23267232" y="7568856"/>
             <a:ext cx="310896" cy="310896"/>
           </a:xfrm>
           <a:prstGeom prst="ellipse">
@@ -2525,7 +2525,7 @@
         </p:nvSpPr>
         <p:spPr>
           <a:xfrm>
-            <a:off x="23761008" y="14144983"/>
+            <a:off x="23761008" y="7459128"/>
             <a:ext cx="7918992" cy="603504"/>
           </a:xfrm>
           <a:prstGeom prst="rect">
@@ -2564,8 +2564,8 @@
         </p:nvSpPr>
         <p:spPr>
           <a:xfrm>
-            <a:off x="23303808" y="14894791"/>
-            <a:ext cx="8339616" cy="7918704"/>
+            <a:off x="23303808" y="8208936"/>
+            <a:ext cx="8339616" cy="7690104"/>
           </a:xfrm>
           <a:prstGeom prst="rect">
             <a:avLst/>
@@ -2585,7 +2585,7 @@
               <a:buChar char="•"/>
             </a:pPr>
             <a:r>
-              <a:rPr lang="en-US" sz="3200" dirty="0">
+              <a:rPr lang="en-US" sz="3100" dirty="0">
                 <a:solidFill>
                   <a:srgbClr val="333333"/>
                 </a:solidFill>
@@ -2595,7 +2595,7 @@
               </a:rPr>
               <a:t>The gastrointestinal tract is an unusual site for breast metastasis; the small bowel is rarer still, and perforation as the initial manifestation is exceptional.</a:t>
             </a:r>
-            <a:endParaRPr lang="en-US" sz="3200" dirty="0"/>
+            <a:endParaRPr lang="en-US" sz="3100" dirty="0"/>
           </a:p>
           <a:p>
             <a:pPr algn="l" marL="228600" indent="-228600">
@@ -2606,7 +2606,7 @@
               <a:buChar char="•"/>
             </a:pPr>
             <a:r>
-              <a:rPr lang="en-US" sz="3200" dirty="0">
+              <a:rPr lang="en-US" sz="3100" dirty="0">
                 <a:solidFill>
                   <a:srgbClr val="333333"/>
                 </a:solidFill>
@@ -2616,7 +2616,7 @@
               </a:rPr>
               <a:t>Diagnostic trap: acute peritonitis overshadows the primary, and the breast lump had been dismissed as an abscess — delaying the true diagnosis.</a:t>
             </a:r>
-            <a:endParaRPr lang="en-US" sz="3200" dirty="0"/>
+            <a:endParaRPr lang="en-US" sz="3100" dirty="0"/>
           </a:p>
           <a:p>
             <a:pPr algn="l" marL="228600" indent="-228600">
@@ -2627,7 +2627,7 @@
               <a:buChar char="•"/>
             </a:pPr>
             <a:r>
-              <a:rPr lang="en-US" sz="3200" dirty="0">
+              <a:rPr lang="en-US" sz="3100" dirty="0">
                 <a:solidFill>
                   <a:srgbClr val="333333"/>
                 </a:solidFill>
@@ -2637,7 +2637,7 @@
               </a:rPr>
               <a:t>An acute surgical abdomen may be the first presentation of metastatic malignancy.</a:t>
             </a:r>
-            <a:endParaRPr lang="en-US" sz="3200" dirty="0"/>
+            <a:endParaRPr lang="en-US" sz="3100" dirty="0"/>
           </a:p>
           <a:p>
             <a:pPr algn="l" marL="228600" indent="-228600">
@@ -2648,7 +2648,7 @@
               <a:buChar char="•"/>
             </a:pPr>
             <a:r>
-              <a:rPr lang="en-US" sz="3200" dirty="0">
+              <a:rPr lang="en-US" sz="3100" dirty="0">
                 <a:solidFill>
                   <a:srgbClr val="333333"/>
                 </a:solidFill>
@@ -2658,7 +2658,7 @@
               </a:rPr>
               <a:t>Management requires emergency surgery followed by evaluation and treatment of the primary breast malignancy.</a:t>
             </a:r>
-            <a:endParaRPr lang="en-US" sz="3200" dirty="0"/>
+            <a:endParaRPr lang="en-US" sz="3100" dirty="0"/>
           </a:p>
         </p:txBody>
       </p:sp>
@@ -2670,12 +2670,12 @@
         </p:nvSpPr>
         <p:spPr>
           <a:xfrm>
-            <a:off x="23267232" y="23388109"/>
-            <a:ext cx="8412768" cy="6761988"/>
+            <a:off x="23267232" y="18867881"/>
+            <a:ext cx="8412768" cy="6611112"/>
           </a:xfrm>
           <a:prstGeom prst="roundRect">
             <a:avLst>
-              <a:gd name="adj" fmla="val 1352"/>
+              <a:gd name="adj" fmla="val 1383"/>
             </a:avLst>
           </a:prstGeom>
           <a:solidFill>
@@ -2704,7 +2704,7 @@
         </p:nvSpPr>
         <p:spPr>
           <a:xfrm>
-            <a:off x="23559840" y="23845309"/>
+            <a:off x="23559840" y="19325081"/>
             <a:ext cx="310896" cy="310896"/>
           </a:xfrm>
           <a:prstGeom prst="ellipse">
@@ -2724,7 +2724,7 @@
         </p:nvSpPr>
         <p:spPr>
           <a:xfrm>
-            <a:off x="24035328" y="23772157"/>
+            <a:off x="24035328" y="19251929"/>
             <a:ext cx="7352064" cy="603504"/>
           </a:xfrm>
           <a:prstGeom prst="rect">
@@ -2763,8 +2763,8 @@
         </p:nvSpPr>
         <p:spPr>
           <a:xfrm>
-            <a:off x="23559840" y="24503677"/>
-            <a:ext cx="7827552" cy="5372100"/>
+            <a:off x="23559840" y="19983449"/>
+            <a:ext cx="7827552" cy="5221224"/>
           </a:xfrm>
           <a:prstGeom prst="rect">
             <a:avLst/>
@@ -2784,7 +2784,7 @@
               <a:buChar char="•"/>
             </a:pPr>
             <a:r>
-              <a:rPr lang="en-US" sz="3200" dirty="0">
+              <a:rPr lang="en-US" sz="3100" dirty="0">
                 <a:solidFill>
                   <a:srgbClr val="5A4A12"/>
                 </a:solidFill>
@@ -2794,7 +2794,7 @@
               </a:rPr>
               <a:t>Ileal perforation was the initial manifestation of previously unrecognised metastatic breast carcinoma.</a:t>
             </a:r>
-            <a:endParaRPr lang="en-US" sz="3200" dirty="0"/>
+            <a:endParaRPr lang="en-US" sz="3100" dirty="0"/>
           </a:p>
           <a:p>
             <a:pPr algn="l" marL="228600" indent="-228600">
@@ -2805,7 +2805,7 @@
               <a:buChar char="•"/>
             </a:pPr>
             <a:r>
-              <a:rPr lang="en-US" sz="3200" dirty="0">
+              <a:rPr lang="en-US" sz="3100" dirty="0">
                 <a:solidFill>
                   <a:srgbClr val="5A4A12"/>
                 </a:solidFill>
@@ -2815,7 +2815,7 @@
               </a:rPr>
               <a:t>Perforation as the first presentation is exceedingly rare, with only a limited number of reported cases.</a:t>
             </a:r>
-            <a:endParaRPr lang="en-US" sz="3200" dirty="0"/>
+            <a:endParaRPr lang="en-US" sz="3100" dirty="0"/>
           </a:p>
           <a:p>
             <a:pPr algn="l" marL="228600" indent="-228600">
@@ -2826,7 +2826,7 @@
               <a:buChar char="•"/>
             </a:pPr>
             <a:r>
-              <a:rPr lang="en-US" sz="3200" dirty="0">
+              <a:rPr lang="en-US" sz="3100" dirty="0">
                 <a:solidFill>
                   <a:srgbClr val="5A4A12"/>
                 </a:solidFill>
@@ -2836,7 +2836,7 @@
               </a:rPr>
               <a:t>Demonstrates that an acute surgical abdomen may be the first presentation of metastatic malignancy.</a:t>
             </a:r>
-            <a:endParaRPr lang="en-US" sz="3200" dirty="0"/>
+            <a:endParaRPr lang="en-US" sz="3100" dirty="0"/>
           </a:p>
         </p:txBody>
       </p:sp>
@@ -2848,12 +2848,12 @@
         </p:nvSpPr>
         <p:spPr>
           <a:xfrm>
-            <a:off x="23267232" y="30816152"/>
-            <a:ext cx="8412768" cy="5578450"/>
+            <a:off x="23267232" y="28539274"/>
+            <a:ext cx="8412768" cy="5461102"/>
           </a:xfrm>
           <a:prstGeom prst="roundRect">
             <a:avLst>
-              <a:gd name="adj" fmla="val 1639"/>
+              <a:gd name="adj" fmla="val 1674"/>
             </a:avLst>
           </a:prstGeom>
           <a:solidFill>
@@ -2877,7 +2877,7 @@
         </p:nvSpPr>
         <p:spPr>
           <a:xfrm>
-            <a:off x="23559840" y="31273352"/>
+            <a:off x="23559840" y="28996474"/>
             <a:ext cx="310896" cy="310896"/>
           </a:xfrm>
           <a:prstGeom prst="ellipse">
@@ -2897,7 +2897,7 @@
         </p:nvSpPr>
         <p:spPr>
           <a:xfrm>
-            <a:off x="24035328" y="31200200"/>
+            <a:off x="24035328" y="28923322"/>
             <a:ext cx="7352064" cy="603504"/>
           </a:xfrm>
           <a:prstGeom prst="rect">
@@ -2936,8 +2936,8 @@
         </p:nvSpPr>
         <p:spPr>
           <a:xfrm>
-            <a:off x="23559840" y="31931720"/>
-            <a:ext cx="7827552" cy="4188562"/>
+            <a:off x="23559840" y="29654842"/>
+            <a:ext cx="7827552" cy="4071214"/>
           </a:xfrm>
           <a:prstGeom prst="rect">
             <a:avLst/>
@@ -2957,7 +2957,7 @@
               <a:buChar char="•"/>
             </a:pPr>
             <a:r>
-              <a:rPr lang="en-US" sz="3200" dirty="0">
+              <a:rPr lang="en-US" sz="3100" dirty="0">
                 <a:solidFill>
                   <a:srgbClr val="EAF1F8"/>
                 </a:solidFill>
@@ -2967,7 +2967,7 @@
               </a:rPr>
               <a:t>Ileal perforation can rarely be the presenting manifestation of metastatic breast carcinoma.</a:t>
             </a:r>
-            <a:endParaRPr lang="en-US" sz="3200" dirty="0"/>
+            <a:endParaRPr lang="en-US" sz="3100" dirty="0"/>
           </a:p>
           <a:p>
             <a:pPr algn="l" marL="228600" indent="-228600">
@@ -2978,7 +2978,7 @@
               <a:buChar char="•"/>
             </a:pPr>
             <a:r>
-              <a:rPr lang="en-US" sz="3200" dirty="0">
+              <a:rPr lang="en-US" sz="3100" dirty="0">
                 <a:solidFill>
                   <a:srgbClr val="EAF1F8"/>
                 </a:solidFill>
@@ -2988,7 +2988,7 @@
               </a:rPr>
               <a:t>A high index of suspicion together with early histopathological confirmation is essential for accurate diagnosis and appropriate management.</a:t>
             </a:r>
-            <a:endParaRPr lang="en-US" sz="3200" dirty="0"/>
+            <a:endParaRPr lang="en-US" sz="3100" dirty="0"/>
           </a:p>
         </p:txBody>
       </p:sp>

</xml_diff>